<commit_message>
fix(course): PPTX roleplay title, speaker labels, text overflow, dual-purpose note
- Roleplay slide title shortened to "Roleplay" (full scenario in speaker notes)
- Speaker labels changed from "Learner" to "You" for 1:1 feel
- Parenthetical cues stripped from speaker pills (e.g. "(your turn...)")
- Practice drill block widened to full teaching width to prevent text overflow
- Added dual-purpose lesson note: lessons work for self-paced course AND live 1:1 with Nine
- Updated script generation prompt to use "You" in roleplay labels
- Regenerated L001 and L002 decks with all fixes

Co-Authored-By: Claude Opus 4.6 (1M context) <noreply@anthropic.com>

Former-commit-id: 51617ed1a40ca470d79350302d6b26afb9dad5bf
Former-commit-id: ae3ea9e62ec520f284a3f942494a25da5c09bf40
Former-commit-id: f936d875177953fd3e21075a754c7ce9b5dbd0c6
</commit_message>
<xml_diff>
--- a/course/modules/M01/L001/M01-L001-canva-deck.pptx
+++ b/course/modules/M01/L001/M01-L001-canva-deck.pptx
@@ -3419,7 +3419,7 @@
                 <a:ea typeface="Sarabun"/>
                 <a:cs typeface="Sarabun"/>
               </a:rPr>
-              <a:t>Learner</a:t>
+              <a:t>You</a:t>
             </a:r>
           </a:p>
         </p:txBody>
@@ -3663,7 +3663,7 @@
                 <a:ea typeface="Sarabun"/>
                 <a:cs typeface="Sarabun"/>
               </a:rPr>
-              <a:t>Learner (your turn — say the next line before I show it)</a:t>
+              <a:t>You</a:t>
             </a:r>
           </a:p>
         </p:txBody>
@@ -3907,7 +3907,7 @@
                 <a:ea typeface="Sarabun"/>
                 <a:cs typeface="Sarabun"/>
               </a:rPr>
-              <a:t>Learner (your turn — what do you say after receiving help?)</a:t>
+              <a:t>You</a:t>
             </a:r>
           </a:p>
         </p:txBody>

</xml_diff>

<commit_message>
fix(pptx): add PiP to canva-deck, fix opener text overlap
- Added PiP placeholder to canva-deck renderer (was missing)
- Reduced opener title from 42pt to 32pt to prevent wrapping overflow
- Increased title textbox height and moved bullet block down
- Constrained opener bullet block width to CONTENT_WIDTH_BESIDE_PIP

Co-Authored-By: Claude Opus 4.6 (1M context) <noreply@anthropic.com>

Former-commit-id: aa30965c7339277fed0d6c1a2e0691c64b52880d
Former-commit-id: 00d1211fc8898a3e3087ecbe5a4419f1bdcce7d9
Former-commit-id: d796383844feaa369a551f654cb81e55418c5600
</commit_message>
<xml_diff>
--- a/course/modules/M01/L001/M01-L001-canva-deck.pptx
+++ b/course/modules/M01/L001/M01-L001-canva-deck.pptx
@@ -3271,6 +3271,63 @@
           </a:p>
         </p:txBody>
       </p:sp>
+      <p:sp>
+        <p:nvSpPr>
+          <p:cNvPr id="7" name="__pip_placeholder__"/>
+          <p:cNvSpPr/>
+          <p:nvPr/>
+        </p:nvSpPr>
+        <p:spPr>
+          <a:xfrm>
+            <a:off x="8351215" y="0"/>
+            <a:ext cx="3840480" cy="2880360"/>
+          </a:xfrm>
+          <a:prstGeom prst="rect">
+            <a:avLst/>
+          </a:prstGeom>
+          <a:solidFill>
+            <a:srgbClr val="DBE7EC">
+              <a:alpha val="30000"/>
+            </a:srgbClr>
+          </a:solidFill>
+          <a:ln w="19050">
+            <a:solidFill>
+              <a:srgbClr val="355C7D"/>
+            </a:solidFill>
+            <a:prstDash val="sysDash"/>
+          </a:ln>
+        </p:spPr>
+        <p:style>
+          <a:lnRef idx="1">
+            <a:schemeClr val="accent1"/>
+          </a:lnRef>
+          <a:fillRef idx="3">
+            <a:schemeClr val="accent1"/>
+          </a:fillRef>
+          <a:effectRef idx="2">
+            <a:schemeClr val="accent1"/>
+          </a:effectRef>
+          <a:fontRef idx="minor">
+            <a:schemeClr val="lt1"/>
+          </a:fontRef>
+        </p:style>
+        <p:txBody>
+          <a:bodyPr rtlCol="0" anchor="ctr" wrap="none"/>
+          <a:lstStyle/>
+          <a:p>
+            <a:pPr algn="ctr"/>
+            <a:r>
+              <a:rPr sz="1800" b="1">
+                <a:solidFill>
+                  <a:srgbClr val="355C7D"/>
+                </a:solidFill>
+                <a:latin typeface="Sarabun"/>
+              </a:rPr>
+              <a:t>Nine</a:t>
+            </a:r>
+          </a:p>
+        </p:txBody>
+      </p:sp>
     </p:spTree>
   </p:cSld>
   <p:clrMapOvr>
@@ -4119,6 +4176,63 @@
           </a:p>
         </p:txBody>
       </p:sp>
+      <p:sp>
+        <p:nvSpPr>
+          <p:cNvPr id="23" name="__pip_placeholder__"/>
+          <p:cNvSpPr/>
+          <p:nvPr/>
+        </p:nvSpPr>
+        <p:spPr>
+          <a:xfrm>
+            <a:off x="8351215" y="0"/>
+            <a:ext cx="3840480" cy="2880360"/>
+          </a:xfrm>
+          <a:prstGeom prst="rect">
+            <a:avLst/>
+          </a:prstGeom>
+          <a:solidFill>
+            <a:srgbClr val="DBE7EC">
+              <a:alpha val="30000"/>
+            </a:srgbClr>
+          </a:solidFill>
+          <a:ln w="19050">
+            <a:solidFill>
+              <a:srgbClr val="355C7D"/>
+            </a:solidFill>
+            <a:prstDash val="sysDash"/>
+          </a:ln>
+        </p:spPr>
+        <p:style>
+          <a:lnRef idx="1">
+            <a:schemeClr val="accent1"/>
+          </a:lnRef>
+          <a:fillRef idx="3">
+            <a:schemeClr val="accent1"/>
+          </a:fillRef>
+          <a:effectRef idx="2">
+            <a:schemeClr val="accent1"/>
+          </a:effectRef>
+          <a:fontRef idx="minor">
+            <a:schemeClr val="lt1"/>
+          </a:fontRef>
+        </p:style>
+        <p:txBody>
+          <a:bodyPr rtlCol="0" anchor="ctr" wrap="none"/>
+          <a:lstStyle/>
+          <a:p>
+            <a:pPr algn="ctr"/>
+            <a:r>
+              <a:rPr sz="1800" b="1">
+                <a:solidFill>
+                  <a:srgbClr val="355C7D"/>
+                </a:solidFill>
+                <a:latin typeface="Sarabun"/>
+              </a:rPr>
+              <a:t>Nine</a:t>
+            </a:r>
+          </a:p>
+        </p:txBody>
+      </p:sp>
     </p:spTree>
   </p:cSld>
   <p:clrMapOvr>
@@ -4581,6 +4695,63 @@
           </a:p>
         </p:txBody>
       </p:sp>
+      <p:sp>
+        <p:nvSpPr>
+          <p:cNvPr id="9" name="__pip_placeholder__"/>
+          <p:cNvSpPr/>
+          <p:nvPr/>
+        </p:nvSpPr>
+        <p:spPr>
+          <a:xfrm>
+            <a:off x="8351215" y="0"/>
+            <a:ext cx="3840480" cy="2880360"/>
+          </a:xfrm>
+          <a:prstGeom prst="rect">
+            <a:avLst/>
+          </a:prstGeom>
+          <a:solidFill>
+            <a:srgbClr val="DBE7EC">
+              <a:alpha val="30000"/>
+            </a:srgbClr>
+          </a:solidFill>
+          <a:ln w="19050">
+            <a:solidFill>
+              <a:srgbClr val="355C7D"/>
+            </a:solidFill>
+            <a:prstDash val="sysDash"/>
+          </a:ln>
+        </p:spPr>
+        <p:style>
+          <a:lnRef idx="1">
+            <a:schemeClr val="accent1"/>
+          </a:lnRef>
+          <a:fillRef idx="3">
+            <a:schemeClr val="accent1"/>
+          </a:fillRef>
+          <a:effectRef idx="2">
+            <a:schemeClr val="accent1"/>
+          </a:effectRef>
+          <a:fontRef idx="minor">
+            <a:schemeClr val="lt1"/>
+          </a:fontRef>
+        </p:style>
+        <p:txBody>
+          <a:bodyPr rtlCol="0" anchor="ctr" wrap="none"/>
+          <a:lstStyle/>
+          <a:p>
+            <a:pPr algn="ctr"/>
+            <a:r>
+              <a:rPr sz="1800" b="1">
+                <a:solidFill>
+                  <a:srgbClr val="355C7D"/>
+                </a:solidFill>
+                <a:latin typeface="Sarabun"/>
+              </a:rPr>
+              <a:t>Nine</a:t>
+            </a:r>
+          </a:p>
+        </p:txBody>
+      </p:sp>
     </p:spTree>
   </p:cSld>
   <p:clrMapOvr>
@@ -4822,6 +4993,63 @@
           </a:p>
         </p:txBody>
       </p:sp>
+      <p:sp>
+        <p:nvSpPr>
+          <p:cNvPr id="8" name="__pip_placeholder__"/>
+          <p:cNvSpPr/>
+          <p:nvPr/>
+        </p:nvSpPr>
+        <p:spPr>
+          <a:xfrm>
+            <a:off x="8351215" y="0"/>
+            <a:ext cx="3840480" cy="2880360"/>
+          </a:xfrm>
+          <a:prstGeom prst="rect">
+            <a:avLst/>
+          </a:prstGeom>
+          <a:solidFill>
+            <a:srgbClr val="DBE7EC">
+              <a:alpha val="30000"/>
+            </a:srgbClr>
+          </a:solidFill>
+          <a:ln w="19050">
+            <a:solidFill>
+              <a:srgbClr val="355C7D"/>
+            </a:solidFill>
+            <a:prstDash val="sysDash"/>
+          </a:ln>
+        </p:spPr>
+        <p:style>
+          <a:lnRef idx="1">
+            <a:schemeClr val="accent1"/>
+          </a:lnRef>
+          <a:fillRef idx="3">
+            <a:schemeClr val="accent1"/>
+          </a:fillRef>
+          <a:effectRef idx="2">
+            <a:schemeClr val="accent1"/>
+          </a:effectRef>
+          <a:fontRef idx="minor">
+            <a:schemeClr val="lt1"/>
+          </a:fontRef>
+        </p:style>
+        <p:txBody>
+          <a:bodyPr rtlCol="0" anchor="ctr" wrap="none"/>
+          <a:lstStyle/>
+          <a:p>
+            <a:pPr algn="ctr"/>
+            <a:r>
+              <a:rPr sz="1800" b="1">
+                <a:solidFill>
+                  <a:srgbClr val="355C7D"/>
+                </a:solidFill>
+                <a:latin typeface="Sarabun"/>
+              </a:rPr>
+              <a:t>Nine</a:t>
+            </a:r>
+          </a:p>
+        </p:txBody>
+      </p:sp>
     </p:spTree>
   </p:cSld>
   <p:clrMapOvr>
@@ -5339,6 +5567,63 @@
           </a:p>
         </p:txBody>
       </p:sp>
+      <p:sp>
+        <p:nvSpPr>
+          <p:cNvPr id="9" name="__pip_placeholder__"/>
+          <p:cNvSpPr/>
+          <p:nvPr/>
+        </p:nvSpPr>
+        <p:spPr>
+          <a:xfrm>
+            <a:off x="8351215" y="0"/>
+            <a:ext cx="3840480" cy="2880360"/>
+          </a:xfrm>
+          <a:prstGeom prst="rect">
+            <a:avLst/>
+          </a:prstGeom>
+          <a:solidFill>
+            <a:srgbClr val="DBE7EC">
+              <a:alpha val="30000"/>
+            </a:srgbClr>
+          </a:solidFill>
+          <a:ln w="19050">
+            <a:solidFill>
+              <a:srgbClr val="355C7D"/>
+            </a:solidFill>
+            <a:prstDash val="sysDash"/>
+          </a:ln>
+        </p:spPr>
+        <p:style>
+          <a:lnRef idx="1">
+            <a:schemeClr val="accent1"/>
+          </a:lnRef>
+          <a:fillRef idx="3">
+            <a:schemeClr val="accent1"/>
+          </a:fillRef>
+          <a:effectRef idx="2">
+            <a:schemeClr val="accent1"/>
+          </a:effectRef>
+          <a:fontRef idx="minor">
+            <a:schemeClr val="lt1"/>
+          </a:fontRef>
+        </p:style>
+        <p:txBody>
+          <a:bodyPr rtlCol="0" anchor="ctr" wrap="none"/>
+          <a:lstStyle/>
+          <a:p>
+            <a:pPr algn="ctr"/>
+            <a:r>
+              <a:rPr sz="1800" b="1">
+                <a:solidFill>
+                  <a:srgbClr val="355C7D"/>
+                </a:solidFill>
+                <a:latin typeface="Sarabun"/>
+              </a:rPr>
+              <a:t>Nine</a:t>
+            </a:r>
+          </a:p>
+        </p:txBody>
+      </p:sp>
     </p:spTree>
   </p:cSld>
   <p:clrMapOvr>
@@ -5591,6 +5876,63 @@
           </a:p>
         </p:txBody>
       </p:sp>
+      <p:sp>
+        <p:nvSpPr>
+          <p:cNvPr id="8" name="__pip_placeholder__"/>
+          <p:cNvSpPr/>
+          <p:nvPr/>
+        </p:nvSpPr>
+        <p:spPr>
+          <a:xfrm>
+            <a:off x="8351215" y="0"/>
+            <a:ext cx="3840480" cy="2880360"/>
+          </a:xfrm>
+          <a:prstGeom prst="rect">
+            <a:avLst/>
+          </a:prstGeom>
+          <a:solidFill>
+            <a:srgbClr val="DBE7EC">
+              <a:alpha val="30000"/>
+            </a:srgbClr>
+          </a:solidFill>
+          <a:ln w="19050">
+            <a:solidFill>
+              <a:srgbClr val="355C7D"/>
+            </a:solidFill>
+            <a:prstDash val="sysDash"/>
+          </a:ln>
+        </p:spPr>
+        <p:style>
+          <a:lnRef idx="1">
+            <a:schemeClr val="accent1"/>
+          </a:lnRef>
+          <a:fillRef idx="3">
+            <a:schemeClr val="accent1"/>
+          </a:fillRef>
+          <a:effectRef idx="2">
+            <a:schemeClr val="accent1"/>
+          </a:effectRef>
+          <a:fontRef idx="minor">
+            <a:schemeClr val="lt1"/>
+          </a:fontRef>
+        </p:style>
+        <p:txBody>
+          <a:bodyPr rtlCol="0" anchor="ctr" wrap="none"/>
+          <a:lstStyle/>
+          <a:p>
+            <a:pPr algn="ctr"/>
+            <a:r>
+              <a:rPr sz="1800" b="1">
+                <a:solidFill>
+                  <a:srgbClr val="355C7D"/>
+                </a:solidFill>
+                <a:latin typeface="Sarabun"/>
+              </a:rPr>
+              <a:t>Nine</a:t>
+            </a:r>
+          </a:p>
+        </p:txBody>
+      </p:sp>
     </p:spTree>
   </p:cSld>
   <p:clrMapOvr>
@@ -5999,6 +6341,63 @@
           </a:p>
         </p:txBody>
       </p:sp>
+      <p:sp>
+        <p:nvSpPr>
+          <p:cNvPr id="12" name="__pip_placeholder__"/>
+          <p:cNvSpPr/>
+          <p:nvPr/>
+        </p:nvSpPr>
+        <p:spPr>
+          <a:xfrm>
+            <a:off x="8351215" y="0"/>
+            <a:ext cx="3840480" cy="2880360"/>
+          </a:xfrm>
+          <a:prstGeom prst="rect">
+            <a:avLst/>
+          </a:prstGeom>
+          <a:solidFill>
+            <a:srgbClr val="DBE7EC">
+              <a:alpha val="30000"/>
+            </a:srgbClr>
+          </a:solidFill>
+          <a:ln w="19050">
+            <a:solidFill>
+              <a:srgbClr val="355C7D"/>
+            </a:solidFill>
+            <a:prstDash val="sysDash"/>
+          </a:ln>
+        </p:spPr>
+        <p:style>
+          <a:lnRef idx="1">
+            <a:schemeClr val="accent1"/>
+          </a:lnRef>
+          <a:fillRef idx="3">
+            <a:schemeClr val="accent1"/>
+          </a:fillRef>
+          <a:effectRef idx="2">
+            <a:schemeClr val="accent1"/>
+          </a:effectRef>
+          <a:fontRef idx="minor">
+            <a:schemeClr val="lt1"/>
+          </a:fontRef>
+        </p:style>
+        <p:txBody>
+          <a:bodyPr rtlCol="0" anchor="ctr" wrap="none"/>
+          <a:lstStyle/>
+          <a:p>
+            <a:pPr algn="ctr"/>
+            <a:r>
+              <a:rPr sz="1800" b="1">
+                <a:solidFill>
+                  <a:srgbClr val="355C7D"/>
+                </a:solidFill>
+                <a:latin typeface="Sarabun"/>
+              </a:rPr>
+              <a:t>Nine</a:t>
+            </a:r>
+          </a:p>
+        </p:txBody>
+      </p:sp>
     </p:spTree>
   </p:cSld>
   <p:clrMapOvr>
@@ -6481,6 +6880,63 @@
           </a:p>
         </p:txBody>
       </p:sp>
+      <p:sp>
+        <p:nvSpPr>
+          <p:cNvPr id="14" name="__pip_placeholder__"/>
+          <p:cNvSpPr/>
+          <p:nvPr/>
+        </p:nvSpPr>
+        <p:spPr>
+          <a:xfrm>
+            <a:off x="8351215" y="0"/>
+            <a:ext cx="3840480" cy="2880360"/>
+          </a:xfrm>
+          <a:prstGeom prst="rect">
+            <a:avLst/>
+          </a:prstGeom>
+          <a:solidFill>
+            <a:srgbClr val="DBE7EC">
+              <a:alpha val="30000"/>
+            </a:srgbClr>
+          </a:solidFill>
+          <a:ln w="19050">
+            <a:solidFill>
+              <a:srgbClr val="355C7D"/>
+            </a:solidFill>
+            <a:prstDash val="sysDash"/>
+          </a:ln>
+        </p:spPr>
+        <p:style>
+          <a:lnRef idx="1">
+            <a:schemeClr val="accent1"/>
+          </a:lnRef>
+          <a:fillRef idx="3">
+            <a:schemeClr val="accent1"/>
+          </a:fillRef>
+          <a:effectRef idx="2">
+            <a:schemeClr val="accent1"/>
+          </a:effectRef>
+          <a:fontRef idx="minor">
+            <a:schemeClr val="lt1"/>
+          </a:fontRef>
+        </p:style>
+        <p:txBody>
+          <a:bodyPr rtlCol="0" anchor="ctr" wrap="none"/>
+          <a:lstStyle/>
+          <a:p>
+            <a:pPr algn="ctr"/>
+            <a:r>
+              <a:rPr sz="1800" b="1">
+                <a:solidFill>
+                  <a:srgbClr val="355C7D"/>
+                </a:solidFill>
+                <a:latin typeface="Sarabun"/>
+              </a:rPr>
+              <a:t>Nine</a:t>
+            </a:r>
+          </a:p>
+        </p:txBody>
+      </p:sp>
     </p:spTree>
   </p:cSld>
   <p:clrMapOvr>
@@ -7000,6 +7456,63 @@
           </a:p>
         </p:txBody>
       </p:sp>
+      <p:sp>
+        <p:nvSpPr>
+          <p:cNvPr id="15" name="__pip_placeholder__"/>
+          <p:cNvSpPr/>
+          <p:nvPr/>
+        </p:nvSpPr>
+        <p:spPr>
+          <a:xfrm>
+            <a:off x="8351215" y="0"/>
+            <a:ext cx="3840480" cy="2880360"/>
+          </a:xfrm>
+          <a:prstGeom prst="rect">
+            <a:avLst/>
+          </a:prstGeom>
+          <a:solidFill>
+            <a:srgbClr val="DBE7EC">
+              <a:alpha val="30000"/>
+            </a:srgbClr>
+          </a:solidFill>
+          <a:ln w="19050">
+            <a:solidFill>
+              <a:srgbClr val="355C7D"/>
+            </a:solidFill>
+            <a:prstDash val="sysDash"/>
+          </a:ln>
+        </p:spPr>
+        <p:style>
+          <a:lnRef idx="1">
+            <a:schemeClr val="accent1"/>
+          </a:lnRef>
+          <a:fillRef idx="3">
+            <a:schemeClr val="accent1"/>
+          </a:fillRef>
+          <a:effectRef idx="2">
+            <a:schemeClr val="accent1"/>
+          </a:effectRef>
+          <a:fontRef idx="minor">
+            <a:schemeClr val="lt1"/>
+          </a:fontRef>
+        </p:style>
+        <p:txBody>
+          <a:bodyPr rtlCol="0" anchor="ctr" wrap="none"/>
+          <a:lstStyle/>
+          <a:p>
+            <a:pPr algn="ctr"/>
+            <a:r>
+              <a:rPr sz="1800" b="1">
+                <a:solidFill>
+                  <a:srgbClr val="355C7D"/>
+                </a:solidFill>
+                <a:latin typeface="Sarabun"/>
+              </a:rPr>
+              <a:t>Nine</a:t>
+            </a:r>
+          </a:p>
+        </p:txBody>
+      </p:sp>
     </p:spTree>
   </p:cSld>
   <p:clrMapOvr>
@@ -7553,6 +8066,63 @@
           </a:p>
         </p:txBody>
       </p:sp>
+      <p:sp>
+        <p:nvSpPr>
+          <p:cNvPr id="13" name="__pip_placeholder__"/>
+          <p:cNvSpPr/>
+          <p:nvPr/>
+        </p:nvSpPr>
+        <p:spPr>
+          <a:xfrm>
+            <a:off x="8351215" y="0"/>
+            <a:ext cx="3840480" cy="2880360"/>
+          </a:xfrm>
+          <a:prstGeom prst="rect">
+            <a:avLst/>
+          </a:prstGeom>
+          <a:solidFill>
+            <a:srgbClr val="DBE7EC">
+              <a:alpha val="30000"/>
+            </a:srgbClr>
+          </a:solidFill>
+          <a:ln w="19050">
+            <a:solidFill>
+              <a:srgbClr val="355C7D"/>
+            </a:solidFill>
+            <a:prstDash val="sysDash"/>
+          </a:ln>
+        </p:spPr>
+        <p:style>
+          <a:lnRef idx="1">
+            <a:schemeClr val="accent1"/>
+          </a:lnRef>
+          <a:fillRef idx="3">
+            <a:schemeClr val="accent1"/>
+          </a:fillRef>
+          <a:effectRef idx="2">
+            <a:schemeClr val="accent1"/>
+          </a:effectRef>
+          <a:fontRef idx="minor">
+            <a:schemeClr val="lt1"/>
+          </a:fontRef>
+        </p:style>
+        <p:txBody>
+          <a:bodyPr rtlCol="0" anchor="ctr" wrap="none"/>
+          <a:lstStyle/>
+          <a:p>
+            <a:pPr algn="ctr"/>
+            <a:r>
+              <a:rPr sz="1800" b="1">
+                <a:solidFill>
+                  <a:srgbClr val="355C7D"/>
+                </a:solidFill>
+                <a:latin typeface="Sarabun"/>
+              </a:rPr>
+              <a:t>Nine</a:t>
+            </a:r>
+          </a:p>
+        </p:txBody>
+      </p:sp>
     </p:spTree>
   </p:cSld>
   <p:clrMapOvr>
@@ -8406,6 +8976,63 @@
           </a:p>
         </p:txBody>
       </p:sp>
+      <p:sp>
+        <p:nvSpPr>
+          <p:cNvPr id="16" name="__pip_placeholder__"/>
+          <p:cNvSpPr/>
+          <p:nvPr/>
+        </p:nvSpPr>
+        <p:spPr>
+          <a:xfrm>
+            <a:off x="8351215" y="0"/>
+            <a:ext cx="3840480" cy="2880360"/>
+          </a:xfrm>
+          <a:prstGeom prst="rect">
+            <a:avLst/>
+          </a:prstGeom>
+          <a:solidFill>
+            <a:srgbClr val="DBE7EC">
+              <a:alpha val="30000"/>
+            </a:srgbClr>
+          </a:solidFill>
+          <a:ln w="19050">
+            <a:solidFill>
+              <a:srgbClr val="355C7D"/>
+            </a:solidFill>
+            <a:prstDash val="sysDash"/>
+          </a:ln>
+        </p:spPr>
+        <p:style>
+          <a:lnRef idx="1">
+            <a:schemeClr val="accent1"/>
+          </a:lnRef>
+          <a:fillRef idx="3">
+            <a:schemeClr val="accent1"/>
+          </a:fillRef>
+          <a:effectRef idx="2">
+            <a:schemeClr val="accent1"/>
+          </a:effectRef>
+          <a:fontRef idx="minor">
+            <a:schemeClr val="lt1"/>
+          </a:fontRef>
+        </p:style>
+        <p:txBody>
+          <a:bodyPr rtlCol="0" anchor="ctr" wrap="none"/>
+          <a:lstStyle/>
+          <a:p>
+            <a:pPr algn="ctr"/>
+            <a:r>
+              <a:rPr sz="1800" b="1">
+                <a:solidFill>
+                  <a:srgbClr val="355C7D"/>
+                </a:solidFill>
+                <a:latin typeface="Sarabun"/>
+              </a:rPr>
+              <a:t>Nine</a:t>
+            </a:r>
+          </a:p>
+        </p:txBody>
+      </p:sp>
     </p:spTree>
   </p:cSld>
   <p:clrMapOvr>
@@ -8947,6 +9574,63 @@
                 <a:cs typeface="Sarabun"/>
               </a:rPr>
               <a:t>Softens the situation - not a yes/no answer</a:t>
+            </a:r>
+          </a:p>
+        </p:txBody>
+      </p:sp>
+      <p:sp>
+        <p:nvSpPr>
+          <p:cNvPr id="16" name="__pip_placeholder__"/>
+          <p:cNvSpPr/>
+          <p:nvPr/>
+        </p:nvSpPr>
+        <p:spPr>
+          <a:xfrm>
+            <a:off x="8351215" y="0"/>
+            <a:ext cx="3840480" cy="2880360"/>
+          </a:xfrm>
+          <a:prstGeom prst="rect">
+            <a:avLst/>
+          </a:prstGeom>
+          <a:solidFill>
+            <a:srgbClr val="DBE7EC">
+              <a:alpha val="30000"/>
+            </a:srgbClr>
+          </a:solidFill>
+          <a:ln w="19050">
+            <a:solidFill>
+              <a:srgbClr val="355C7D"/>
+            </a:solidFill>
+            <a:prstDash val="sysDash"/>
+          </a:ln>
+        </p:spPr>
+        <p:style>
+          <a:lnRef idx="1">
+            <a:schemeClr val="accent1"/>
+          </a:lnRef>
+          <a:fillRef idx="3">
+            <a:schemeClr val="accent1"/>
+          </a:fillRef>
+          <a:effectRef idx="2">
+            <a:schemeClr val="accent1"/>
+          </a:effectRef>
+          <a:fontRef idx="minor">
+            <a:schemeClr val="lt1"/>
+          </a:fontRef>
+        </p:style>
+        <p:txBody>
+          <a:bodyPr rtlCol="0" anchor="ctr" wrap="none"/>
+          <a:lstStyle/>
+          <a:p>
+            <a:pPr algn="ctr"/>
+            <a:r>
+              <a:rPr sz="1800" b="1">
+                <a:solidFill>
+                  <a:srgbClr val="355C7D"/>
+                </a:solidFill>
+                <a:latin typeface="Sarabun"/>
+              </a:rPr>
+              <a:t>Nine</a:t>
             </a:r>
           </a:p>
         </p:txBody>

</xml_diff>

<commit_message>
fix(pptx): text-only slides, remove images and internal metadata
- Disabled all image fetching/rendering — slides are text-only now
- Removed "Visual rationale" internal metadata from student slides
- Triplet cards now use full constrained width (was limited to left column)
- Drill block placed directly below content (was pushed to fixed Y=4.85")
- No images, no rationale text, no boxes on any slide

Co-Authored-By: Claude Opus 4.6 (1M context) <noreply@anthropic.com>

Former-commit-id: 9fdc66174ea510c68942299e0a386ab4bfae277f
Former-commit-id: db7e4648d2579444f97fd61e4caab7ca53b5b2b1
Former-commit-id: da59666540db84abe4701111a0ebb5aad30faf9f
</commit_message>
<xml_diff>
--- a/course/modules/M01/L001/M01-L001-canva-deck.pptx
+++ b/course/modules/M01/L001/M01-L001-canva-deck.pptx
@@ -4816,7 +4816,7 @@
         <p:spPr>
           <a:xfrm>
             <a:off x="731520" y="1325880"/>
-            <a:ext cx="3889080" cy="1572768"/>
+            <a:ext cx="7071055" cy="1572768"/>
           </a:xfrm>
           <a:prstGeom prst="roundRect">
             <a:avLst/>
@@ -4900,7 +4900,7 @@
         <p:spPr>
           <a:xfrm>
             <a:off x="1078992" y="1435608"/>
-            <a:ext cx="3431880" cy="658368"/>
+            <a:ext cx="6613855" cy="658368"/>
           </a:xfrm>
           <a:prstGeom prst="rect">
             <a:avLst/>
@@ -4948,7 +4948,7 @@
         <p:spPr>
           <a:xfrm>
             <a:off x="1078992" y="2203704"/>
-            <a:ext cx="3431880" cy="274320"/>
+            <a:ext cx="6613855" cy="274320"/>
           </a:xfrm>
           <a:prstGeom prst="rect">
             <a:avLst/>
@@ -4985,7 +4985,7 @@
         <p:spPr>
           <a:xfrm>
             <a:off x="731520" y="3081528"/>
-            <a:ext cx="3889080" cy="1572768"/>
+            <a:ext cx="7071055" cy="1572768"/>
           </a:xfrm>
           <a:prstGeom prst="roundRect">
             <a:avLst/>
@@ -5069,7 +5069,7 @@
         <p:spPr>
           <a:xfrm>
             <a:off x="1078992" y="3191256"/>
-            <a:ext cx="3431880" cy="658368"/>
+            <a:ext cx="6613855" cy="658368"/>
           </a:xfrm>
           <a:prstGeom prst="rect">
             <a:avLst/>
@@ -5117,7 +5117,7 @@
         <p:spPr>
           <a:xfrm>
             <a:off x="1078992" y="3959352"/>
-            <a:ext cx="3431880" cy="274320"/>
+            <a:ext cx="6613855" cy="274320"/>
           </a:xfrm>
           <a:prstGeom prst="rect">
             <a:avLst/>
@@ -5154,7 +5154,7 @@
         <p:spPr>
           <a:xfrm>
             <a:off x="731520" y="4837176"/>
-            <a:ext cx="3889080" cy="1572768"/>
+            <a:ext cx="7071055" cy="1572768"/>
           </a:xfrm>
           <a:prstGeom prst="roundRect">
             <a:avLst/>
@@ -5238,7 +5238,7 @@
         <p:spPr>
           <a:xfrm>
             <a:off x="1078992" y="4946904"/>
-            <a:ext cx="3431880" cy="658368"/>
+            <a:ext cx="6613855" cy="658368"/>
           </a:xfrm>
           <a:prstGeom prst="rect">
             <a:avLst/>
@@ -5286,7 +5286,7 @@
         <p:spPr>
           <a:xfrm>
             <a:off x="1078992" y="5715000"/>
-            <a:ext cx="3431880" cy="274320"/>
+            <a:ext cx="6613855" cy="274320"/>
           </a:xfrm>
           <a:prstGeom prst="rect">
             <a:avLst/>
@@ -5322,7 +5322,7 @@
         </p:nvSpPr>
         <p:spPr>
           <a:xfrm>
-            <a:off x="932688" y="6922008"/>
+            <a:off x="932688" y="6876288"/>
             <a:ext cx="9692640" cy="228600"/>
           </a:xfrm>
           <a:prstGeom prst="rect">
@@ -5359,7 +5359,7 @@
         </p:nvSpPr>
         <p:spPr>
           <a:xfrm>
-            <a:off x="932688" y="7306056"/>
+            <a:off x="932688" y="7260336"/>
             <a:ext cx="82296" cy="82296"/>
           </a:xfrm>
           <a:prstGeom prst="ellipse">
@@ -5402,7 +5402,7 @@
         </p:nvSpPr>
         <p:spPr>
           <a:xfrm>
-            <a:off x="1078992" y="7214616"/>
+            <a:off x="1078992" y="7168896"/>
             <a:ext cx="9555480" cy="274320"/>
           </a:xfrm>
           <a:prstGeom prst="rect">
@@ -5739,7 +5739,7 @@
         <p:spPr>
           <a:xfrm>
             <a:off x="731520" y="1325880"/>
-            <a:ext cx="3889080" cy="1572768"/>
+            <a:ext cx="7071055" cy="1572768"/>
           </a:xfrm>
           <a:prstGeom prst="roundRect">
             <a:avLst/>
@@ -5823,7 +5823,7 @@
         <p:spPr>
           <a:xfrm>
             <a:off x="1078992" y="1435608"/>
-            <a:ext cx="3431880" cy="658368"/>
+            <a:ext cx="6613855" cy="658368"/>
           </a:xfrm>
           <a:prstGeom prst="rect">
             <a:avLst/>
@@ -5871,7 +5871,7 @@
         <p:spPr>
           <a:xfrm>
             <a:off x="1078992" y="2203704"/>
-            <a:ext cx="3431880" cy="274320"/>
+            <a:ext cx="6613855" cy="274320"/>
           </a:xfrm>
           <a:prstGeom prst="rect">
             <a:avLst/>
@@ -5908,7 +5908,7 @@
         <p:spPr>
           <a:xfrm>
             <a:off x="731520" y="3081528"/>
-            <a:ext cx="3889080" cy="1572768"/>
+            <a:ext cx="7071055" cy="1572768"/>
           </a:xfrm>
           <a:prstGeom prst="roundRect">
             <a:avLst/>
@@ -5992,7 +5992,7 @@
         <p:spPr>
           <a:xfrm>
             <a:off x="1078992" y="3191256"/>
-            <a:ext cx="3431880" cy="658368"/>
+            <a:ext cx="6613855" cy="658368"/>
           </a:xfrm>
           <a:prstGeom prst="rect">
             <a:avLst/>
@@ -6040,7 +6040,7 @@
         <p:spPr>
           <a:xfrm>
             <a:off x="1078992" y="3959352"/>
-            <a:ext cx="3431880" cy="274320"/>
+            <a:ext cx="6613855" cy="274320"/>
           </a:xfrm>
           <a:prstGeom prst="rect">
             <a:avLst/>
@@ -6077,7 +6077,7 @@
         <p:spPr>
           <a:xfrm>
             <a:off x="731520" y="4837176"/>
-            <a:ext cx="3889080" cy="1572768"/>
+            <a:ext cx="7071055" cy="1572768"/>
           </a:xfrm>
           <a:prstGeom prst="roundRect">
             <a:avLst/>
@@ -6161,7 +6161,7 @@
         <p:spPr>
           <a:xfrm>
             <a:off x="1078992" y="4946904"/>
-            <a:ext cx="3431880" cy="658368"/>
+            <a:ext cx="6613855" cy="658368"/>
           </a:xfrm>
           <a:prstGeom prst="rect">
             <a:avLst/>
@@ -6209,7 +6209,7 @@
         <p:spPr>
           <a:xfrm>
             <a:off x="1078992" y="5715000"/>
-            <a:ext cx="3431880" cy="274320"/>
+            <a:ext cx="6613855" cy="274320"/>
           </a:xfrm>
           <a:prstGeom prst="rect">
             <a:avLst/>
@@ -6245,7 +6245,7 @@
         </p:nvSpPr>
         <p:spPr>
           <a:xfrm>
-            <a:off x="932688" y="6922008"/>
+            <a:off x="932688" y="6876288"/>
             <a:ext cx="9692640" cy="228600"/>
           </a:xfrm>
           <a:prstGeom prst="rect">
@@ -6282,7 +6282,7 @@
         </p:nvSpPr>
         <p:spPr>
           <a:xfrm>
-            <a:off x="932688" y="7306056"/>
+            <a:off x="932688" y="7260336"/>
             <a:ext cx="82296" cy="82296"/>
           </a:xfrm>
           <a:prstGeom prst="ellipse">
@@ -6325,7 +6325,7 @@
         </p:nvSpPr>
         <p:spPr>
           <a:xfrm>
-            <a:off x="1078992" y="7214616"/>
+            <a:off x="1078992" y="7168896"/>
             <a:ext cx="9555480" cy="274320"/>
           </a:xfrm>
           <a:prstGeom prst="rect">
@@ -6629,7 +6629,7 @@
         <p:spPr>
           <a:xfrm>
             <a:off x="731520" y="1325880"/>
-            <a:ext cx="3889080" cy="1572768"/>
+            <a:ext cx="7071055" cy="1572768"/>
           </a:xfrm>
           <a:prstGeom prst="roundRect">
             <a:avLst/>
@@ -6713,7 +6713,7 @@
         <p:spPr>
           <a:xfrm>
             <a:off x="1078992" y="1435608"/>
-            <a:ext cx="3431880" cy="658368"/>
+            <a:ext cx="6613855" cy="658368"/>
           </a:xfrm>
           <a:prstGeom prst="rect">
             <a:avLst/>
@@ -6761,7 +6761,7 @@
         <p:spPr>
           <a:xfrm>
             <a:off x="1078992" y="2203704"/>
-            <a:ext cx="3431880" cy="274320"/>
+            <a:ext cx="6613855" cy="274320"/>
           </a:xfrm>
           <a:prstGeom prst="rect">
             <a:avLst/>
@@ -6798,7 +6798,7 @@
         <p:spPr>
           <a:xfrm>
             <a:off x="731520" y="3081528"/>
-            <a:ext cx="3889080" cy="1572768"/>
+            <a:ext cx="7071055" cy="1572768"/>
           </a:xfrm>
           <a:prstGeom prst="roundRect">
             <a:avLst/>
@@ -6882,7 +6882,7 @@
         <p:spPr>
           <a:xfrm>
             <a:off x="1078992" y="3191256"/>
-            <a:ext cx="3431880" cy="658368"/>
+            <a:ext cx="6613855" cy="658368"/>
           </a:xfrm>
           <a:prstGeom prst="rect">
             <a:avLst/>
@@ -6930,7 +6930,7 @@
         <p:spPr>
           <a:xfrm>
             <a:off x="1078992" y="3959352"/>
-            <a:ext cx="3431880" cy="274320"/>
+            <a:ext cx="6613855" cy="274320"/>
           </a:xfrm>
           <a:prstGeom prst="rect">
             <a:avLst/>
@@ -6967,7 +6967,7 @@
         <p:spPr>
           <a:xfrm>
             <a:off x="731520" y="4837176"/>
-            <a:ext cx="3889080" cy="1572768"/>
+            <a:ext cx="7071055" cy="1572768"/>
           </a:xfrm>
           <a:prstGeom prst="roundRect">
             <a:avLst/>
@@ -7051,7 +7051,7 @@
         <p:spPr>
           <a:xfrm>
             <a:off x="1078992" y="4946904"/>
-            <a:ext cx="3431880" cy="658368"/>
+            <a:ext cx="6613855" cy="658368"/>
           </a:xfrm>
           <a:prstGeom prst="rect">
             <a:avLst/>
@@ -7099,7 +7099,7 @@
         <p:spPr>
           <a:xfrm>
             <a:off x="1078992" y="5715000"/>
-            <a:ext cx="3431880" cy="274320"/>
+            <a:ext cx="6613855" cy="274320"/>
           </a:xfrm>
           <a:prstGeom prst="rect">
             <a:avLst/>
@@ -7135,7 +7135,7 @@
         </p:nvSpPr>
         <p:spPr>
           <a:xfrm>
-            <a:off x="932688" y="6922008"/>
+            <a:off x="932688" y="6876288"/>
             <a:ext cx="9692640" cy="228600"/>
           </a:xfrm>
           <a:prstGeom prst="rect">
@@ -7172,7 +7172,7 @@
         </p:nvSpPr>
         <p:spPr>
           <a:xfrm>
-            <a:off x="932688" y="7306056"/>
+            <a:off x="932688" y="7260336"/>
             <a:ext cx="82296" cy="82296"/>
           </a:xfrm>
           <a:prstGeom prst="ellipse">
@@ -7215,7 +7215,7 @@
         </p:nvSpPr>
         <p:spPr>
           <a:xfrm>
-            <a:off x="1078992" y="7214616"/>
+            <a:off x="1078992" y="7168896"/>
             <a:ext cx="9555480" cy="274320"/>
           </a:xfrm>
           <a:prstGeom prst="rect">
@@ -7552,7 +7552,7 @@
         <p:spPr>
           <a:xfrm>
             <a:off x="731520" y="1325880"/>
-            <a:ext cx="3889080" cy="1572768"/>
+            <a:ext cx="7071055" cy="1572768"/>
           </a:xfrm>
           <a:prstGeom prst="roundRect">
             <a:avLst/>
@@ -7636,7 +7636,7 @@
         <p:spPr>
           <a:xfrm>
             <a:off x="1078992" y="1435608"/>
-            <a:ext cx="3431880" cy="658368"/>
+            <a:ext cx="6613855" cy="658368"/>
           </a:xfrm>
           <a:prstGeom prst="rect">
             <a:avLst/>
@@ -7684,7 +7684,7 @@
         <p:spPr>
           <a:xfrm>
             <a:off x="1078992" y="2203704"/>
-            <a:ext cx="3431880" cy="274320"/>
+            <a:ext cx="6613855" cy="274320"/>
           </a:xfrm>
           <a:prstGeom prst="rect">
             <a:avLst/>
@@ -7721,7 +7721,7 @@
         <p:spPr>
           <a:xfrm>
             <a:off x="731520" y="3081528"/>
-            <a:ext cx="3889080" cy="1572768"/>
+            <a:ext cx="7071055" cy="1572768"/>
           </a:xfrm>
           <a:prstGeom prst="roundRect">
             <a:avLst/>
@@ -7805,7 +7805,7 @@
         <p:spPr>
           <a:xfrm>
             <a:off x="1078992" y="3191256"/>
-            <a:ext cx="3431880" cy="658368"/>
+            <a:ext cx="6613855" cy="658368"/>
           </a:xfrm>
           <a:prstGeom prst="rect">
             <a:avLst/>
@@ -7853,7 +7853,7 @@
         <p:spPr>
           <a:xfrm>
             <a:off x="1078992" y="3959352"/>
-            <a:ext cx="3431880" cy="274320"/>
+            <a:ext cx="6613855" cy="274320"/>
           </a:xfrm>
           <a:prstGeom prst="rect">
             <a:avLst/>
@@ -7890,7 +7890,7 @@
         <p:spPr>
           <a:xfrm>
             <a:off x="731520" y="4837176"/>
-            <a:ext cx="3889080" cy="1572768"/>
+            <a:ext cx="7071055" cy="1572768"/>
           </a:xfrm>
           <a:prstGeom prst="roundRect">
             <a:avLst/>
@@ -7974,7 +7974,7 @@
         <p:spPr>
           <a:xfrm>
             <a:off x="1078992" y="4946904"/>
-            <a:ext cx="3431880" cy="658368"/>
+            <a:ext cx="6613855" cy="658368"/>
           </a:xfrm>
           <a:prstGeom prst="rect">
             <a:avLst/>
@@ -8022,7 +8022,7 @@
         <p:spPr>
           <a:xfrm>
             <a:off x="1078992" y="5715000"/>
-            <a:ext cx="3431880" cy="274320"/>
+            <a:ext cx="6613855" cy="274320"/>
           </a:xfrm>
           <a:prstGeom prst="rect">
             <a:avLst/>
@@ -8058,7 +8058,7 @@
         </p:nvSpPr>
         <p:spPr>
           <a:xfrm>
-            <a:off x="932688" y="6922008"/>
+            <a:off x="932688" y="6876288"/>
             <a:ext cx="9692640" cy="228600"/>
           </a:xfrm>
           <a:prstGeom prst="rect">
@@ -8095,7 +8095,7 @@
         </p:nvSpPr>
         <p:spPr>
           <a:xfrm>
-            <a:off x="932688" y="7306056"/>
+            <a:off x="932688" y="7260336"/>
             <a:ext cx="82296" cy="82296"/>
           </a:xfrm>
           <a:prstGeom prst="ellipse">
@@ -8138,7 +8138,7 @@
         </p:nvSpPr>
         <p:spPr>
           <a:xfrm>
-            <a:off x="1078992" y="7214616"/>
+            <a:off x="1078992" y="7168896"/>
             <a:ext cx="9555480" cy="274320"/>
           </a:xfrm>
           <a:prstGeom prst="rect">
@@ -8442,7 +8442,7 @@
         <p:spPr>
           <a:xfrm>
             <a:off x="731520" y="1325880"/>
-            <a:ext cx="3889080" cy="1572768"/>
+            <a:ext cx="7071055" cy="1572768"/>
           </a:xfrm>
           <a:prstGeom prst="roundRect">
             <a:avLst/>
@@ -8526,7 +8526,7 @@
         <p:spPr>
           <a:xfrm>
             <a:off x="1078992" y="1435608"/>
-            <a:ext cx="3431880" cy="658368"/>
+            <a:ext cx="6613855" cy="658368"/>
           </a:xfrm>
           <a:prstGeom prst="rect">
             <a:avLst/>
@@ -8574,7 +8574,7 @@
         <p:spPr>
           <a:xfrm>
             <a:off x="1078992" y="2203704"/>
-            <a:ext cx="3431880" cy="274320"/>
+            <a:ext cx="6613855" cy="274320"/>
           </a:xfrm>
           <a:prstGeom prst="rect">
             <a:avLst/>
@@ -8611,7 +8611,7 @@
         <p:spPr>
           <a:xfrm>
             <a:off x="731520" y="3081528"/>
-            <a:ext cx="3889080" cy="1572768"/>
+            <a:ext cx="7071055" cy="1572768"/>
           </a:xfrm>
           <a:prstGeom prst="roundRect">
             <a:avLst/>
@@ -8695,7 +8695,7 @@
         <p:spPr>
           <a:xfrm>
             <a:off x="1078992" y="3191256"/>
-            <a:ext cx="3431880" cy="658368"/>
+            <a:ext cx="6613855" cy="658368"/>
           </a:xfrm>
           <a:prstGeom prst="rect">
             <a:avLst/>
@@ -8743,7 +8743,7 @@
         <p:spPr>
           <a:xfrm>
             <a:off x="1078992" y="3959352"/>
-            <a:ext cx="3431880" cy="274320"/>
+            <a:ext cx="6613855" cy="274320"/>
           </a:xfrm>
           <a:prstGeom prst="rect">
             <a:avLst/>
@@ -8780,7 +8780,7 @@
         <p:spPr>
           <a:xfrm>
             <a:off x="731520" y="4837176"/>
-            <a:ext cx="3889080" cy="1572768"/>
+            <a:ext cx="7071055" cy="1572768"/>
           </a:xfrm>
           <a:prstGeom prst="roundRect">
             <a:avLst/>
@@ -8864,7 +8864,7 @@
         <p:spPr>
           <a:xfrm>
             <a:off x="1078992" y="4946904"/>
-            <a:ext cx="3431880" cy="658368"/>
+            <a:ext cx="6613855" cy="658368"/>
           </a:xfrm>
           <a:prstGeom prst="rect">
             <a:avLst/>
@@ -8912,7 +8912,7 @@
         <p:spPr>
           <a:xfrm>
             <a:off x="1078992" y="5715000"/>
-            <a:ext cx="3431880" cy="274320"/>
+            <a:ext cx="6613855" cy="274320"/>
           </a:xfrm>
           <a:prstGeom prst="rect">
             <a:avLst/>
@@ -8948,7 +8948,7 @@
         </p:nvSpPr>
         <p:spPr>
           <a:xfrm>
-            <a:off x="932688" y="6922008"/>
+            <a:off x="932688" y="6876288"/>
             <a:ext cx="9692640" cy="228600"/>
           </a:xfrm>
           <a:prstGeom prst="rect">
@@ -8985,7 +8985,7 @@
         </p:nvSpPr>
         <p:spPr>
           <a:xfrm>
-            <a:off x="932688" y="7306056"/>
+            <a:off x="932688" y="7260336"/>
             <a:ext cx="82296" cy="82296"/>
           </a:xfrm>
           <a:prstGeom prst="ellipse">
@@ -9028,7 +9028,7 @@
         </p:nvSpPr>
         <p:spPr>
           <a:xfrm>
-            <a:off x="1078992" y="7214616"/>
+            <a:off x="1078992" y="7168896"/>
             <a:ext cx="9555480" cy="274320"/>
           </a:xfrm>
           <a:prstGeom prst="rect">

</xml_diff>

<commit_message>
feat(pptx): hard-fail visual QA validator with geometry checks
Expanded validate_slide_layout() with 4 categories of checks:
1. PiP zone intrusion — no shape crosses into camera zone (top-right)
2. Off-screen bottom — no shape below slide height (7.5")
3. Off-screen right — no shape past slide width (13.33")
4. Text-text overlap — existing check (>0.15" vertical overlap)

Validator now hard-fails (sys.exit(1)) instead of printing warnings.
Thin decorative bars (<0.15" tall, no text) are excluded from checks.
Drill blocks that don't fit are moved to speaker notes instead of
overflowing off-screen.

All 3 lessons (L001, L002, L004) pass validation cleanly.

Co-Authored-By: Claude Opus 4.6 (1M context) <noreply@anthropic.com>

Former-commit-id: 99d51b3c2b5ea56ceb91e82716b6455d1454c78b
Former-commit-id: d0efccb3692801949e8b117a27467b6474cb2812
Former-commit-id: 9d1ce70d812abdc56aa6435e408591fd8889dd93
</commit_message>
<xml_diff>
--- a/course/modules/M01/L001/M01-L001-canva-deck.pptx
+++ b/course/modules/M01/L001/M01-L001-canva-deck.pptx
@@ -8,13 +8,13 @@
     <p:sldId id="256" r:id="rId7"/>
     <p:sldId id="257" r:id="rId8"/>
     <p:sldId id="258" r:id="rId9"/>
-    <p:sldId id="259" r:id="rId10"/>
-    <p:sldId id="260" r:id="rId11"/>
-    <p:sldId id="261" r:id="rId12"/>
-    <p:sldId id="262" r:id="rId13"/>
-    <p:sldId id="263" r:id="rId14"/>
-    <p:sldId id="264" r:id="rId15"/>
-    <p:sldId id="265" r:id="rId16"/>
+    <p:sldId id="259" r:id="rId11"/>
+    <p:sldId id="260" r:id="rId12"/>
+    <p:sldId id="261" r:id="rId13"/>
+    <p:sldId id="262" r:id="rId14"/>
+    <p:sldId id="263" r:id="rId15"/>
+    <p:sldId id="264" r:id="rId16"/>
+    <p:sldId id="265" r:id="rId17"/>
   </p:sldIdLst>
   <p:sldSz cx="12191695" cy="6858000" type="screen4x3"/>
   <p:notesSz cx="6858000" cy="9144000"/>
@@ -114,6 +114,791 @@
     </a:lvl9pPr>
   </p:defaultTextStyle>
 </p:presentation>
+</file>
+
+<file path=ppt/notesMasters/notesMaster1.xml><?xml version="1.0" encoding="utf-8"?>
+<p:notesMaster xmlns:a="http://schemas.openxmlformats.org/drawingml/2006/main" xmlns:p="http://schemas.openxmlformats.org/presentationml/2006/main" xmlns:r="http://schemas.openxmlformats.org/officeDocument/2006/relationships">
+  <p:cSld>
+    <p:bg>
+      <p:bgRef idx="1001">
+        <a:schemeClr val="bg1"/>
+      </p:bgRef>
+    </p:bg>
+    <p:spTree>
+      <p:nvGrpSpPr>
+        <p:cNvPr id="1" name=""/>
+        <p:cNvGrpSpPr/>
+        <p:nvPr/>
+      </p:nvGrpSpPr>
+      <p:grpSpPr>
+        <a:xfrm>
+          <a:off x="0" y="0"/>
+          <a:ext cx="0" cy="0"/>
+          <a:chOff x="0" y="0"/>
+          <a:chExt cx="0" cy="0"/>
+        </a:xfrm>
+      </p:grpSpPr>
+      <p:sp>
+        <p:nvSpPr>
+          <p:cNvPr id="2" name="Header Placeholder 1"/>
+          <p:cNvSpPr>
+            <a:spLocks noGrp="1"/>
+          </p:cNvSpPr>
+          <p:nvPr>
+            <p:ph type="hdr" sz="quarter"/>
+          </p:nvPr>
+        </p:nvSpPr>
+        <p:spPr>
+          <a:xfrm>
+            <a:off x="0" y="0"/>
+            <a:ext cx="2971800" cy="457200"/>
+          </a:xfrm>
+          <a:prstGeom prst="rect">
+            <a:avLst/>
+          </a:prstGeom>
+        </p:spPr>
+        <p:txBody>
+          <a:bodyPr vert="horz" lIns="91440" tIns="45720" rIns="91440" bIns="45720" rtlCol="0"/>
+          <a:lstStyle>
+            <a:lvl1pPr algn="l">
+              <a:defRPr sz="1200"/>
+            </a:lvl1pPr>
+          </a:lstStyle>
+          <a:p>
+            <a:endParaRPr lang="en-US"/>
+          </a:p>
+        </p:txBody>
+      </p:sp>
+      <p:sp>
+        <p:nvSpPr>
+          <p:cNvPr id="3" name="Date Placeholder 2"/>
+          <p:cNvSpPr>
+            <a:spLocks noGrp="1"/>
+          </p:cNvSpPr>
+          <p:nvPr>
+            <p:ph type="dt" idx="1"/>
+          </p:nvPr>
+        </p:nvSpPr>
+        <p:spPr>
+          <a:xfrm>
+            <a:off x="3884613" y="0"/>
+            <a:ext cx="2971800" cy="457200"/>
+          </a:xfrm>
+          <a:prstGeom prst="rect">
+            <a:avLst/>
+          </a:prstGeom>
+        </p:spPr>
+        <p:txBody>
+          <a:bodyPr vert="horz" lIns="91440" tIns="45720" rIns="91440" bIns="45720" rtlCol="0"/>
+          <a:lstStyle>
+            <a:lvl1pPr algn="r">
+              <a:defRPr sz="1200"/>
+            </a:lvl1pPr>
+          </a:lstStyle>
+          <a:p>
+            <a:fld id="{0F89C1C7-3DCD-1040-A9CF-14679D8B5DDD}" type="datetimeFigureOut">
+              <a:rPr lang="en-US" smtClean="0"/>
+              <a:t>10/17/16</a:t>
+            </a:fld>
+            <a:endParaRPr lang="en-US"/>
+          </a:p>
+        </p:txBody>
+      </p:sp>
+      <p:sp>
+        <p:nvSpPr>
+          <p:cNvPr id="4" name="Slide Image Placeholder 3"/>
+          <p:cNvSpPr>
+            <a:spLocks noGrp="1" noRot="1" noChangeAspect="1"/>
+          </p:cNvSpPr>
+          <p:nvPr>
+            <p:ph type="sldImg" idx="2"/>
+          </p:nvPr>
+        </p:nvSpPr>
+        <p:spPr>
+          <a:xfrm>
+            <a:off x="1143000" y="685800"/>
+            <a:ext cx="4572000" cy="3429000"/>
+          </a:xfrm>
+          <a:prstGeom prst="rect">
+            <a:avLst/>
+          </a:prstGeom>
+          <a:noFill/>
+          <a:ln w="12700">
+            <a:solidFill>
+              <a:prstClr val="black"/>
+            </a:solidFill>
+          </a:ln>
+        </p:spPr>
+        <p:txBody>
+          <a:bodyPr vert="horz" lIns="91440" tIns="45720" rIns="91440" bIns="45720" rtlCol="0" anchor="ctr"/>
+          <a:lstStyle/>
+          <a:p>
+            <a:endParaRPr lang="en-US"/>
+          </a:p>
+        </p:txBody>
+      </p:sp>
+      <p:sp>
+        <p:nvSpPr>
+          <p:cNvPr id="5" name="Notes Placeholder 4"/>
+          <p:cNvSpPr>
+            <a:spLocks noGrp="1"/>
+          </p:cNvSpPr>
+          <p:nvPr>
+            <p:ph type="body" sz="quarter" idx="3"/>
+          </p:nvPr>
+        </p:nvSpPr>
+        <p:spPr>
+          <a:xfrm>
+            <a:off x="685800" y="4343400"/>
+            <a:ext cx="5486400" cy="4114800"/>
+          </a:xfrm>
+          <a:prstGeom prst="rect">
+            <a:avLst/>
+          </a:prstGeom>
+        </p:spPr>
+        <p:txBody>
+          <a:bodyPr vert="horz" lIns="91440" tIns="45720" rIns="91440" bIns="45720" rtlCol="0"/>
+          <a:lstStyle/>
+          <a:p>
+            <a:pPr lvl="0"/>
+            <a:r>
+              <a:rPr lang="en-US" smtClean="0"/>
+              <a:t>Click to edit Master text styles</a:t>
+            </a:r>
+          </a:p>
+          <a:p>
+            <a:pPr lvl="1"/>
+            <a:r>
+              <a:rPr lang="en-US" smtClean="0"/>
+              <a:t>Second level</a:t>
+            </a:r>
+          </a:p>
+          <a:p>
+            <a:pPr lvl="2"/>
+            <a:r>
+              <a:rPr lang="en-US" smtClean="0"/>
+              <a:t>Third level</a:t>
+            </a:r>
+          </a:p>
+          <a:p>
+            <a:pPr lvl="3"/>
+            <a:r>
+              <a:rPr lang="en-US" smtClean="0"/>
+              <a:t>Fourth level</a:t>
+            </a:r>
+          </a:p>
+          <a:p>
+            <a:pPr lvl="4"/>
+            <a:r>
+              <a:rPr lang="en-US" smtClean="0"/>
+              <a:t>Fifth level</a:t>
+            </a:r>
+            <a:endParaRPr lang="en-US"/>
+          </a:p>
+        </p:txBody>
+      </p:sp>
+      <p:sp>
+        <p:nvSpPr>
+          <p:cNvPr id="6" name="Footer Placeholder 5"/>
+          <p:cNvSpPr>
+            <a:spLocks noGrp="1"/>
+          </p:cNvSpPr>
+          <p:nvPr>
+            <p:ph type="ftr" sz="quarter" idx="4"/>
+          </p:nvPr>
+        </p:nvSpPr>
+        <p:spPr>
+          <a:xfrm>
+            <a:off x="0" y="8685213"/>
+            <a:ext cx="2971800" cy="457200"/>
+          </a:xfrm>
+          <a:prstGeom prst="rect">
+            <a:avLst/>
+          </a:prstGeom>
+        </p:spPr>
+        <p:txBody>
+          <a:bodyPr vert="horz" lIns="91440" tIns="45720" rIns="91440" bIns="45720" rtlCol="0" anchor="b"/>
+          <a:lstStyle>
+            <a:lvl1pPr algn="l">
+              <a:defRPr sz="1200"/>
+            </a:lvl1pPr>
+          </a:lstStyle>
+          <a:p>
+            <a:endParaRPr lang="en-US"/>
+          </a:p>
+        </p:txBody>
+      </p:sp>
+      <p:sp>
+        <p:nvSpPr>
+          <p:cNvPr id="7" name="Slide Number Placeholder 6"/>
+          <p:cNvSpPr>
+            <a:spLocks noGrp="1"/>
+          </p:cNvSpPr>
+          <p:nvPr>
+            <p:ph type="sldNum" sz="quarter" idx="5"/>
+          </p:nvPr>
+        </p:nvSpPr>
+        <p:spPr>
+          <a:xfrm>
+            <a:off x="3884613" y="8685213"/>
+            <a:ext cx="2971800" cy="457200"/>
+          </a:xfrm>
+          <a:prstGeom prst="rect">
+            <a:avLst/>
+          </a:prstGeom>
+        </p:spPr>
+        <p:txBody>
+          <a:bodyPr vert="horz" lIns="91440" tIns="45720" rIns="91440" bIns="45720" rtlCol="0" anchor="b"/>
+          <a:lstStyle>
+            <a:lvl1pPr algn="r">
+              <a:defRPr sz="1200"/>
+            </a:lvl1pPr>
+          </a:lstStyle>
+          <a:p>
+            <a:fld id="{BB5E49A5-4136-284D-997B-48E1D791AD67}" type="slidenum">
+              <a:rPr lang="en-US" smtClean="0"/>
+              <a:t>‹#›</a:t>
+            </a:fld>
+            <a:endParaRPr lang="en-US"/>
+          </a:p>
+        </p:txBody>
+      </p:sp>
+    </p:spTree>
+    <p:extLst>
+      <p:ext uri="{BB962C8B-B14F-4D97-AF65-F5344CB8AC3E}">
+        <p14:creationId xmlns:p14="http://schemas.microsoft.com/office/powerpoint/2010/main" val="2623252185"/>
+      </p:ext>
+    </p:extLst>
+  </p:cSld>
+  <p:clrMap bg1="lt1" tx1="dk1" bg2="lt2" tx2="dk2" accent1="accent1" accent2="accent2" accent3="accent3" accent4="accent4" accent5="accent5" accent6="accent6" hlink="hlink" folHlink="folHlink"/>
+  <p:notesStyle>
+    <a:lvl1pPr marL="0" algn="l" defTabSz="457200" rtl="0" eaLnBrk="1" latinLnBrk="0" hangingPunct="1">
+      <a:defRPr sz="1200" kern="1200">
+        <a:solidFill>
+          <a:schemeClr val="tx1"/>
+        </a:solidFill>
+        <a:latin typeface="+mn-lt"/>
+        <a:ea typeface="+mn-ea"/>
+        <a:cs typeface="+mn-cs"/>
+      </a:defRPr>
+    </a:lvl1pPr>
+    <a:lvl2pPr marL="457200" algn="l" defTabSz="457200" rtl="0" eaLnBrk="1" latinLnBrk="0" hangingPunct="1">
+      <a:defRPr sz="1200" kern="1200">
+        <a:solidFill>
+          <a:schemeClr val="tx1"/>
+        </a:solidFill>
+        <a:latin typeface="+mn-lt"/>
+        <a:ea typeface="+mn-ea"/>
+        <a:cs typeface="+mn-cs"/>
+      </a:defRPr>
+    </a:lvl2pPr>
+    <a:lvl3pPr marL="914400" algn="l" defTabSz="457200" rtl="0" eaLnBrk="1" latinLnBrk="0" hangingPunct="1">
+      <a:defRPr sz="1200" kern="1200">
+        <a:solidFill>
+          <a:schemeClr val="tx1"/>
+        </a:solidFill>
+        <a:latin typeface="+mn-lt"/>
+        <a:ea typeface="+mn-ea"/>
+        <a:cs typeface="+mn-cs"/>
+      </a:defRPr>
+    </a:lvl3pPr>
+    <a:lvl4pPr marL="1371600" algn="l" defTabSz="457200" rtl="0" eaLnBrk="1" latinLnBrk="0" hangingPunct="1">
+      <a:defRPr sz="1200" kern="1200">
+        <a:solidFill>
+          <a:schemeClr val="tx1"/>
+        </a:solidFill>
+        <a:latin typeface="+mn-lt"/>
+        <a:ea typeface="+mn-ea"/>
+        <a:cs typeface="+mn-cs"/>
+      </a:defRPr>
+    </a:lvl4pPr>
+    <a:lvl5pPr marL="1828800" algn="l" defTabSz="457200" rtl="0" eaLnBrk="1" latinLnBrk="0" hangingPunct="1">
+      <a:defRPr sz="1200" kern="1200">
+        <a:solidFill>
+          <a:schemeClr val="tx1"/>
+        </a:solidFill>
+        <a:latin typeface="+mn-lt"/>
+        <a:ea typeface="+mn-ea"/>
+        <a:cs typeface="+mn-cs"/>
+      </a:defRPr>
+    </a:lvl5pPr>
+    <a:lvl6pPr marL="2286000" algn="l" defTabSz="457200" rtl="0" eaLnBrk="1" latinLnBrk="0" hangingPunct="1">
+      <a:defRPr sz="1200" kern="1200">
+        <a:solidFill>
+          <a:schemeClr val="tx1"/>
+        </a:solidFill>
+        <a:latin typeface="+mn-lt"/>
+        <a:ea typeface="+mn-ea"/>
+        <a:cs typeface="+mn-cs"/>
+      </a:defRPr>
+    </a:lvl6pPr>
+    <a:lvl7pPr marL="2743200" algn="l" defTabSz="457200" rtl="0" eaLnBrk="1" latinLnBrk="0" hangingPunct="1">
+      <a:defRPr sz="1200" kern="1200">
+        <a:solidFill>
+          <a:schemeClr val="tx1"/>
+        </a:solidFill>
+        <a:latin typeface="+mn-lt"/>
+        <a:ea typeface="+mn-ea"/>
+        <a:cs typeface="+mn-cs"/>
+      </a:defRPr>
+    </a:lvl7pPr>
+    <a:lvl8pPr marL="3200400" algn="l" defTabSz="457200" rtl="0" eaLnBrk="1" latinLnBrk="0" hangingPunct="1">
+      <a:defRPr sz="1200" kern="1200">
+        <a:solidFill>
+          <a:schemeClr val="tx1"/>
+        </a:solidFill>
+        <a:latin typeface="+mn-lt"/>
+        <a:ea typeface="+mn-ea"/>
+        <a:cs typeface="+mn-cs"/>
+      </a:defRPr>
+    </a:lvl8pPr>
+    <a:lvl9pPr marL="3657600" algn="l" defTabSz="457200" rtl="0" eaLnBrk="1" latinLnBrk="0" hangingPunct="1">
+      <a:defRPr sz="1200" kern="1200">
+        <a:solidFill>
+          <a:schemeClr val="tx1"/>
+        </a:solidFill>
+        <a:latin typeface="+mn-lt"/>
+        <a:ea typeface="+mn-ea"/>
+        <a:cs typeface="+mn-cs"/>
+      </a:defRPr>
+    </a:lvl9pPr>
+  </p:notesStyle>
+</p:notesMaster>
+</file>
+
+<file path=ppt/notesSlides/notesSlide1.xml><?xml version="1.0" encoding="utf-8"?>
+<p:notes xmlns:a="http://schemas.openxmlformats.org/drawingml/2006/main" xmlns:p="http://schemas.openxmlformats.org/presentationml/2006/main" xmlns:r="http://schemas.openxmlformats.org/officeDocument/2006/relationships">
+  <p:cSld>
+    <p:spTree>
+      <p:nvGrpSpPr>
+        <p:cNvPr id="1" name=""/>
+        <p:cNvGrpSpPr/>
+        <p:nvPr/>
+      </p:nvGrpSpPr>
+      <p:grpSpPr>
+        <a:xfrm>
+          <a:off x="0" y="0"/>
+          <a:ext cx="0" cy="0"/>
+          <a:chOff x="0" y="0"/>
+          <a:chExt cx="0" cy="0"/>
+        </a:xfrm>
+      </p:grpSpPr>
+      <p:sp>
+        <p:nvSpPr>
+          <p:cNvPr id="2" name="Slide Image Placeholder 1"/>
+          <p:cNvSpPr>
+            <a:spLocks noGrp="1"/>
+          </p:cNvSpPr>
+          <p:nvPr>
+            <p:ph type="sldImg" idx="2"/>
+          </p:nvPr>
+        </p:nvSpPr>
+        <p:spPr/>
+      </p:sp>
+      <p:sp>
+        <p:nvSpPr>
+          <p:cNvPr id="3" name="Notes Placeholder 2"/>
+          <p:cNvSpPr>
+            <a:spLocks noGrp="1"/>
+          </p:cNvSpPr>
+          <p:nvPr>
+            <p:ph type="body" idx="3" sz="quarter"/>
+          </p:nvPr>
+        </p:nvSpPr>
+        <p:spPr/>
+        <p:txBody>
+          <a:bodyPr/>
+          <a:lstStyle/>
+          <a:p/>
+          <a:p/>
+          <a:p>
+            <a:r>
+              <a:t>[Practice — moved to notes, no room on slide]</a:t>
+            </a:r>
+          </a:p>
+          <a:p>
+            <a:r>
+              <a:t>• Listen and repeat three times: สวัสดี, สวัสดีครับ, สวัสดีค่ะ.</a:t>
+            </a:r>
+          </a:p>
+          <a:p>
+            <a:r>
+              <a:t>• Your turn: I will point to a male or female role. Say the correct full greeting aloud before I show the answer.</a:t>
+            </a:r>
+          </a:p>
+          <a:p>
+            <a:r>
+              <a:t>• Substitution drill: replace the ending — say สวัสดี with ครับ, now with ค่ะ.</a:t>
+            </a:r>
+          </a:p>
+          <a:p/>
+        </p:txBody>
+      </p:sp>
+      <p:sp>
+        <p:nvSpPr>
+          <p:cNvPr id="4" name="Slide Number Placeholder 3"/>
+          <p:cNvSpPr>
+            <a:spLocks noGrp="1"/>
+          </p:cNvSpPr>
+          <p:nvPr>
+            <p:ph type="sldNum" idx="5" sz="quarter"/>
+          </p:nvPr>
+        </p:nvSpPr>
+        <p:spPr/>
+      </p:sp>
+    </p:spTree>
+  </p:cSld>
+  <p:clrMapOvr>
+    <a:masterClrMapping/>
+  </p:clrMapOvr>
+</p:notes>
+</file>
+
+<file path=ppt/notesSlides/notesSlide2.xml><?xml version="1.0" encoding="utf-8"?>
+<p:notes xmlns:a="http://schemas.openxmlformats.org/drawingml/2006/main" xmlns:p="http://schemas.openxmlformats.org/presentationml/2006/main" xmlns:r="http://schemas.openxmlformats.org/officeDocument/2006/relationships">
+  <p:cSld>
+    <p:spTree>
+      <p:nvGrpSpPr>
+        <p:cNvPr id="1" name=""/>
+        <p:cNvGrpSpPr/>
+        <p:nvPr/>
+      </p:nvGrpSpPr>
+      <p:grpSpPr>
+        <a:xfrm>
+          <a:off x="0" y="0"/>
+          <a:ext cx="0" cy="0"/>
+          <a:chOff x="0" y="0"/>
+          <a:chExt cx="0" cy="0"/>
+        </a:xfrm>
+      </p:grpSpPr>
+      <p:sp>
+        <p:nvSpPr>
+          <p:cNvPr id="2" name="Slide Image Placeholder 1"/>
+          <p:cNvSpPr>
+            <a:spLocks noGrp="1"/>
+          </p:cNvSpPr>
+          <p:nvPr>
+            <p:ph type="sldImg" idx="2"/>
+          </p:nvPr>
+        </p:nvSpPr>
+        <p:spPr/>
+      </p:sp>
+      <p:sp>
+        <p:nvSpPr>
+          <p:cNvPr id="3" name="Notes Placeholder 2"/>
+          <p:cNvSpPr>
+            <a:spLocks noGrp="1"/>
+          </p:cNvSpPr>
+          <p:nvPr>
+            <p:ph type="body" idx="3" sz="quarter"/>
+          </p:nvPr>
+        </p:nvSpPr>
+        <p:spPr/>
+        <p:txBody>
+          <a:bodyPr/>
+          <a:lstStyle/>
+          <a:p/>
+          <a:p/>
+          <a:p>
+            <a:r>
+              <a:t>[Practice — moved to notes, no room on slide]</a:t>
+            </a:r>
+          </a:p>
+          <a:p>
+            <a:r>
+              <a:t>• Discrimination drill: I describe a situation. Choose ขอบคุณ or ขอโทษ — which one fits? Say it aloud.</a:t>
+            </a:r>
+          </a:p>
+          <a:p>
+            <a:r>
+              <a:t>• Response-building drill: I say ขอโทษครับ. Your turn — what do you say back? Pause and answer before I show it.</a:t>
+            </a:r>
+          </a:p>
+          <a:p>
+            <a:r>
+              <a:t>• Substitution drill: say ขอบคุณ with ครับ, now with ค่ะ. Now say ขอโทษ with ครับ, now with ค่ะ.</a:t>
+            </a:r>
+          </a:p>
+          <a:p/>
+        </p:txBody>
+      </p:sp>
+      <p:sp>
+        <p:nvSpPr>
+          <p:cNvPr id="4" name="Slide Number Placeholder 3"/>
+          <p:cNvSpPr>
+            <a:spLocks noGrp="1"/>
+          </p:cNvSpPr>
+          <p:nvPr>
+            <p:ph type="sldNum" idx="5" sz="quarter"/>
+          </p:nvPr>
+        </p:nvSpPr>
+        <p:spPr/>
+      </p:sp>
+    </p:spTree>
+  </p:cSld>
+  <p:clrMapOvr>
+    <a:masterClrMapping/>
+  </p:clrMapOvr>
+</p:notes>
+</file>
+
+<file path=ppt/notesSlides/notesSlide3.xml><?xml version="1.0" encoding="utf-8"?>
+<p:notes xmlns:a="http://schemas.openxmlformats.org/drawingml/2006/main" xmlns:p="http://schemas.openxmlformats.org/presentationml/2006/main" xmlns:r="http://schemas.openxmlformats.org/officeDocument/2006/relationships">
+  <p:cSld>
+    <p:spTree>
+      <p:nvGrpSpPr>
+        <p:cNvPr id="1" name=""/>
+        <p:cNvGrpSpPr/>
+        <p:nvPr/>
+      </p:nvGrpSpPr>
+      <p:grpSpPr>
+        <a:xfrm>
+          <a:off x="0" y="0"/>
+          <a:ext cx="0" cy="0"/>
+          <a:chOff x="0" y="0"/>
+          <a:chExt cx="0" cy="0"/>
+        </a:xfrm>
+      </p:grpSpPr>
+      <p:sp>
+        <p:nvSpPr>
+          <p:cNvPr id="2" name="Slide Image Placeholder 1"/>
+          <p:cNvSpPr>
+            <a:spLocks noGrp="1"/>
+          </p:cNvSpPr>
+          <p:nvPr>
+            <p:ph type="sldImg" idx="2"/>
+          </p:nvPr>
+        </p:nvSpPr>
+        <p:spPr/>
+      </p:sp>
+      <p:sp>
+        <p:nvSpPr>
+          <p:cNvPr id="3" name="Notes Placeholder 2"/>
+          <p:cNvSpPr>
+            <a:spLocks noGrp="1"/>
+          </p:cNvSpPr>
+          <p:nvPr>
+            <p:ph type="body" idx="3" sz="quarter"/>
+          </p:nvPr>
+        </p:nvSpPr>
+        <p:spPr/>
+        <p:txBody>
+          <a:bodyPr/>
+          <a:lstStyle/>
+          <a:p/>
+          <a:p/>
+          <a:p>
+            <a:r>
+              <a:t>[Practice — moved to notes, no room on slide]</a:t>
+            </a:r>
+          </a:p>
+          <a:p>
+            <a:r>
+              <a:t>• Substitution drill: I say a bare phrase. You add the correct polite ending. สวัสดี — your turn. ขอบคุณ — your turn. ขอโทษ — your turn.</a:t>
+            </a:r>
+          </a:p>
+          <a:p>
+            <a:r>
+              <a:t>• Discrimination drill: I say ค่ะ or คะ. Is the speaker making a statement or asking a question? Choose before I tell you.</a:t>
+            </a:r>
+          </a:p>
+          <a:p>
+            <a:r>
+              <a:t>• Substitution drill round 2: now try it with ไม่เป็นไร and ใช่. Add ครับ or ค่ะ.</a:t>
+            </a:r>
+          </a:p>
+          <a:p/>
+        </p:txBody>
+      </p:sp>
+      <p:sp>
+        <p:nvSpPr>
+          <p:cNvPr id="4" name="Slide Number Placeholder 3"/>
+          <p:cNvSpPr>
+            <a:spLocks noGrp="1"/>
+          </p:cNvSpPr>
+          <p:nvPr>
+            <p:ph type="sldNum" idx="5" sz="quarter"/>
+          </p:nvPr>
+        </p:nvSpPr>
+        <p:spPr/>
+      </p:sp>
+    </p:spTree>
+  </p:cSld>
+  <p:clrMapOvr>
+    <a:masterClrMapping/>
+  </p:clrMapOvr>
+</p:notes>
+</file>
+
+<file path=ppt/notesSlides/notesSlide4.xml><?xml version="1.0" encoding="utf-8"?>
+<p:notes xmlns:a="http://schemas.openxmlformats.org/drawingml/2006/main" xmlns:p="http://schemas.openxmlformats.org/presentationml/2006/main" xmlns:r="http://schemas.openxmlformats.org/officeDocument/2006/relationships">
+  <p:cSld>
+    <p:spTree>
+      <p:nvGrpSpPr>
+        <p:cNvPr id="1" name=""/>
+        <p:cNvGrpSpPr/>
+        <p:nvPr/>
+      </p:nvGrpSpPr>
+      <p:grpSpPr>
+        <a:xfrm>
+          <a:off x="0" y="0"/>
+          <a:ext cx="0" cy="0"/>
+          <a:chOff x="0" y="0"/>
+          <a:chExt cx="0" cy="0"/>
+        </a:xfrm>
+      </p:grpSpPr>
+      <p:sp>
+        <p:nvSpPr>
+          <p:cNvPr id="2" name="Slide Image Placeholder 1"/>
+          <p:cNvSpPr>
+            <a:spLocks noGrp="1"/>
+          </p:cNvSpPr>
+          <p:nvPr>
+            <p:ph type="sldImg" idx="2"/>
+          </p:nvPr>
+        </p:nvSpPr>
+        <p:spPr/>
+      </p:sp>
+      <p:sp>
+        <p:nvSpPr>
+          <p:cNvPr id="3" name="Notes Placeholder 2"/>
+          <p:cNvSpPr>
+            <a:spLocks noGrp="1"/>
+          </p:cNvSpPr>
+          <p:nvPr>
+            <p:ph type="body" idx="3" sz="quarter"/>
+          </p:nvPr>
+        </p:nvSpPr>
+        <p:spPr/>
+        <p:txBody>
+          <a:bodyPr/>
+          <a:lstStyle/>
+          <a:p/>
+          <a:p/>
+          <a:p>
+            <a:r>
+              <a:t>[Practice — moved to notes, no room on slide]</a:t>
+            </a:r>
+          </a:p>
+          <a:p>
+            <a:r>
+              <a:t>• Pause-and-produce: I ask a yes/no question. Say ใช่ or ไม่ใช่ before I show the answer.</a:t>
+            </a:r>
+          </a:p>
+          <a:p>
+            <a:r>
+              <a:t>• Response-building: I say ขอโทษครับ. What do you say back? Then I say ขอบคุณค่ะ. What do you say back?</a:t>
+            </a:r>
+          </a:p>
+          <a:p>
+            <a:r>
+              <a:t>• Substitution drill: say ใช่ with ครับ, now with ค่ะ. Say ไม่ใช่ with ครับ, now with ค่ะ.</a:t>
+            </a:r>
+          </a:p>
+          <a:p/>
+        </p:txBody>
+      </p:sp>
+      <p:sp>
+        <p:nvSpPr>
+          <p:cNvPr id="4" name="Slide Number Placeholder 3"/>
+          <p:cNvSpPr>
+            <a:spLocks noGrp="1"/>
+          </p:cNvSpPr>
+          <p:nvPr>
+            <p:ph type="sldNum" idx="5" sz="quarter"/>
+          </p:nvPr>
+        </p:nvSpPr>
+        <p:spPr/>
+      </p:sp>
+    </p:spTree>
+  </p:cSld>
+  <p:clrMapOvr>
+    <a:masterClrMapping/>
+  </p:clrMapOvr>
+</p:notes>
+</file>
+
+<file path=ppt/notesSlides/notesSlide5.xml><?xml version="1.0" encoding="utf-8"?>
+<p:notes xmlns:a="http://schemas.openxmlformats.org/drawingml/2006/main" xmlns:p="http://schemas.openxmlformats.org/presentationml/2006/main" xmlns:r="http://schemas.openxmlformats.org/officeDocument/2006/relationships">
+  <p:cSld>
+    <p:spTree>
+      <p:nvGrpSpPr>
+        <p:cNvPr id="1" name=""/>
+        <p:cNvGrpSpPr/>
+        <p:nvPr/>
+      </p:nvGrpSpPr>
+      <p:grpSpPr>
+        <a:xfrm>
+          <a:off x="0" y="0"/>
+          <a:ext cx="0" cy="0"/>
+          <a:chOff x="0" y="0"/>
+          <a:chExt cx="0" cy="0"/>
+        </a:xfrm>
+      </p:grpSpPr>
+      <p:sp>
+        <p:nvSpPr>
+          <p:cNvPr id="2" name="Slide Image Placeholder 1"/>
+          <p:cNvSpPr>
+            <a:spLocks noGrp="1"/>
+          </p:cNvSpPr>
+          <p:nvPr>
+            <p:ph type="sldImg" idx="2"/>
+          </p:nvPr>
+        </p:nvSpPr>
+        <p:spPr/>
+      </p:sp>
+      <p:sp>
+        <p:nvSpPr>
+          <p:cNvPr id="3" name="Notes Placeholder 2"/>
+          <p:cNvSpPr>
+            <a:spLocks noGrp="1"/>
+          </p:cNvSpPr>
+          <p:nvPr>
+            <p:ph type="body" idx="3" sz="quarter"/>
+          </p:nvPr>
+        </p:nvSpPr>
+        <p:spPr/>
+        <p:txBody>
+          <a:bodyPr/>
+          <a:lstStyle/>
+          <a:p/>
+          <a:p/>
+          <a:p>
+            <a:r>
+              <a:t>[Practice — moved to notes, no room on slide]</a:t>
+            </a:r>
+          </a:p>
+          <a:p>
+            <a:r>
+              <a:t>• Tone echo: I say ครับ khráp. Repeat it. Now I say ค่ะ khâ. Repeat it. Can you feel the difference?</a:t>
+            </a:r>
+          </a:p>
+          <a:p>
+            <a:r>
+              <a:t>• Minimal pair choice: I say two words. Which one is ครับ and which is ค่ะ? Point to the answer.</a:t>
+            </a:r>
+          </a:p>
+          <a:p/>
+        </p:txBody>
+      </p:sp>
+      <p:sp>
+        <p:nvSpPr>
+          <p:cNvPr id="4" name="Slide Number Placeholder 3"/>
+          <p:cNvSpPr>
+            <a:spLocks noGrp="1"/>
+          </p:cNvSpPr>
+          <p:nvPr>
+            <p:ph type="sldNum" idx="5" sz="quarter"/>
+          </p:nvPr>
+        </p:nvSpPr>
+        <p:spPr/>
+      </p:sp>
+    </p:spTree>
+  </p:cSld>
+  <p:clrMapOvr>
+    <a:masterClrMapping/>
+  </p:clrMapOvr>
+</p:notes>
 </file>
 
 <file path=ppt/slideLayouts/slideLayout1.xml><?xml version="1.0" encoding="utf-8"?>
@@ -5314,222 +6099,6 @@
           </a:p>
         </p:txBody>
       </p:sp>
-      <p:sp>
-        <p:nvSpPr>
-          <p:cNvPr id="18" name="TextBox 17"/>
-          <p:cNvSpPr txBox="1"/>
-          <p:nvPr/>
-        </p:nvSpPr>
-        <p:spPr>
-          <a:xfrm>
-            <a:off x="932688" y="6876288"/>
-            <a:ext cx="9692640" cy="228600"/>
-          </a:xfrm>
-          <a:prstGeom prst="rect">
-            <a:avLst/>
-          </a:prstGeom>
-          <a:noFill/>
-        </p:spPr>
-        <p:txBody>
-          <a:bodyPr wrap="square" anchor="t">
-            <a:spAutoFit/>
-          </a:bodyPr>
-          <a:lstStyle/>
-          <a:p>
-            <a:pPr algn="l"/>
-            <a:r>
-              <a:rPr sz="1700" b="1" i="0" lang="en-US" altLang="en-US">
-                <a:solidFill>
-                  <a:srgbClr val="C96F4A"/>
-                </a:solidFill>
-                <a:latin typeface="Sarabun"/>
-                <a:ea typeface="Sarabun"/>
-                <a:cs typeface="Sarabun"/>
-              </a:rPr>
-              <a:t>Practice</a:t>
-            </a:r>
-          </a:p>
-        </p:txBody>
-      </p:sp>
-      <p:sp>
-        <p:nvSpPr>
-          <p:cNvPr id="19" name="Oval 18"/>
-          <p:cNvSpPr/>
-          <p:nvPr/>
-        </p:nvSpPr>
-        <p:spPr>
-          <a:xfrm>
-            <a:off x="932688" y="7260336"/>
-            <a:ext cx="82296" cy="82296"/>
-          </a:xfrm>
-          <a:prstGeom prst="ellipse">
-            <a:avLst/>
-          </a:prstGeom>
-          <a:solidFill>
-            <a:srgbClr val="C96F4A"/>
-          </a:solidFill>
-          <a:ln>
-            <a:noFill/>
-          </a:ln>
-        </p:spPr>
-        <p:style>
-          <a:lnRef idx="1">
-            <a:schemeClr val="accent1"/>
-          </a:lnRef>
-          <a:fillRef idx="3">
-            <a:schemeClr val="accent1"/>
-          </a:fillRef>
-          <a:effectRef idx="2">
-            <a:schemeClr val="accent1"/>
-          </a:effectRef>
-          <a:fontRef idx="minor">
-            <a:schemeClr val="lt1"/>
-          </a:fontRef>
-        </p:style>
-        <p:txBody>
-          <a:bodyPr rtlCol="0" anchor="ctr"/>
-          <a:lstStyle/>
-          <a:p>
-            <a:pPr algn="ctr"/>
-          </a:p>
-        </p:txBody>
-      </p:sp>
-      <p:sp>
-        <p:nvSpPr>
-          <p:cNvPr id="20" name="TextBox 19"/>
-          <p:cNvSpPr txBox="1"/>
-          <p:nvPr/>
-        </p:nvSpPr>
-        <p:spPr>
-          <a:xfrm>
-            <a:off x="1078992" y="7168896"/>
-            <a:ext cx="9555480" cy="274320"/>
-          </a:xfrm>
-          <a:prstGeom prst="rect">
-            <a:avLst/>
-          </a:prstGeom>
-          <a:noFill/>
-        </p:spPr>
-        <p:txBody>
-          <a:bodyPr wrap="square" anchor="t">
-            <a:spAutoFit/>
-          </a:bodyPr>
-          <a:lstStyle/>
-          <a:p>
-            <a:pPr algn="l"/>
-            <a:r>
-              <a:rPr sz="1700" b="0" i="0" lang="en-US" altLang="en-US">
-                <a:solidFill>
-                  <a:srgbClr val="24333D"/>
-                </a:solidFill>
-                <a:latin typeface="Sarabun"/>
-                <a:ea typeface="Sarabun"/>
-                <a:cs typeface="Sarabun"/>
-              </a:rPr>
-              <a:t>Listen and repeat three times: </a:t>
-            </a:r>
-            <a:r>
-              <a:rPr sz="1700" b="0" i="0" lang="th-TH" altLang="en-US">
-                <a:solidFill>
-                  <a:srgbClr val="24333D"/>
-                </a:solidFill>
-                <a:latin typeface="Sarabun"/>
-                <a:ea typeface="Sarabun"/>
-                <a:cs typeface="Sarabun"/>
-              </a:rPr>
-              <a:t>สวัสดี</a:t>
-            </a:r>
-            <a:r>
-              <a:rPr sz="1700" b="0" i="1" lang="en-US" altLang="en-US">
-                <a:solidFill>
-                  <a:srgbClr val="566873"/>
-                </a:solidFill>
-                <a:latin typeface="Sarabun"/>
-                <a:ea typeface="Sarabun"/>
-                <a:cs typeface="Sarabun"/>
-              </a:rPr>
-              <a:t> (sà-wàt-dii)</a:t>
-            </a:r>
-            <a:r>
-              <a:rPr sz="1700" b="0" i="0" lang="en-US" altLang="en-US">
-                <a:solidFill>
-                  <a:srgbClr val="24333D"/>
-                </a:solidFill>
-                <a:latin typeface="Sarabun"/>
-                <a:ea typeface="Sarabun"/>
-                <a:cs typeface="Sarabun"/>
-              </a:rPr>
-              <a:t>, </a:t>
-            </a:r>
-            <a:r>
-              <a:rPr sz="1700" b="0" i="0" lang="th-TH" altLang="en-US">
-                <a:solidFill>
-                  <a:srgbClr val="24333D"/>
-                </a:solidFill>
-                <a:latin typeface="Sarabun"/>
-                <a:ea typeface="Sarabun"/>
-                <a:cs typeface="Sarabun"/>
-              </a:rPr>
-              <a:t>สวัสดีครับ</a:t>
-            </a:r>
-            <a:r>
-              <a:rPr sz="1700" b="0" i="1" lang="en-US" altLang="en-US">
-                <a:solidFill>
-                  <a:srgbClr val="566873"/>
-                </a:solidFill>
-                <a:latin typeface="Sarabun"/>
-                <a:ea typeface="Sarabun"/>
-                <a:cs typeface="Sarabun"/>
-              </a:rPr>
-              <a:t> (sà-wàt-dii khráp)</a:t>
-            </a:r>
-            <a:r>
-              <a:rPr sz="1700" b="0" i="0" lang="en-US" altLang="en-US">
-                <a:solidFill>
-                  <a:srgbClr val="24333D"/>
-                </a:solidFill>
-                <a:latin typeface="Sarabun"/>
-                <a:ea typeface="Sarabun"/>
-                <a:cs typeface="Sarabun"/>
-              </a:rPr>
-              <a:t>, </a:t>
-            </a:r>
-            <a:r>
-              <a:rPr sz="1700" b="0" i="0" lang="th-TH" altLang="en-US">
-                <a:solidFill>
-                  <a:srgbClr val="24333D"/>
-                </a:solidFill>
-                <a:latin typeface="Sarabun"/>
-                <a:ea typeface="Sarabun"/>
-                <a:cs typeface="Sarabun"/>
-              </a:rPr>
-              <a:t>สวัสดีค่ะ</a:t>
-            </a:r>
-            <a:r>
-              <a:rPr sz="1700" b="0" i="1" lang="en-US" altLang="en-US">
-                <a:solidFill>
-                  <a:srgbClr val="566873"/>
-                </a:solidFill>
-                <a:latin typeface="Sarabun"/>
-                <a:ea typeface="Sarabun"/>
-                <a:cs typeface="Sarabun"/>
-              </a:rPr>
-              <a:t> (sà-wàt-dii khâ)</a:t>
-            </a:r>
-            <a:r>
-              <a:rPr sz="1700" b="0" i="0" lang="en-US" altLang="en-US">
-                <a:solidFill>
-                  <a:srgbClr val="24333D"/>
-                </a:solidFill>
-                <a:latin typeface="Sarabun"/>
-                <a:ea typeface="Sarabun"/>
-                <a:cs typeface="Sarabun"/>
-              </a:rPr>
-              <a:t>.</a:t>
-            </a:r>
-          </a:p>
-        </p:txBody>
-      </p:sp>
     </p:spTree>
   </p:cSld>
   <p:clrMapOvr>
@@ -6237,189 +6806,6 @@
           </a:p>
         </p:txBody>
       </p:sp>
-      <p:sp>
-        <p:nvSpPr>
-          <p:cNvPr id="18" name="TextBox 17"/>
-          <p:cNvSpPr txBox="1"/>
-          <p:nvPr/>
-        </p:nvSpPr>
-        <p:spPr>
-          <a:xfrm>
-            <a:off x="932688" y="6876288"/>
-            <a:ext cx="9692640" cy="228600"/>
-          </a:xfrm>
-          <a:prstGeom prst="rect">
-            <a:avLst/>
-          </a:prstGeom>
-          <a:noFill/>
-        </p:spPr>
-        <p:txBody>
-          <a:bodyPr wrap="square" anchor="t">
-            <a:spAutoFit/>
-          </a:bodyPr>
-          <a:lstStyle/>
-          <a:p>
-            <a:pPr algn="l"/>
-            <a:r>
-              <a:rPr sz="1700" b="1" i="0" lang="en-US" altLang="en-US">
-                <a:solidFill>
-                  <a:srgbClr val="C96F4A"/>
-                </a:solidFill>
-                <a:latin typeface="Sarabun"/>
-                <a:ea typeface="Sarabun"/>
-                <a:cs typeface="Sarabun"/>
-              </a:rPr>
-              <a:t>Practice</a:t>
-            </a:r>
-          </a:p>
-        </p:txBody>
-      </p:sp>
-      <p:sp>
-        <p:nvSpPr>
-          <p:cNvPr id="19" name="Oval 18"/>
-          <p:cNvSpPr/>
-          <p:nvPr/>
-        </p:nvSpPr>
-        <p:spPr>
-          <a:xfrm>
-            <a:off x="932688" y="7260336"/>
-            <a:ext cx="82296" cy="82296"/>
-          </a:xfrm>
-          <a:prstGeom prst="ellipse">
-            <a:avLst/>
-          </a:prstGeom>
-          <a:solidFill>
-            <a:srgbClr val="C96F4A"/>
-          </a:solidFill>
-          <a:ln>
-            <a:noFill/>
-          </a:ln>
-        </p:spPr>
-        <p:style>
-          <a:lnRef idx="1">
-            <a:schemeClr val="accent1"/>
-          </a:lnRef>
-          <a:fillRef idx="3">
-            <a:schemeClr val="accent1"/>
-          </a:fillRef>
-          <a:effectRef idx="2">
-            <a:schemeClr val="accent1"/>
-          </a:effectRef>
-          <a:fontRef idx="minor">
-            <a:schemeClr val="lt1"/>
-          </a:fontRef>
-        </p:style>
-        <p:txBody>
-          <a:bodyPr rtlCol="0" anchor="ctr"/>
-          <a:lstStyle/>
-          <a:p>
-            <a:pPr algn="ctr"/>
-          </a:p>
-        </p:txBody>
-      </p:sp>
-      <p:sp>
-        <p:nvSpPr>
-          <p:cNvPr id="20" name="TextBox 19"/>
-          <p:cNvSpPr txBox="1"/>
-          <p:nvPr/>
-        </p:nvSpPr>
-        <p:spPr>
-          <a:xfrm>
-            <a:off x="1078992" y="7168896"/>
-            <a:ext cx="9555480" cy="274320"/>
-          </a:xfrm>
-          <a:prstGeom prst="rect">
-            <a:avLst/>
-          </a:prstGeom>
-          <a:noFill/>
-        </p:spPr>
-        <p:txBody>
-          <a:bodyPr wrap="square" anchor="t">
-            <a:spAutoFit/>
-          </a:bodyPr>
-          <a:lstStyle/>
-          <a:p>
-            <a:pPr algn="l"/>
-            <a:r>
-              <a:rPr sz="1700" b="0" i="0" lang="en-US" altLang="en-US">
-                <a:solidFill>
-                  <a:srgbClr val="24333D"/>
-                </a:solidFill>
-                <a:latin typeface="Sarabun"/>
-                <a:ea typeface="Sarabun"/>
-                <a:cs typeface="Sarabun"/>
-              </a:rPr>
-              <a:t>Discrimination drill: I describe a situation. Choose </a:t>
-            </a:r>
-            <a:r>
-              <a:rPr sz="1700" b="0" i="0" lang="th-TH" altLang="en-US">
-                <a:solidFill>
-                  <a:srgbClr val="24333D"/>
-                </a:solidFill>
-                <a:latin typeface="Sarabun"/>
-                <a:ea typeface="Sarabun"/>
-                <a:cs typeface="Sarabun"/>
-              </a:rPr>
-              <a:t>ขอบคุณ</a:t>
-            </a:r>
-            <a:r>
-              <a:rPr sz="1700" b="0" i="1" lang="en-US" altLang="en-US">
-                <a:solidFill>
-                  <a:srgbClr val="566873"/>
-                </a:solidFill>
-                <a:latin typeface="Sarabun"/>
-                <a:ea typeface="Sarabun"/>
-                <a:cs typeface="Sarabun"/>
-              </a:rPr>
-              <a:t> (khàawp-khun)</a:t>
-            </a:r>
-            <a:r>
-              <a:rPr sz="1700" b="0" i="0" lang="en-US" altLang="en-US">
-                <a:solidFill>
-                  <a:srgbClr val="24333D"/>
-                </a:solidFill>
-                <a:latin typeface="Sarabun"/>
-                <a:ea typeface="Sarabun"/>
-                <a:cs typeface="Sarabun"/>
-              </a:rPr>
-              <a:t> or </a:t>
-            </a:r>
-            <a:r>
-              <a:rPr sz="1700" b="0" i="0" lang="th-TH" altLang="en-US">
-                <a:solidFill>
-                  <a:srgbClr val="24333D"/>
-                </a:solidFill>
-                <a:latin typeface="Sarabun"/>
-                <a:ea typeface="Sarabun"/>
-                <a:cs typeface="Sarabun"/>
-              </a:rPr>
-              <a:t>ขอโทษ</a:t>
-            </a:r>
-            <a:r>
-              <a:rPr sz="1700" b="0" i="1" lang="en-US" altLang="en-US">
-                <a:solidFill>
-                  <a:srgbClr val="566873"/>
-                </a:solidFill>
-                <a:latin typeface="Sarabun"/>
-                <a:ea typeface="Sarabun"/>
-                <a:cs typeface="Sarabun"/>
-              </a:rPr>
-              <a:t> (khǎaw-thôot)</a:t>
-            </a:r>
-            <a:r>
-              <a:rPr sz="1700" b="0" i="0" lang="en-US" altLang="en-US">
-                <a:solidFill>
-                  <a:srgbClr val="24333D"/>
-                </a:solidFill>
-                <a:latin typeface="Sarabun"/>
-                <a:ea typeface="Sarabun"/>
-                <a:cs typeface="Sarabun"/>
-              </a:rPr>
-              <a:t> — which one fits? Say it aloud.</a:t>
-            </a:r>
-          </a:p>
-        </p:txBody>
-      </p:sp>
     </p:spTree>
   </p:cSld>
   <p:clrMapOvr>
@@ -7127,222 +7513,6 @@
           </a:p>
         </p:txBody>
       </p:sp>
-      <p:sp>
-        <p:nvSpPr>
-          <p:cNvPr id="18" name="TextBox 17"/>
-          <p:cNvSpPr txBox="1"/>
-          <p:nvPr/>
-        </p:nvSpPr>
-        <p:spPr>
-          <a:xfrm>
-            <a:off x="932688" y="6876288"/>
-            <a:ext cx="9692640" cy="228600"/>
-          </a:xfrm>
-          <a:prstGeom prst="rect">
-            <a:avLst/>
-          </a:prstGeom>
-          <a:noFill/>
-        </p:spPr>
-        <p:txBody>
-          <a:bodyPr wrap="square" anchor="t">
-            <a:spAutoFit/>
-          </a:bodyPr>
-          <a:lstStyle/>
-          <a:p>
-            <a:pPr algn="l"/>
-            <a:r>
-              <a:rPr sz="1700" b="1" i="0" lang="en-US" altLang="en-US">
-                <a:solidFill>
-                  <a:srgbClr val="C96F4A"/>
-                </a:solidFill>
-                <a:latin typeface="Sarabun"/>
-                <a:ea typeface="Sarabun"/>
-                <a:cs typeface="Sarabun"/>
-              </a:rPr>
-              <a:t>Practice</a:t>
-            </a:r>
-          </a:p>
-        </p:txBody>
-      </p:sp>
-      <p:sp>
-        <p:nvSpPr>
-          <p:cNvPr id="19" name="Oval 18"/>
-          <p:cNvSpPr/>
-          <p:nvPr/>
-        </p:nvSpPr>
-        <p:spPr>
-          <a:xfrm>
-            <a:off x="932688" y="7260336"/>
-            <a:ext cx="82296" cy="82296"/>
-          </a:xfrm>
-          <a:prstGeom prst="ellipse">
-            <a:avLst/>
-          </a:prstGeom>
-          <a:solidFill>
-            <a:srgbClr val="C96F4A"/>
-          </a:solidFill>
-          <a:ln>
-            <a:noFill/>
-          </a:ln>
-        </p:spPr>
-        <p:style>
-          <a:lnRef idx="1">
-            <a:schemeClr val="accent1"/>
-          </a:lnRef>
-          <a:fillRef idx="3">
-            <a:schemeClr val="accent1"/>
-          </a:fillRef>
-          <a:effectRef idx="2">
-            <a:schemeClr val="accent1"/>
-          </a:effectRef>
-          <a:fontRef idx="minor">
-            <a:schemeClr val="lt1"/>
-          </a:fontRef>
-        </p:style>
-        <p:txBody>
-          <a:bodyPr rtlCol="0" anchor="ctr"/>
-          <a:lstStyle/>
-          <a:p>
-            <a:pPr algn="ctr"/>
-          </a:p>
-        </p:txBody>
-      </p:sp>
-      <p:sp>
-        <p:nvSpPr>
-          <p:cNvPr id="20" name="TextBox 19"/>
-          <p:cNvSpPr txBox="1"/>
-          <p:nvPr/>
-        </p:nvSpPr>
-        <p:spPr>
-          <a:xfrm>
-            <a:off x="1078992" y="7168896"/>
-            <a:ext cx="9555480" cy="274320"/>
-          </a:xfrm>
-          <a:prstGeom prst="rect">
-            <a:avLst/>
-          </a:prstGeom>
-          <a:noFill/>
-        </p:spPr>
-        <p:txBody>
-          <a:bodyPr wrap="square" anchor="t">
-            <a:spAutoFit/>
-          </a:bodyPr>
-          <a:lstStyle/>
-          <a:p>
-            <a:pPr algn="l"/>
-            <a:r>
-              <a:rPr sz="1700" b="0" i="0" lang="en-US" altLang="en-US">
-                <a:solidFill>
-                  <a:srgbClr val="24333D"/>
-                </a:solidFill>
-                <a:latin typeface="Sarabun"/>
-                <a:ea typeface="Sarabun"/>
-                <a:cs typeface="Sarabun"/>
-              </a:rPr>
-              <a:t>Substitution drill: I say a bare phrase. You add the correct polite ending. </a:t>
-            </a:r>
-            <a:r>
-              <a:rPr sz="1700" b="0" i="0" lang="th-TH" altLang="en-US">
-                <a:solidFill>
-                  <a:srgbClr val="24333D"/>
-                </a:solidFill>
-                <a:latin typeface="Sarabun"/>
-                <a:ea typeface="Sarabun"/>
-                <a:cs typeface="Sarabun"/>
-              </a:rPr>
-              <a:t>สวัสดี</a:t>
-            </a:r>
-            <a:r>
-              <a:rPr sz="1700" b="0" i="1" lang="en-US" altLang="en-US">
-                <a:solidFill>
-                  <a:srgbClr val="566873"/>
-                </a:solidFill>
-                <a:latin typeface="Sarabun"/>
-                <a:ea typeface="Sarabun"/>
-                <a:cs typeface="Sarabun"/>
-              </a:rPr>
-              <a:t> (sà-wàt-dii)</a:t>
-            </a:r>
-            <a:r>
-              <a:rPr sz="1700" b="0" i="0" lang="en-US" altLang="en-US">
-                <a:solidFill>
-                  <a:srgbClr val="24333D"/>
-                </a:solidFill>
-                <a:latin typeface="Sarabun"/>
-                <a:ea typeface="Sarabun"/>
-                <a:cs typeface="Sarabun"/>
-              </a:rPr>
-              <a:t> — your turn. </a:t>
-            </a:r>
-            <a:r>
-              <a:rPr sz="1700" b="0" i="0" lang="th-TH" altLang="en-US">
-                <a:solidFill>
-                  <a:srgbClr val="24333D"/>
-                </a:solidFill>
-                <a:latin typeface="Sarabun"/>
-                <a:ea typeface="Sarabun"/>
-                <a:cs typeface="Sarabun"/>
-              </a:rPr>
-              <a:t>ขอบคุณ</a:t>
-            </a:r>
-            <a:r>
-              <a:rPr sz="1700" b="0" i="1" lang="en-US" altLang="en-US">
-                <a:solidFill>
-                  <a:srgbClr val="566873"/>
-                </a:solidFill>
-                <a:latin typeface="Sarabun"/>
-                <a:ea typeface="Sarabun"/>
-                <a:cs typeface="Sarabun"/>
-              </a:rPr>
-              <a:t> (khàawp-khun)</a:t>
-            </a:r>
-            <a:r>
-              <a:rPr sz="1700" b="0" i="0" lang="en-US" altLang="en-US">
-                <a:solidFill>
-                  <a:srgbClr val="24333D"/>
-                </a:solidFill>
-                <a:latin typeface="Sarabun"/>
-                <a:ea typeface="Sarabun"/>
-                <a:cs typeface="Sarabun"/>
-              </a:rPr>
-              <a:t> — your turn. </a:t>
-            </a:r>
-            <a:r>
-              <a:rPr sz="1700" b="0" i="0" lang="th-TH" altLang="en-US">
-                <a:solidFill>
-                  <a:srgbClr val="24333D"/>
-                </a:solidFill>
-                <a:latin typeface="Sarabun"/>
-                <a:ea typeface="Sarabun"/>
-                <a:cs typeface="Sarabun"/>
-              </a:rPr>
-              <a:t>ขอโทษ</a:t>
-            </a:r>
-            <a:r>
-              <a:rPr sz="1700" b="0" i="1" lang="en-US" altLang="en-US">
-                <a:solidFill>
-                  <a:srgbClr val="566873"/>
-                </a:solidFill>
-                <a:latin typeface="Sarabun"/>
-                <a:ea typeface="Sarabun"/>
-                <a:cs typeface="Sarabun"/>
-              </a:rPr>
-              <a:t> (khǎaw-thôot)</a:t>
-            </a:r>
-            <a:r>
-              <a:rPr sz="1700" b="0" i="0" lang="en-US" altLang="en-US">
-                <a:solidFill>
-                  <a:srgbClr val="24333D"/>
-                </a:solidFill>
-                <a:latin typeface="Sarabun"/>
-                <a:ea typeface="Sarabun"/>
-                <a:cs typeface="Sarabun"/>
-              </a:rPr>
-              <a:t> — your turn.</a:t>
-            </a:r>
-          </a:p>
-        </p:txBody>
-      </p:sp>
     </p:spTree>
   </p:cSld>
   <p:clrMapOvr>
@@ -8050,189 +8220,6 @@
           </a:p>
         </p:txBody>
       </p:sp>
-      <p:sp>
-        <p:nvSpPr>
-          <p:cNvPr id="18" name="TextBox 17"/>
-          <p:cNvSpPr txBox="1"/>
-          <p:nvPr/>
-        </p:nvSpPr>
-        <p:spPr>
-          <a:xfrm>
-            <a:off x="932688" y="6876288"/>
-            <a:ext cx="9692640" cy="228600"/>
-          </a:xfrm>
-          <a:prstGeom prst="rect">
-            <a:avLst/>
-          </a:prstGeom>
-          <a:noFill/>
-        </p:spPr>
-        <p:txBody>
-          <a:bodyPr wrap="square" anchor="t">
-            <a:spAutoFit/>
-          </a:bodyPr>
-          <a:lstStyle/>
-          <a:p>
-            <a:pPr algn="l"/>
-            <a:r>
-              <a:rPr sz="1700" b="1" i="0" lang="en-US" altLang="en-US">
-                <a:solidFill>
-                  <a:srgbClr val="C96F4A"/>
-                </a:solidFill>
-                <a:latin typeface="Sarabun"/>
-                <a:ea typeface="Sarabun"/>
-                <a:cs typeface="Sarabun"/>
-              </a:rPr>
-              <a:t>Practice</a:t>
-            </a:r>
-          </a:p>
-        </p:txBody>
-      </p:sp>
-      <p:sp>
-        <p:nvSpPr>
-          <p:cNvPr id="19" name="Oval 18"/>
-          <p:cNvSpPr/>
-          <p:nvPr/>
-        </p:nvSpPr>
-        <p:spPr>
-          <a:xfrm>
-            <a:off x="932688" y="7260336"/>
-            <a:ext cx="82296" cy="82296"/>
-          </a:xfrm>
-          <a:prstGeom prst="ellipse">
-            <a:avLst/>
-          </a:prstGeom>
-          <a:solidFill>
-            <a:srgbClr val="C96F4A"/>
-          </a:solidFill>
-          <a:ln>
-            <a:noFill/>
-          </a:ln>
-        </p:spPr>
-        <p:style>
-          <a:lnRef idx="1">
-            <a:schemeClr val="accent1"/>
-          </a:lnRef>
-          <a:fillRef idx="3">
-            <a:schemeClr val="accent1"/>
-          </a:fillRef>
-          <a:effectRef idx="2">
-            <a:schemeClr val="accent1"/>
-          </a:effectRef>
-          <a:fontRef idx="minor">
-            <a:schemeClr val="lt1"/>
-          </a:fontRef>
-        </p:style>
-        <p:txBody>
-          <a:bodyPr rtlCol="0" anchor="ctr"/>
-          <a:lstStyle/>
-          <a:p>
-            <a:pPr algn="ctr"/>
-          </a:p>
-        </p:txBody>
-      </p:sp>
-      <p:sp>
-        <p:nvSpPr>
-          <p:cNvPr id="20" name="TextBox 19"/>
-          <p:cNvSpPr txBox="1"/>
-          <p:nvPr/>
-        </p:nvSpPr>
-        <p:spPr>
-          <a:xfrm>
-            <a:off x="1078992" y="7168896"/>
-            <a:ext cx="9555480" cy="274320"/>
-          </a:xfrm>
-          <a:prstGeom prst="rect">
-            <a:avLst/>
-          </a:prstGeom>
-          <a:noFill/>
-        </p:spPr>
-        <p:txBody>
-          <a:bodyPr wrap="square" anchor="t">
-            <a:spAutoFit/>
-          </a:bodyPr>
-          <a:lstStyle/>
-          <a:p>
-            <a:pPr algn="l"/>
-            <a:r>
-              <a:rPr sz="1700" b="0" i="0" lang="en-US" altLang="en-US">
-                <a:solidFill>
-                  <a:srgbClr val="24333D"/>
-                </a:solidFill>
-                <a:latin typeface="Sarabun"/>
-                <a:ea typeface="Sarabun"/>
-                <a:cs typeface="Sarabun"/>
-              </a:rPr>
-              <a:t>Pause-and-produce: I ask a yes/no question. Say </a:t>
-            </a:r>
-            <a:r>
-              <a:rPr sz="1700" b="0" i="0" lang="th-TH" altLang="en-US">
-                <a:solidFill>
-                  <a:srgbClr val="24333D"/>
-                </a:solidFill>
-                <a:latin typeface="Sarabun"/>
-                <a:ea typeface="Sarabun"/>
-                <a:cs typeface="Sarabun"/>
-              </a:rPr>
-              <a:t>ใช่</a:t>
-            </a:r>
-            <a:r>
-              <a:rPr sz="1700" b="0" i="1" lang="en-US" altLang="en-US">
-                <a:solidFill>
-                  <a:srgbClr val="566873"/>
-                </a:solidFill>
-                <a:latin typeface="Sarabun"/>
-                <a:ea typeface="Sarabun"/>
-                <a:cs typeface="Sarabun"/>
-              </a:rPr>
-              <a:t> (châi)</a:t>
-            </a:r>
-            <a:r>
-              <a:rPr sz="1700" b="0" i="0" lang="en-US" altLang="en-US">
-                <a:solidFill>
-                  <a:srgbClr val="24333D"/>
-                </a:solidFill>
-                <a:latin typeface="Sarabun"/>
-                <a:ea typeface="Sarabun"/>
-                <a:cs typeface="Sarabun"/>
-              </a:rPr>
-              <a:t> or </a:t>
-            </a:r>
-            <a:r>
-              <a:rPr sz="1700" b="0" i="0" lang="th-TH" altLang="en-US">
-                <a:solidFill>
-                  <a:srgbClr val="24333D"/>
-                </a:solidFill>
-                <a:latin typeface="Sarabun"/>
-                <a:ea typeface="Sarabun"/>
-                <a:cs typeface="Sarabun"/>
-              </a:rPr>
-              <a:t>ไม่ใช่</a:t>
-            </a:r>
-            <a:r>
-              <a:rPr sz="1700" b="0" i="1" lang="en-US" altLang="en-US">
-                <a:solidFill>
-                  <a:srgbClr val="566873"/>
-                </a:solidFill>
-                <a:latin typeface="Sarabun"/>
-                <a:ea typeface="Sarabun"/>
-                <a:cs typeface="Sarabun"/>
-              </a:rPr>
-              <a:t> (mâi châi)</a:t>
-            </a:r>
-            <a:r>
-              <a:rPr sz="1700" b="0" i="0" lang="en-US" altLang="en-US">
-                <a:solidFill>
-                  <a:srgbClr val="24333D"/>
-                </a:solidFill>
-                <a:latin typeface="Sarabun"/>
-                <a:ea typeface="Sarabun"/>
-                <a:cs typeface="Sarabun"/>
-              </a:rPr>
-              <a:t> before I show the answer.</a:t>
-            </a:r>
-          </a:p>
-        </p:txBody>
-      </p:sp>
     </p:spTree>
   </p:cSld>
   <p:clrMapOvr>
@@ -8936,189 +8923,6 @@
                 <a:cs typeface="Sarabun"/>
               </a:rPr>
               <a:t>low tone on khàawp — voice stays low</a:t>
-            </a:r>
-          </a:p>
-        </p:txBody>
-      </p:sp>
-      <p:sp>
-        <p:nvSpPr>
-          <p:cNvPr id="18" name="TextBox 17"/>
-          <p:cNvSpPr txBox="1"/>
-          <p:nvPr/>
-        </p:nvSpPr>
-        <p:spPr>
-          <a:xfrm>
-            <a:off x="932688" y="6876288"/>
-            <a:ext cx="9692640" cy="228600"/>
-          </a:xfrm>
-          <a:prstGeom prst="rect">
-            <a:avLst/>
-          </a:prstGeom>
-          <a:noFill/>
-        </p:spPr>
-        <p:txBody>
-          <a:bodyPr wrap="square" anchor="t">
-            <a:spAutoFit/>
-          </a:bodyPr>
-          <a:lstStyle/>
-          <a:p>
-            <a:pPr algn="l"/>
-            <a:r>
-              <a:rPr sz="1700" b="1" i="0" lang="en-US" altLang="en-US">
-                <a:solidFill>
-                  <a:srgbClr val="C96F4A"/>
-                </a:solidFill>
-                <a:latin typeface="Sarabun"/>
-                <a:ea typeface="Sarabun"/>
-                <a:cs typeface="Sarabun"/>
-              </a:rPr>
-              <a:t>Practice</a:t>
-            </a:r>
-          </a:p>
-        </p:txBody>
-      </p:sp>
-      <p:sp>
-        <p:nvSpPr>
-          <p:cNvPr id="19" name="Oval 18"/>
-          <p:cNvSpPr/>
-          <p:nvPr/>
-        </p:nvSpPr>
-        <p:spPr>
-          <a:xfrm>
-            <a:off x="932688" y="7260336"/>
-            <a:ext cx="82296" cy="82296"/>
-          </a:xfrm>
-          <a:prstGeom prst="ellipse">
-            <a:avLst/>
-          </a:prstGeom>
-          <a:solidFill>
-            <a:srgbClr val="C96F4A"/>
-          </a:solidFill>
-          <a:ln>
-            <a:noFill/>
-          </a:ln>
-        </p:spPr>
-        <p:style>
-          <a:lnRef idx="1">
-            <a:schemeClr val="accent1"/>
-          </a:lnRef>
-          <a:fillRef idx="3">
-            <a:schemeClr val="accent1"/>
-          </a:fillRef>
-          <a:effectRef idx="2">
-            <a:schemeClr val="accent1"/>
-          </a:effectRef>
-          <a:fontRef idx="minor">
-            <a:schemeClr val="lt1"/>
-          </a:fontRef>
-        </p:style>
-        <p:txBody>
-          <a:bodyPr rtlCol="0" anchor="ctr"/>
-          <a:lstStyle/>
-          <a:p>
-            <a:pPr algn="ctr"/>
-          </a:p>
-        </p:txBody>
-      </p:sp>
-      <p:sp>
-        <p:nvSpPr>
-          <p:cNvPr id="20" name="TextBox 19"/>
-          <p:cNvSpPr txBox="1"/>
-          <p:nvPr/>
-        </p:nvSpPr>
-        <p:spPr>
-          <a:xfrm>
-            <a:off x="1078992" y="7168896"/>
-            <a:ext cx="9555480" cy="274320"/>
-          </a:xfrm>
-          <a:prstGeom prst="rect">
-            <a:avLst/>
-          </a:prstGeom>
-          <a:noFill/>
-        </p:spPr>
-        <p:txBody>
-          <a:bodyPr wrap="square" anchor="t">
-            <a:spAutoFit/>
-          </a:bodyPr>
-          <a:lstStyle/>
-          <a:p>
-            <a:pPr algn="l"/>
-            <a:r>
-              <a:rPr sz="1700" b="0" i="0" lang="en-US" altLang="en-US">
-                <a:solidFill>
-                  <a:srgbClr val="24333D"/>
-                </a:solidFill>
-                <a:latin typeface="Sarabun"/>
-                <a:ea typeface="Sarabun"/>
-                <a:cs typeface="Sarabun"/>
-              </a:rPr>
-              <a:t>Tone echo: I say </a:t>
-            </a:r>
-            <a:r>
-              <a:rPr sz="1700" b="0" i="0" lang="th-TH" altLang="en-US">
-                <a:solidFill>
-                  <a:srgbClr val="24333D"/>
-                </a:solidFill>
-                <a:latin typeface="Sarabun"/>
-                <a:ea typeface="Sarabun"/>
-                <a:cs typeface="Sarabun"/>
-              </a:rPr>
-              <a:t>ครับ</a:t>
-            </a:r>
-            <a:r>
-              <a:rPr sz="1700" b="0" i="1" lang="en-US" altLang="en-US">
-                <a:solidFill>
-                  <a:srgbClr val="566873"/>
-                </a:solidFill>
-                <a:latin typeface="Sarabun"/>
-                <a:ea typeface="Sarabun"/>
-                <a:cs typeface="Sarabun"/>
-              </a:rPr>
-              <a:t> (khráp)</a:t>
-            </a:r>
-            <a:r>
-              <a:rPr sz="1700" b="0" i="0" lang="en-US" altLang="en-US">
-                <a:solidFill>
-                  <a:srgbClr val="24333D"/>
-                </a:solidFill>
-                <a:latin typeface="Sarabun"/>
-                <a:ea typeface="Sarabun"/>
-                <a:cs typeface="Sarabun"/>
-              </a:rPr>
-              <a:t> khráp. Repeat it. Now I say </a:t>
-            </a:r>
-            <a:r>
-              <a:rPr sz="1700" b="0" i="0" lang="th-TH" altLang="en-US">
-                <a:solidFill>
-                  <a:srgbClr val="24333D"/>
-                </a:solidFill>
-                <a:latin typeface="Sarabun"/>
-                <a:ea typeface="Sarabun"/>
-                <a:cs typeface="Sarabun"/>
-              </a:rPr>
-              <a:t>ค่ะ</a:t>
-            </a:r>
-            <a:r>
-              <a:rPr sz="1700" b="0" i="1" lang="en-US" altLang="en-US">
-                <a:solidFill>
-                  <a:srgbClr val="566873"/>
-                </a:solidFill>
-                <a:latin typeface="Sarabun"/>
-                <a:ea typeface="Sarabun"/>
-                <a:cs typeface="Sarabun"/>
-              </a:rPr>
-              <a:t> (khâ)</a:t>
-            </a:r>
-            <a:r>
-              <a:rPr sz="1700" b="0" i="0" lang="en-US" altLang="en-US">
-                <a:solidFill>
-                  <a:srgbClr val="24333D"/>
-                </a:solidFill>
-                <a:latin typeface="Sarabun"/>
-                <a:ea typeface="Sarabun"/>
-                <a:cs typeface="Sarabun"/>
-              </a:rPr>
-              <a:t> khâ. Repeat it. Can you feel the difference?</a:t>
             </a:r>
           </a:p>
         </p:txBody>
@@ -11579,4 +11383,324 @@
   </ns0:objectDefaults>
   <ns0:extraClrSchemeLst/>
 </ns0:theme>
+</file>
+
+<file path=ppt/theme/theme2.xml><?xml version="1.0" encoding="utf-8"?>
+<a:theme xmlns:a="http://schemas.openxmlformats.org/drawingml/2006/main" name="Office Theme">
+  <a:themeElements>
+    <a:clrScheme name="Office">
+      <a:dk1>
+        <a:sysClr val="windowText" lastClr="000000"/>
+      </a:dk1>
+      <a:lt1>
+        <a:sysClr val="window" lastClr="FFFFFF"/>
+      </a:lt1>
+      <a:dk2>
+        <a:srgbClr val="1F497D"/>
+      </a:dk2>
+      <a:lt2>
+        <a:srgbClr val="EEECE1"/>
+      </a:lt2>
+      <a:accent1>
+        <a:srgbClr val="4F81BD"/>
+      </a:accent1>
+      <a:accent2>
+        <a:srgbClr val="C0504D"/>
+      </a:accent2>
+      <a:accent3>
+        <a:srgbClr val="9BBB59"/>
+      </a:accent3>
+      <a:accent4>
+        <a:srgbClr val="8064A2"/>
+      </a:accent4>
+      <a:accent5>
+        <a:srgbClr val="4BACC6"/>
+      </a:accent5>
+      <a:accent6>
+        <a:srgbClr val="F79646"/>
+      </a:accent6>
+      <a:hlink>
+        <a:srgbClr val="0000FF"/>
+      </a:hlink>
+      <a:folHlink>
+        <a:srgbClr val="800080"/>
+      </a:folHlink>
+    </a:clrScheme>
+    <a:fontScheme name="Office">
+      <a:majorFont>
+        <a:latin typeface="Calibri"/>
+        <a:ea typeface=""/>
+        <a:cs typeface=""/>
+        <a:font script="Jpan" typeface="ＭＳ Ｐゴシック"/>
+        <a:font script="Hang" typeface="맑은 고딕"/>
+        <a:font script="Hans" typeface="宋体"/>
+        <a:font script="Hant" typeface="新細明體"/>
+        <a:font script="Arab" typeface="Times New Roman"/>
+        <a:font script="Hebr" typeface="Times New Roman"/>
+        <a:font script="Thai" typeface="Angsana New"/>
+        <a:font script="Ethi" typeface="Nyala"/>
+        <a:font script="Beng" typeface="Vrinda"/>
+        <a:font script="Gujr" typeface="Shruti"/>
+        <a:font script="Khmr" typeface="MoolBoran"/>
+        <a:font script="Knda" typeface="Tunga"/>
+        <a:font script="Guru" typeface="Raavi"/>
+        <a:font script="Cans" typeface="Euphemia"/>
+        <a:font script="Cher" typeface="Plantagenet Cherokee"/>
+        <a:font script="Yiii" typeface="Microsoft Yi Baiti"/>
+        <a:font script="Tibt" typeface="Microsoft Himalaya"/>
+        <a:font script="Thaa" typeface="MV Boli"/>
+        <a:font script="Deva" typeface="Mangal"/>
+        <a:font script="Telu" typeface="Gautami"/>
+        <a:font script="Taml" typeface="Latha"/>
+        <a:font script="Syrc" typeface="Estrangelo Edessa"/>
+        <a:font script="Orya" typeface="Kalinga"/>
+        <a:font script="Mlym" typeface="Kartika"/>
+        <a:font script="Laoo" typeface="DokChampa"/>
+        <a:font script="Sinh" typeface="Iskoola Pota"/>
+        <a:font script="Mong" typeface="Mongolian Baiti"/>
+        <a:font script="Viet" typeface="Times New Roman"/>
+        <a:font script="Uigh" typeface="Microsoft Uighur"/>
+        <a:font script="Geor" typeface="Sylfaen"/>
+      </a:majorFont>
+      <a:minorFont>
+        <a:latin typeface="Calibri"/>
+        <a:ea typeface=""/>
+        <a:cs typeface=""/>
+        <a:font script="Jpan" typeface="ＭＳ Ｐゴシック"/>
+        <a:font script="Hang" typeface="맑은 고딕"/>
+        <a:font script="Hans" typeface="宋体"/>
+        <a:font script="Hant" typeface="新細明體"/>
+        <a:font script="Arab" typeface="Arial"/>
+        <a:font script="Hebr" typeface="Arial"/>
+        <a:font script="Thai" typeface="Cordia New"/>
+        <a:font script="Ethi" typeface="Nyala"/>
+        <a:font script="Beng" typeface="Vrinda"/>
+        <a:font script="Gujr" typeface="Shruti"/>
+        <a:font script="Khmr" typeface="DaunPenh"/>
+        <a:font script="Knda" typeface="Tunga"/>
+        <a:font script="Guru" typeface="Raavi"/>
+        <a:font script="Cans" typeface="Euphemia"/>
+        <a:font script="Cher" typeface="Plantagenet Cherokee"/>
+        <a:font script="Yiii" typeface="Microsoft Yi Baiti"/>
+        <a:font script="Tibt" typeface="Microsoft Himalaya"/>
+        <a:font script="Thaa" typeface="MV Boli"/>
+        <a:font script="Deva" typeface="Mangal"/>
+        <a:font script="Telu" typeface="Gautami"/>
+        <a:font script="Taml" typeface="Latha"/>
+        <a:font script="Syrc" typeface="Estrangelo Edessa"/>
+        <a:font script="Orya" typeface="Kalinga"/>
+        <a:font script="Mlym" typeface="Kartika"/>
+        <a:font script="Laoo" typeface="DokChampa"/>
+        <a:font script="Sinh" typeface="Iskoola Pota"/>
+        <a:font script="Mong" typeface="Mongolian Baiti"/>
+        <a:font script="Viet" typeface="Arial"/>
+        <a:font script="Uigh" typeface="Microsoft Uighur"/>
+        <a:font script="Geor" typeface="Sylfaen"/>
+      </a:minorFont>
+    </a:fontScheme>
+    <a:fmtScheme name="Office">
+      <a:fillStyleLst>
+        <a:solidFill>
+          <a:schemeClr val="phClr"/>
+        </a:solidFill>
+        <a:gradFill rotWithShape="1">
+          <a:gsLst>
+            <a:gs pos="0">
+              <a:schemeClr val="phClr">
+                <a:tint val="50000"/>
+                <a:satMod val="300000"/>
+              </a:schemeClr>
+            </a:gs>
+            <a:gs pos="35000">
+              <a:schemeClr val="phClr">
+                <a:tint val="37000"/>
+                <a:satMod val="300000"/>
+              </a:schemeClr>
+            </a:gs>
+            <a:gs pos="100000">
+              <a:schemeClr val="phClr">
+                <a:tint val="15000"/>
+                <a:satMod val="350000"/>
+              </a:schemeClr>
+            </a:gs>
+          </a:gsLst>
+          <a:lin ang="16200000" scaled="1"/>
+        </a:gradFill>
+        <a:gradFill rotWithShape="1">
+          <a:gsLst>
+            <a:gs pos="0">
+              <a:schemeClr val="phClr">
+                <a:tint val="100000"/>
+                <a:shade val="100000"/>
+                <a:satMod val="130000"/>
+              </a:schemeClr>
+            </a:gs>
+            <a:gs pos="100000">
+              <a:schemeClr val="phClr">
+                <a:tint val="50000"/>
+                <a:shade val="100000"/>
+                <a:satMod val="350000"/>
+              </a:schemeClr>
+            </a:gs>
+          </a:gsLst>
+          <a:lin ang="16200000" scaled="0"/>
+        </a:gradFill>
+      </a:fillStyleLst>
+      <a:lnStyleLst>
+        <a:ln w="9525" cap="flat" cmpd="sng" algn="ctr">
+          <a:solidFill>
+            <a:schemeClr val="phClr">
+              <a:shade val="95000"/>
+              <a:satMod val="105000"/>
+            </a:schemeClr>
+          </a:solidFill>
+          <a:prstDash val="solid"/>
+        </a:ln>
+        <a:ln w="25400" cap="flat" cmpd="sng" algn="ctr">
+          <a:solidFill>
+            <a:schemeClr val="phClr"/>
+          </a:solidFill>
+          <a:prstDash val="solid"/>
+        </a:ln>
+        <a:ln w="38100" cap="flat" cmpd="sng" algn="ctr">
+          <a:solidFill>
+            <a:schemeClr val="phClr"/>
+          </a:solidFill>
+          <a:prstDash val="solid"/>
+        </a:ln>
+      </a:lnStyleLst>
+      <a:effectStyleLst>
+        <a:effectStyle>
+          <a:effectLst>
+            <a:outerShdw blurRad="40000" dist="20000" dir="5400000" rotWithShape="0">
+              <a:srgbClr val="000000">
+                <a:alpha val="38000"/>
+              </a:srgbClr>
+            </a:outerShdw>
+          </a:effectLst>
+        </a:effectStyle>
+        <a:effectStyle>
+          <a:effectLst>
+            <a:outerShdw blurRad="40000" dist="23000" dir="5400000" rotWithShape="0">
+              <a:srgbClr val="000000">
+                <a:alpha val="35000"/>
+              </a:srgbClr>
+            </a:outerShdw>
+          </a:effectLst>
+        </a:effectStyle>
+        <a:effectStyle>
+          <a:effectLst>
+            <a:outerShdw blurRad="40000" dist="23000" dir="5400000" rotWithShape="0">
+              <a:srgbClr val="000000">
+                <a:alpha val="35000"/>
+              </a:srgbClr>
+            </a:outerShdw>
+          </a:effectLst>
+          <a:scene3d>
+            <a:camera prst="orthographicFront">
+              <a:rot lat="0" lon="0" rev="0"/>
+            </a:camera>
+            <a:lightRig rig="threePt" dir="t">
+              <a:rot lat="0" lon="0" rev="1200000"/>
+            </a:lightRig>
+          </a:scene3d>
+          <a:sp3d>
+            <a:bevelT w="63500" h="25400"/>
+          </a:sp3d>
+        </a:effectStyle>
+      </a:effectStyleLst>
+      <a:bgFillStyleLst>
+        <a:solidFill>
+          <a:schemeClr val="phClr"/>
+        </a:solidFill>
+        <a:gradFill rotWithShape="1">
+          <a:gsLst>
+            <a:gs pos="0">
+              <a:schemeClr val="phClr">
+                <a:tint val="40000"/>
+                <a:satMod val="350000"/>
+              </a:schemeClr>
+            </a:gs>
+            <a:gs pos="40000">
+              <a:schemeClr val="phClr">
+                <a:tint val="45000"/>
+                <a:shade val="99000"/>
+                <a:satMod val="350000"/>
+              </a:schemeClr>
+            </a:gs>
+            <a:gs pos="100000">
+              <a:schemeClr val="phClr">
+                <a:shade val="20000"/>
+                <a:satMod val="255000"/>
+              </a:schemeClr>
+            </a:gs>
+          </a:gsLst>
+          <a:path path="circle">
+            <a:fillToRect l="50000" t="-80000" r="50000" b="180000"/>
+          </a:path>
+        </a:gradFill>
+        <a:gradFill rotWithShape="1">
+          <a:gsLst>
+            <a:gs pos="0">
+              <a:schemeClr val="phClr">
+                <a:tint val="80000"/>
+                <a:satMod val="300000"/>
+              </a:schemeClr>
+            </a:gs>
+            <a:gs pos="100000">
+              <a:schemeClr val="phClr">
+                <a:shade val="30000"/>
+                <a:satMod val="200000"/>
+              </a:schemeClr>
+            </a:gs>
+          </a:gsLst>
+          <a:path path="circle">
+            <a:fillToRect l="50000" t="50000" r="50000" b="50000"/>
+          </a:path>
+        </a:gradFill>
+      </a:bgFillStyleLst>
+    </a:fmtScheme>
+  </a:themeElements>
+  <a:objectDefaults>
+    <a:spDef>
+      <a:spPr/>
+      <a:bodyPr/>
+      <a:lstStyle/>
+      <a:style>
+        <a:lnRef idx="1">
+          <a:schemeClr val="accent1"/>
+        </a:lnRef>
+        <a:fillRef idx="3">
+          <a:schemeClr val="accent1"/>
+        </a:fillRef>
+        <a:effectRef idx="2">
+          <a:schemeClr val="accent1"/>
+        </a:effectRef>
+        <a:fontRef idx="minor">
+          <a:schemeClr val="lt1"/>
+        </a:fontRef>
+      </a:style>
+    </a:spDef>
+    <a:lnDef>
+      <a:spPr/>
+      <a:bodyPr/>
+      <a:lstStyle/>
+      <a:style>
+        <a:lnRef idx="2">
+          <a:schemeClr val="accent1"/>
+        </a:lnRef>
+        <a:fillRef idx="0">
+          <a:schemeClr val="accent1"/>
+        </a:fillRef>
+        <a:effectRef idx="1">
+          <a:schemeClr val="accent1"/>
+        </a:effectRef>
+        <a:fontRef idx="minor">
+          <a:schemeClr val="tx1"/>
+        </a:fontRef>
+      </a:style>
+    </a:lnDef>
+  </a:objectDefaults>
+  <a:extraClrSchemeLst/>
+</a:theme>
 </file>
</xml_diff>

<commit_message>
fix(pptx): variable-height bullet textboxes, dynamic recap layout
- Bullet textboxes now estimate wrapped line count and set height
  accordingly (was fixed at 0.3" causing text overflow in Canva)
- Recap "Remember" block positioned dynamically below "What you
  can now do" block instead of at fixed Y=4.55"
- add_bullet_block() now returns bottom Y for downstream positioning
- All 3 lessons pass visual QA validator cleanly

Co-Authored-By: Claude Opus 4.6 (1M context) <noreply@anthropic.com>

Former-commit-id: f28d5c35acfdbeda7fa095f3e2c38f47a944ac23
Former-commit-id: 35e9ed4b8d44c47533d5868eecb8605fb0170b4f
Former-commit-id: e2e095e10c990c8102a6b9fef3f7baca749f4d12
</commit_message>
<xml_diff>
--- a/course/modules/M01/L001/M01-L001-canva-deck.pptx
+++ b/course/modules/M01/L001/M01-L001-canva-deck.pptx
@@ -4190,7 +4190,7 @@
         <p:spPr>
           <a:xfrm>
             <a:off x="1078992" y="4553712"/>
-            <a:ext cx="6568135" cy="274320"/>
+            <a:ext cx="6568135" cy="676656"/>
           </a:xfrm>
           <a:prstGeom prst="rect">
             <a:avLst/>
@@ -4226,7 +4226,7 @@
         </p:nvSpPr>
         <p:spPr>
           <a:xfrm>
-            <a:off x="932688" y="4956048"/>
+            <a:off x="932688" y="5376672"/>
             <a:ext cx="82296" cy="82296"/>
           </a:xfrm>
           <a:prstGeom prst="ellipse">
@@ -4269,8 +4269,8 @@
         </p:nvSpPr>
         <p:spPr>
           <a:xfrm>
-            <a:off x="1078992" y="4864608"/>
-            <a:ext cx="6568135" cy="274320"/>
+            <a:off x="1078992" y="5285232"/>
+            <a:ext cx="6568135" cy="475488"/>
           </a:xfrm>
           <a:prstGeom prst="rect">
             <a:avLst/>
@@ -4624,7 +4624,7 @@
         <p:spPr>
           <a:xfrm>
             <a:off x="1078992" y="2039112"/>
-            <a:ext cx="6568135" cy="274320"/>
+            <a:ext cx="6568135" cy="475488"/>
           </a:xfrm>
           <a:prstGeom prst="rect">
             <a:avLst/>
@@ -4660,7 +4660,7 @@
         </p:nvSpPr>
         <p:spPr>
           <a:xfrm>
-            <a:off x="932688" y="2441448"/>
+            <a:off x="932688" y="2660904"/>
             <a:ext cx="82296" cy="82296"/>
           </a:xfrm>
           <a:prstGeom prst="ellipse">
@@ -4703,7 +4703,7 @@
         </p:nvSpPr>
         <p:spPr>
           <a:xfrm>
-            <a:off x="1078992" y="2350008"/>
+            <a:off x="1078992" y="2569464"/>
             <a:ext cx="6568135" cy="274320"/>
           </a:xfrm>
           <a:prstGeom prst="rect">
@@ -10262,7 +10262,7 @@
         <p:spPr>
           <a:xfrm>
             <a:off x="1078992" y="1856232"/>
-            <a:ext cx="6568135" cy="274320"/>
+            <a:ext cx="6568135" cy="475488"/>
           </a:xfrm>
           <a:prstGeom prst="rect">
             <a:avLst/>
@@ -10298,7 +10298,7 @@
         </p:nvSpPr>
         <p:spPr>
           <a:xfrm>
-            <a:off x="932688" y="2258568"/>
+            <a:off x="932688" y="2478024"/>
             <a:ext cx="82296" cy="82296"/>
           </a:xfrm>
           <a:prstGeom prst="ellipse">
@@ -10341,8 +10341,8 @@
         </p:nvSpPr>
         <p:spPr>
           <a:xfrm>
-            <a:off x="1078992" y="2167128"/>
-            <a:ext cx="6568135" cy="274320"/>
+            <a:off x="1078992" y="2386584"/>
+            <a:ext cx="6568135" cy="475488"/>
           </a:xfrm>
           <a:prstGeom prst="rect">
             <a:avLst/>
@@ -10444,7 +10444,7 @@
         </p:nvSpPr>
         <p:spPr>
           <a:xfrm>
-            <a:off x="932688" y="2569464"/>
+            <a:off x="932688" y="3008376"/>
             <a:ext cx="82296" cy="82296"/>
           </a:xfrm>
           <a:prstGeom prst="ellipse">
@@ -10487,8 +10487,8 @@
         </p:nvSpPr>
         <p:spPr>
           <a:xfrm>
-            <a:off x="1078992" y="2478024"/>
-            <a:ext cx="6568135" cy="274320"/>
+            <a:off x="1078992" y="2916936"/>
+            <a:ext cx="6568135" cy="475488"/>
           </a:xfrm>
           <a:prstGeom prst="rect">
             <a:avLst/>
@@ -10590,7 +10590,7 @@
         </p:nvSpPr>
         <p:spPr>
           <a:xfrm>
-            <a:off x="932688" y="2880360"/>
+            <a:off x="932688" y="3538728"/>
             <a:ext cx="82296" cy="82296"/>
           </a:xfrm>
           <a:prstGeom prst="ellipse">
@@ -10633,8 +10633,8 @@
         </p:nvSpPr>
         <p:spPr>
           <a:xfrm>
-            <a:off x="1078992" y="2788920"/>
-            <a:ext cx="6568135" cy="274320"/>
+            <a:off x="1078992" y="3447288"/>
+            <a:ext cx="6568135" cy="676656"/>
           </a:xfrm>
           <a:prstGeom prst="rect">
             <a:avLst/>
@@ -10736,7 +10736,7 @@
         </p:nvSpPr>
         <p:spPr>
           <a:xfrm>
-            <a:off x="932688" y="3191256"/>
+            <a:off x="932688" y="4270248"/>
             <a:ext cx="82296" cy="82296"/>
           </a:xfrm>
           <a:prstGeom prst="ellipse">
@@ -10779,8 +10779,8 @@
         </p:nvSpPr>
         <p:spPr>
           <a:xfrm>
-            <a:off x="1078992" y="3099816"/>
-            <a:ext cx="6568135" cy="274320"/>
+            <a:off x="1078992" y="4178808"/>
+            <a:ext cx="6568135" cy="475488"/>
           </a:xfrm>
           <a:prstGeom prst="rect">
             <a:avLst/>
@@ -10882,7 +10882,7 @@
         </p:nvSpPr>
         <p:spPr>
           <a:xfrm>
-            <a:off x="932688" y="4306824"/>
+            <a:off x="932688" y="5129784"/>
             <a:ext cx="9692640" cy="228600"/>
           </a:xfrm>
           <a:prstGeom prst="rect">
@@ -10919,7 +10919,7 @@
         </p:nvSpPr>
         <p:spPr>
           <a:xfrm>
-            <a:off x="932688" y="4690872"/>
+            <a:off x="932688" y="5513832"/>
             <a:ext cx="82296" cy="82296"/>
           </a:xfrm>
           <a:prstGeom prst="ellipse">
@@ -10962,7 +10962,7 @@
         </p:nvSpPr>
         <p:spPr>
           <a:xfrm>
-            <a:off x="1078992" y="4599432"/>
+            <a:off x="1078992" y="5422392"/>
             <a:ext cx="9555480" cy="274320"/>
           </a:xfrm>
           <a:prstGeom prst="rect">

</xml_diff>

<commit_message>
feat(pptx): three-line display — Thai / Translit / English on separate lines
Phrase cards and dialogue turns now show:
  Line 1: Thai script
  Line 2: Transliteration (italic, gray)
  Line 3: English translation (gray)

All three lines use the same font size (17pt). Previously Thai
and transliteration were inline on one line with English below.

Inline Thai in English sentences (drill instructions) keeps the
existing "Thai (translit)" format unchanged.

Roleplay turns increased to 1.0" spacing to fit 3 lines, capped
at 5 turns per slide.

Co-Authored-By: Claude Opus 4.6 (1M context) <noreply@anthropic.com>

Former-commit-id: 025c8ef8d7da79ad1c8d574e5e515f4b8eaf982c
Former-commit-id: 82a842f172727fbc99e116232f2e2516663c1d95
Former-commit-id: 3331f4b0b357fa66602aacdf3ce8281916b3ff03
</commit_message>
<xml_diff>
--- a/course/modules/M01/L001/M01-L001-canva-deck.pptx
+++ b/course/modules/M01/L001/M01-L001-canva-deck.pptx
@@ -5684,8 +5684,8 @@
         </p:nvSpPr>
         <p:spPr>
           <a:xfrm>
-            <a:off x="1078992" y="1435608"/>
-            <a:ext cx="6613855" cy="658368"/>
+            <a:off x="1078992" y="1463040"/>
+            <a:ext cx="6613855" cy="320040"/>
           </a:xfrm>
           <a:prstGeom prst="rect">
             <a:avLst/>
@@ -5700,7 +5700,7 @@
           <a:p>
             <a:pPr algn="l"/>
             <a:r>
-              <a:rPr sz="3600" b="1" i="0" lang="th-TH" altLang="en-US">
+              <a:rPr sz="1700" b="0" i="0" lang="th-TH" altLang="en-US">
                 <a:solidFill>
                   <a:srgbClr val="24333D"/>
                 </a:solidFill>
@@ -5709,17 +5709,6 @@
                 <a:cs typeface="Sarabun"/>
               </a:rPr>
               <a:t>สวัสดี</a:t>
-            </a:r>
-            <a:r>
-              <a:rPr sz="2230" b="0" i="1" lang="en-US" altLang="en-US">
-                <a:solidFill>
-                  <a:srgbClr val="566873"/>
-                </a:solidFill>
-                <a:latin typeface="Sarabun"/>
-                <a:ea typeface="Sarabun"/>
-                <a:cs typeface="Sarabun"/>
-              </a:rPr>
-              <a:t> (sà-wàt-dii)</a:t>
             </a:r>
           </a:p>
         </p:txBody>
@@ -5732,7 +5721,7 @@
         </p:nvSpPr>
         <p:spPr>
           <a:xfrm>
-            <a:off x="1078992" y="2203704"/>
+            <a:off x="1078992" y="1828800"/>
             <a:ext cx="6613855" cy="274320"/>
           </a:xfrm>
           <a:prstGeom prst="rect">
@@ -5748,6 +5737,43 @@
           <a:p>
             <a:pPr algn="l"/>
             <a:r>
+              <a:rPr sz="1700" b="0" i="1" lang="en-US" altLang="en-US">
+                <a:solidFill>
+                  <a:srgbClr val="566873"/>
+                </a:solidFill>
+                <a:latin typeface="Sarabun"/>
+                <a:ea typeface="Sarabun"/>
+                <a:cs typeface="Sarabun"/>
+              </a:rPr>
+              <a:t>sà-wàt-dii</a:t>
+            </a:r>
+          </a:p>
+        </p:txBody>
+      </p:sp>
+      <p:sp>
+        <p:nvSpPr>
+          <p:cNvPr id="10" name="TextBox 9"/>
+          <p:cNvSpPr txBox="1"/>
+          <p:nvPr/>
+        </p:nvSpPr>
+        <p:spPr>
+          <a:xfrm>
+            <a:off x="1078992" y="2203704"/>
+            <a:ext cx="6613855" cy="274320"/>
+          </a:xfrm>
+          <a:prstGeom prst="rect">
+            <a:avLst/>
+          </a:prstGeom>
+          <a:noFill/>
+        </p:spPr>
+        <p:txBody>
+          <a:bodyPr wrap="square" anchor="t">
+            <a:spAutoFit/>
+          </a:bodyPr>
+          <a:lstStyle/>
+          <a:p>
+            <a:pPr algn="l"/>
+            <a:r>
               <a:rPr sz="1700" b="0" i="0" lang="en-US" altLang="en-US">
                 <a:solidFill>
                   <a:srgbClr val="82909A"/>
@@ -5763,7 +5789,7 @@
       </p:sp>
       <p:sp>
         <p:nvSpPr>
-          <p:cNvPr id="10" name="Rounded Rectangle 9"/>
+          <p:cNvPr id="11" name="Rounded Rectangle 10"/>
           <p:cNvSpPr/>
           <p:nvPr/>
         </p:nvSpPr>
@@ -5804,7 +5830,7 @@
       </p:sp>
       <p:sp>
         <p:nvSpPr>
-          <p:cNvPr id="11" name="Rectangle 10"/>
+          <p:cNvPr id="12" name="Rectangle 11"/>
           <p:cNvSpPr/>
           <p:nvPr/>
         </p:nvSpPr>
@@ -5847,14 +5873,14 @@
       </p:sp>
       <p:sp>
         <p:nvSpPr>
-          <p:cNvPr id="12" name="TextBox 11"/>
+          <p:cNvPr id="13" name="TextBox 12"/>
           <p:cNvSpPr txBox="1"/>
           <p:nvPr/>
         </p:nvSpPr>
         <p:spPr>
           <a:xfrm>
-            <a:off x="1078992" y="3191256"/>
-            <a:ext cx="6613855" cy="658368"/>
+            <a:off x="1078992" y="3218688"/>
+            <a:ext cx="6613855" cy="320040"/>
           </a:xfrm>
           <a:prstGeom prst="rect">
             <a:avLst/>
@@ -5869,7 +5895,7 @@
           <a:p>
             <a:pPr algn="l"/>
             <a:r>
-              <a:rPr sz="3600" b="1" i="0" lang="th-TH" altLang="en-US">
+              <a:rPr sz="1700" b="0" i="0" lang="th-TH" altLang="en-US">
                 <a:solidFill>
                   <a:srgbClr val="24333D"/>
                 </a:solidFill>
@@ -5879,29 +5905,18 @@
               </a:rPr>
               <a:t>สวัสดีครับ</a:t>
             </a:r>
-            <a:r>
-              <a:rPr sz="2230" b="0" i="1" lang="en-US" altLang="en-US">
-                <a:solidFill>
-                  <a:srgbClr val="566873"/>
-                </a:solidFill>
-                <a:latin typeface="Sarabun"/>
-                <a:ea typeface="Sarabun"/>
-                <a:cs typeface="Sarabun"/>
-              </a:rPr>
-              <a:t> (sà-wàt-dii khráp)</a:t>
-            </a:r>
-          </a:p>
-        </p:txBody>
-      </p:sp>
-      <p:sp>
-        <p:nvSpPr>
-          <p:cNvPr id="13" name="TextBox 12"/>
+          </a:p>
+        </p:txBody>
+      </p:sp>
+      <p:sp>
+        <p:nvSpPr>
+          <p:cNvPr id="14" name="TextBox 13"/>
           <p:cNvSpPr txBox="1"/>
           <p:nvPr/>
         </p:nvSpPr>
         <p:spPr>
           <a:xfrm>
-            <a:off x="1078992" y="3959352"/>
+            <a:off x="1078992" y="3584448"/>
             <a:ext cx="6613855" cy="274320"/>
           </a:xfrm>
           <a:prstGeom prst="rect">
@@ -5917,6 +5932,43 @@
           <a:p>
             <a:pPr algn="l"/>
             <a:r>
+              <a:rPr sz="1700" b="0" i="1" lang="en-US" altLang="en-US">
+                <a:solidFill>
+                  <a:srgbClr val="566873"/>
+                </a:solidFill>
+                <a:latin typeface="Sarabun"/>
+                <a:ea typeface="Sarabun"/>
+                <a:cs typeface="Sarabun"/>
+              </a:rPr>
+              <a:t>sà-wàt-dii khráp</a:t>
+            </a:r>
+          </a:p>
+        </p:txBody>
+      </p:sp>
+      <p:sp>
+        <p:nvSpPr>
+          <p:cNvPr id="15" name="TextBox 14"/>
+          <p:cNvSpPr txBox="1"/>
+          <p:nvPr/>
+        </p:nvSpPr>
+        <p:spPr>
+          <a:xfrm>
+            <a:off x="1078992" y="3959352"/>
+            <a:ext cx="6613855" cy="274320"/>
+          </a:xfrm>
+          <a:prstGeom prst="rect">
+            <a:avLst/>
+          </a:prstGeom>
+          <a:noFill/>
+        </p:spPr>
+        <p:txBody>
+          <a:bodyPr wrap="square" anchor="t">
+            <a:spAutoFit/>
+          </a:bodyPr>
+          <a:lstStyle/>
+          <a:p>
+            <a:pPr algn="l"/>
+            <a:r>
               <a:rPr sz="1700" b="0" i="0" lang="en-US" altLang="en-US">
                 <a:solidFill>
                   <a:srgbClr val="82909A"/>
@@ -5932,7 +5984,7 @@
       </p:sp>
       <p:sp>
         <p:nvSpPr>
-          <p:cNvPr id="14" name="Rounded Rectangle 13"/>
+          <p:cNvPr id="16" name="Rounded Rectangle 15"/>
           <p:cNvSpPr/>
           <p:nvPr/>
         </p:nvSpPr>
@@ -5973,7 +6025,7 @@
       </p:sp>
       <p:sp>
         <p:nvSpPr>
-          <p:cNvPr id="15" name="Rectangle 14"/>
+          <p:cNvPr id="17" name="Rectangle 16"/>
           <p:cNvSpPr/>
           <p:nvPr/>
         </p:nvSpPr>
@@ -6016,14 +6068,14 @@
       </p:sp>
       <p:sp>
         <p:nvSpPr>
-          <p:cNvPr id="16" name="TextBox 15"/>
+          <p:cNvPr id="18" name="TextBox 17"/>
           <p:cNvSpPr txBox="1"/>
           <p:nvPr/>
         </p:nvSpPr>
         <p:spPr>
           <a:xfrm>
-            <a:off x="1078992" y="4946904"/>
-            <a:ext cx="6613855" cy="658368"/>
+            <a:off x="1078992" y="4974336"/>
+            <a:ext cx="6613855" cy="320040"/>
           </a:xfrm>
           <a:prstGeom prst="rect">
             <a:avLst/>
@@ -6038,7 +6090,7 @@
           <a:p>
             <a:pPr algn="l"/>
             <a:r>
-              <a:rPr sz="3600" b="1" i="0" lang="th-TH" altLang="en-US">
+              <a:rPr sz="1700" b="0" i="0" lang="th-TH" altLang="en-US">
                 <a:solidFill>
                   <a:srgbClr val="24333D"/>
                 </a:solidFill>
@@ -6048,8 +6100,34 @@
               </a:rPr>
               <a:t>สวัสดีค่ะ</a:t>
             </a:r>
-            <a:r>
-              <a:rPr sz="2230" b="0" i="1" lang="en-US" altLang="en-US">
+          </a:p>
+        </p:txBody>
+      </p:sp>
+      <p:sp>
+        <p:nvSpPr>
+          <p:cNvPr id="19" name="TextBox 18"/>
+          <p:cNvSpPr txBox="1"/>
+          <p:nvPr/>
+        </p:nvSpPr>
+        <p:spPr>
+          <a:xfrm>
+            <a:off x="1078992" y="5340096"/>
+            <a:ext cx="6613855" cy="274320"/>
+          </a:xfrm>
+          <a:prstGeom prst="rect">
+            <a:avLst/>
+          </a:prstGeom>
+          <a:noFill/>
+        </p:spPr>
+        <p:txBody>
+          <a:bodyPr wrap="square" anchor="t">
+            <a:spAutoFit/>
+          </a:bodyPr>
+          <a:lstStyle/>
+          <a:p>
+            <a:pPr algn="l"/>
+            <a:r>
+              <a:rPr sz="1700" b="0" i="1" lang="en-US" altLang="en-US">
                 <a:solidFill>
                   <a:srgbClr val="566873"/>
                 </a:solidFill>
@@ -6057,14 +6135,14 @@
                 <a:ea typeface="Sarabun"/>
                 <a:cs typeface="Sarabun"/>
               </a:rPr>
-              <a:t> (sà-wàt-dii khâ)</a:t>
-            </a:r>
-          </a:p>
-        </p:txBody>
-      </p:sp>
-      <p:sp>
-        <p:nvSpPr>
-          <p:cNvPr id="17" name="TextBox 16"/>
+              <a:t>sà-wàt-dii khâ</a:t>
+            </a:r>
+          </a:p>
+        </p:txBody>
+      </p:sp>
+      <p:sp>
+        <p:nvSpPr>
+          <p:cNvPr id="20" name="TextBox 19"/>
           <p:cNvSpPr txBox="1"/>
           <p:nvPr/>
         </p:nvSpPr>
@@ -6391,8 +6469,8 @@
         </p:nvSpPr>
         <p:spPr>
           <a:xfrm>
-            <a:off x="1078992" y="1435608"/>
-            <a:ext cx="6613855" cy="658368"/>
+            <a:off x="1078992" y="1463040"/>
+            <a:ext cx="6613855" cy="320040"/>
           </a:xfrm>
           <a:prstGeom prst="rect">
             <a:avLst/>
@@ -6407,7 +6485,7 @@
           <a:p>
             <a:pPr algn="l"/>
             <a:r>
-              <a:rPr sz="3600" b="1" i="0" lang="th-TH" altLang="en-US">
+              <a:rPr sz="1700" b="0" i="0" lang="th-TH" altLang="en-US">
                 <a:solidFill>
                   <a:srgbClr val="24333D"/>
                 </a:solidFill>
@@ -6416,17 +6494,6 @@
                 <a:cs typeface="Sarabun"/>
               </a:rPr>
               <a:t>ขอบคุณ</a:t>
-            </a:r>
-            <a:r>
-              <a:rPr sz="2230" b="0" i="1" lang="en-US" altLang="en-US">
-                <a:solidFill>
-                  <a:srgbClr val="566873"/>
-                </a:solidFill>
-                <a:latin typeface="Sarabun"/>
-                <a:ea typeface="Sarabun"/>
-                <a:cs typeface="Sarabun"/>
-              </a:rPr>
-              <a:t> (khàawp-khun)</a:t>
             </a:r>
           </a:p>
         </p:txBody>
@@ -6439,7 +6506,7 @@
         </p:nvSpPr>
         <p:spPr>
           <a:xfrm>
-            <a:off x="1078992" y="2203704"/>
+            <a:off x="1078992" y="1828800"/>
             <a:ext cx="6613855" cy="274320"/>
           </a:xfrm>
           <a:prstGeom prst="rect">
@@ -6455,6 +6522,43 @@
           <a:p>
             <a:pPr algn="l"/>
             <a:r>
+              <a:rPr sz="1700" b="0" i="1" lang="en-US" altLang="en-US">
+                <a:solidFill>
+                  <a:srgbClr val="566873"/>
+                </a:solidFill>
+                <a:latin typeface="Sarabun"/>
+                <a:ea typeface="Sarabun"/>
+                <a:cs typeface="Sarabun"/>
+              </a:rPr>
+              <a:t>khàawp-khun</a:t>
+            </a:r>
+          </a:p>
+        </p:txBody>
+      </p:sp>
+      <p:sp>
+        <p:nvSpPr>
+          <p:cNvPr id="10" name="TextBox 9"/>
+          <p:cNvSpPr txBox="1"/>
+          <p:nvPr/>
+        </p:nvSpPr>
+        <p:spPr>
+          <a:xfrm>
+            <a:off x="1078992" y="2203704"/>
+            <a:ext cx="6613855" cy="274320"/>
+          </a:xfrm>
+          <a:prstGeom prst="rect">
+            <a:avLst/>
+          </a:prstGeom>
+          <a:noFill/>
+        </p:spPr>
+        <p:txBody>
+          <a:bodyPr wrap="square" anchor="t">
+            <a:spAutoFit/>
+          </a:bodyPr>
+          <a:lstStyle/>
+          <a:p>
+            <a:pPr algn="l"/>
+            <a:r>
               <a:rPr sz="1700" b="0" i="0" lang="en-US" altLang="en-US">
                 <a:solidFill>
                   <a:srgbClr val="82909A"/>
@@ -6470,7 +6574,7 @@
       </p:sp>
       <p:sp>
         <p:nvSpPr>
-          <p:cNvPr id="10" name="Rounded Rectangle 9"/>
+          <p:cNvPr id="11" name="Rounded Rectangle 10"/>
           <p:cNvSpPr/>
           <p:nvPr/>
         </p:nvSpPr>
@@ -6511,7 +6615,7 @@
       </p:sp>
       <p:sp>
         <p:nvSpPr>
-          <p:cNvPr id="11" name="Rectangle 10"/>
+          <p:cNvPr id="12" name="Rectangle 11"/>
           <p:cNvSpPr/>
           <p:nvPr/>
         </p:nvSpPr>
@@ -6554,14 +6658,14 @@
       </p:sp>
       <p:sp>
         <p:nvSpPr>
-          <p:cNvPr id="12" name="TextBox 11"/>
+          <p:cNvPr id="13" name="TextBox 12"/>
           <p:cNvSpPr txBox="1"/>
           <p:nvPr/>
         </p:nvSpPr>
         <p:spPr>
           <a:xfrm>
-            <a:off x="1078992" y="3191256"/>
-            <a:ext cx="6613855" cy="658368"/>
+            <a:off x="1078992" y="3218688"/>
+            <a:ext cx="6613855" cy="320040"/>
           </a:xfrm>
           <a:prstGeom prst="rect">
             <a:avLst/>
@@ -6576,7 +6680,7 @@
           <a:p>
             <a:pPr algn="l"/>
             <a:r>
-              <a:rPr sz="3600" b="1" i="0" lang="th-TH" altLang="en-US">
+              <a:rPr sz="1700" b="0" i="0" lang="th-TH" altLang="en-US">
                 <a:solidFill>
                   <a:srgbClr val="24333D"/>
                 </a:solidFill>
@@ -6586,29 +6690,18 @@
               </a:rPr>
               <a:t>ขอโทษ</a:t>
             </a:r>
-            <a:r>
-              <a:rPr sz="2230" b="0" i="1" lang="en-US" altLang="en-US">
-                <a:solidFill>
-                  <a:srgbClr val="566873"/>
-                </a:solidFill>
-                <a:latin typeface="Sarabun"/>
-                <a:ea typeface="Sarabun"/>
-                <a:cs typeface="Sarabun"/>
-              </a:rPr>
-              <a:t> (khǎaw-thôot)</a:t>
-            </a:r>
-          </a:p>
-        </p:txBody>
-      </p:sp>
-      <p:sp>
-        <p:nvSpPr>
-          <p:cNvPr id="13" name="TextBox 12"/>
+          </a:p>
+        </p:txBody>
+      </p:sp>
+      <p:sp>
+        <p:nvSpPr>
+          <p:cNvPr id="14" name="TextBox 13"/>
           <p:cNvSpPr txBox="1"/>
           <p:nvPr/>
         </p:nvSpPr>
         <p:spPr>
           <a:xfrm>
-            <a:off x="1078992" y="3959352"/>
+            <a:off x="1078992" y="3584448"/>
             <a:ext cx="6613855" cy="274320"/>
           </a:xfrm>
           <a:prstGeom prst="rect">
@@ -6624,6 +6717,43 @@
           <a:p>
             <a:pPr algn="l"/>
             <a:r>
+              <a:rPr sz="1700" b="0" i="1" lang="en-US" altLang="en-US">
+                <a:solidFill>
+                  <a:srgbClr val="566873"/>
+                </a:solidFill>
+                <a:latin typeface="Sarabun"/>
+                <a:ea typeface="Sarabun"/>
+                <a:cs typeface="Sarabun"/>
+              </a:rPr>
+              <a:t>khǎaw-thôot</a:t>
+            </a:r>
+          </a:p>
+        </p:txBody>
+      </p:sp>
+      <p:sp>
+        <p:nvSpPr>
+          <p:cNvPr id="15" name="TextBox 14"/>
+          <p:cNvSpPr txBox="1"/>
+          <p:nvPr/>
+        </p:nvSpPr>
+        <p:spPr>
+          <a:xfrm>
+            <a:off x="1078992" y="3959352"/>
+            <a:ext cx="6613855" cy="274320"/>
+          </a:xfrm>
+          <a:prstGeom prst="rect">
+            <a:avLst/>
+          </a:prstGeom>
+          <a:noFill/>
+        </p:spPr>
+        <p:txBody>
+          <a:bodyPr wrap="square" anchor="t">
+            <a:spAutoFit/>
+          </a:bodyPr>
+          <a:lstStyle/>
+          <a:p>
+            <a:pPr algn="l"/>
+            <a:r>
               <a:rPr sz="1700" b="0" i="0" lang="en-US" altLang="en-US">
                 <a:solidFill>
                   <a:srgbClr val="82909A"/>
@@ -6639,7 +6769,7 @@
       </p:sp>
       <p:sp>
         <p:nvSpPr>
-          <p:cNvPr id="14" name="Rounded Rectangle 13"/>
+          <p:cNvPr id="16" name="Rounded Rectangle 15"/>
           <p:cNvSpPr/>
           <p:nvPr/>
         </p:nvSpPr>
@@ -6680,7 +6810,7 @@
       </p:sp>
       <p:sp>
         <p:nvSpPr>
-          <p:cNvPr id="15" name="Rectangle 14"/>
+          <p:cNvPr id="17" name="Rectangle 16"/>
           <p:cNvSpPr/>
           <p:nvPr/>
         </p:nvSpPr>
@@ -6723,14 +6853,14 @@
       </p:sp>
       <p:sp>
         <p:nvSpPr>
-          <p:cNvPr id="16" name="TextBox 15"/>
+          <p:cNvPr id="18" name="TextBox 17"/>
           <p:cNvSpPr txBox="1"/>
           <p:nvPr/>
         </p:nvSpPr>
         <p:spPr>
           <a:xfrm>
-            <a:off x="1078992" y="4946904"/>
-            <a:ext cx="6613855" cy="658368"/>
+            <a:off x="1078992" y="4974336"/>
+            <a:ext cx="6613855" cy="320040"/>
           </a:xfrm>
           <a:prstGeom prst="rect">
             <a:avLst/>
@@ -6745,7 +6875,7 @@
           <a:p>
             <a:pPr algn="l"/>
             <a:r>
-              <a:rPr sz="3600" b="1" i="0" lang="th-TH" altLang="en-US">
+              <a:rPr sz="1700" b="0" i="0" lang="th-TH" altLang="en-US">
                 <a:solidFill>
                   <a:srgbClr val="24333D"/>
                 </a:solidFill>
@@ -6755,8 +6885,34 @@
               </a:rPr>
               <a:t>ไม่เป็นไร</a:t>
             </a:r>
-            <a:r>
-              <a:rPr sz="2230" b="0" i="1" lang="en-US" altLang="en-US">
+          </a:p>
+        </p:txBody>
+      </p:sp>
+      <p:sp>
+        <p:nvSpPr>
+          <p:cNvPr id="19" name="TextBox 18"/>
+          <p:cNvSpPr txBox="1"/>
+          <p:nvPr/>
+        </p:nvSpPr>
+        <p:spPr>
+          <a:xfrm>
+            <a:off x="1078992" y="5340096"/>
+            <a:ext cx="6613855" cy="274320"/>
+          </a:xfrm>
+          <a:prstGeom prst="rect">
+            <a:avLst/>
+          </a:prstGeom>
+          <a:noFill/>
+        </p:spPr>
+        <p:txBody>
+          <a:bodyPr wrap="square" anchor="t">
+            <a:spAutoFit/>
+          </a:bodyPr>
+          <a:lstStyle/>
+          <a:p>
+            <a:pPr algn="l"/>
+            <a:r>
+              <a:rPr sz="1700" b="0" i="1" lang="en-US" altLang="en-US">
                 <a:solidFill>
                   <a:srgbClr val="566873"/>
                 </a:solidFill>
@@ -6764,14 +6920,14 @@
                 <a:ea typeface="Sarabun"/>
                 <a:cs typeface="Sarabun"/>
               </a:rPr>
-              <a:t> (mâi bpen rai)</a:t>
-            </a:r>
-          </a:p>
-        </p:txBody>
-      </p:sp>
-      <p:sp>
-        <p:nvSpPr>
-          <p:cNvPr id="17" name="TextBox 16"/>
+              <a:t>mâi bpen rai</a:t>
+            </a:r>
+          </a:p>
+        </p:txBody>
+      </p:sp>
+      <p:sp>
+        <p:nvSpPr>
+          <p:cNvPr id="20" name="TextBox 19"/>
           <p:cNvSpPr txBox="1"/>
           <p:nvPr/>
         </p:nvSpPr>
@@ -7098,8 +7254,8 @@
         </p:nvSpPr>
         <p:spPr>
           <a:xfrm>
-            <a:off x="1078992" y="1435608"/>
-            <a:ext cx="6613855" cy="658368"/>
+            <a:off x="1078992" y="1463040"/>
+            <a:ext cx="6613855" cy="320040"/>
           </a:xfrm>
           <a:prstGeom prst="rect">
             <a:avLst/>
@@ -7114,7 +7270,7 @@
           <a:p>
             <a:pPr algn="l"/>
             <a:r>
-              <a:rPr sz="3600" b="1" i="0" lang="th-TH" altLang="en-US">
+              <a:rPr sz="1700" b="0" i="0" lang="th-TH" altLang="en-US">
                 <a:solidFill>
                   <a:srgbClr val="24333D"/>
                 </a:solidFill>
@@ -7123,17 +7279,6 @@
                 <a:cs typeface="Sarabun"/>
               </a:rPr>
               <a:t>ครับ</a:t>
-            </a:r>
-            <a:r>
-              <a:rPr sz="2230" b="0" i="1" lang="en-US" altLang="en-US">
-                <a:solidFill>
-                  <a:srgbClr val="566873"/>
-                </a:solidFill>
-                <a:latin typeface="Sarabun"/>
-                <a:ea typeface="Sarabun"/>
-                <a:cs typeface="Sarabun"/>
-              </a:rPr>
-              <a:t> (khráp)</a:t>
             </a:r>
           </a:p>
         </p:txBody>
@@ -7146,7 +7291,7 @@
         </p:nvSpPr>
         <p:spPr>
           <a:xfrm>
-            <a:off x="1078992" y="2203704"/>
+            <a:off x="1078992" y="1828800"/>
             <a:ext cx="6613855" cy="274320"/>
           </a:xfrm>
           <a:prstGeom prst="rect">
@@ -7162,6 +7307,43 @@
           <a:p>
             <a:pPr algn="l"/>
             <a:r>
+              <a:rPr sz="1700" b="0" i="1" lang="en-US" altLang="en-US">
+                <a:solidFill>
+                  <a:srgbClr val="566873"/>
+                </a:solidFill>
+                <a:latin typeface="Sarabun"/>
+                <a:ea typeface="Sarabun"/>
+                <a:cs typeface="Sarabun"/>
+              </a:rPr>
+              <a:t>khráp</a:t>
+            </a:r>
+          </a:p>
+        </p:txBody>
+      </p:sp>
+      <p:sp>
+        <p:nvSpPr>
+          <p:cNvPr id="10" name="TextBox 9"/>
+          <p:cNvSpPr txBox="1"/>
+          <p:nvPr/>
+        </p:nvSpPr>
+        <p:spPr>
+          <a:xfrm>
+            <a:off x="1078992" y="2203704"/>
+            <a:ext cx="6613855" cy="274320"/>
+          </a:xfrm>
+          <a:prstGeom prst="rect">
+            <a:avLst/>
+          </a:prstGeom>
+          <a:noFill/>
+        </p:spPr>
+        <p:txBody>
+          <a:bodyPr wrap="square" anchor="t">
+            <a:spAutoFit/>
+          </a:bodyPr>
+          <a:lstStyle/>
+          <a:p>
+            <a:pPr algn="l"/>
+            <a:r>
               <a:rPr sz="1700" b="0" i="0" lang="en-US" altLang="en-US">
                 <a:solidFill>
                   <a:srgbClr val="82909A"/>
@@ -7177,7 +7359,7 @@
       </p:sp>
       <p:sp>
         <p:nvSpPr>
-          <p:cNvPr id="10" name="Rounded Rectangle 9"/>
+          <p:cNvPr id="11" name="Rounded Rectangle 10"/>
           <p:cNvSpPr/>
           <p:nvPr/>
         </p:nvSpPr>
@@ -7218,7 +7400,7 @@
       </p:sp>
       <p:sp>
         <p:nvSpPr>
-          <p:cNvPr id="11" name="Rectangle 10"/>
+          <p:cNvPr id="12" name="Rectangle 11"/>
           <p:cNvSpPr/>
           <p:nvPr/>
         </p:nvSpPr>
@@ -7261,14 +7443,14 @@
       </p:sp>
       <p:sp>
         <p:nvSpPr>
-          <p:cNvPr id="12" name="TextBox 11"/>
+          <p:cNvPr id="13" name="TextBox 12"/>
           <p:cNvSpPr txBox="1"/>
           <p:nvPr/>
         </p:nvSpPr>
         <p:spPr>
           <a:xfrm>
-            <a:off x="1078992" y="3191256"/>
-            <a:ext cx="6613855" cy="658368"/>
+            <a:off x="1078992" y="3218688"/>
+            <a:ext cx="6613855" cy="320040"/>
           </a:xfrm>
           <a:prstGeom prst="rect">
             <a:avLst/>
@@ -7283,7 +7465,7 @@
           <a:p>
             <a:pPr algn="l"/>
             <a:r>
-              <a:rPr sz="3600" b="1" i="0" lang="th-TH" altLang="en-US">
+              <a:rPr sz="1700" b="0" i="0" lang="th-TH" altLang="en-US">
                 <a:solidFill>
                   <a:srgbClr val="24333D"/>
                 </a:solidFill>
@@ -7293,29 +7475,18 @@
               </a:rPr>
               <a:t>ค่ะ</a:t>
             </a:r>
-            <a:r>
-              <a:rPr sz="2230" b="0" i="1" lang="en-US" altLang="en-US">
-                <a:solidFill>
-                  <a:srgbClr val="566873"/>
-                </a:solidFill>
-                <a:latin typeface="Sarabun"/>
-                <a:ea typeface="Sarabun"/>
-                <a:cs typeface="Sarabun"/>
-              </a:rPr>
-              <a:t> (khâ)</a:t>
-            </a:r>
-          </a:p>
-        </p:txBody>
-      </p:sp>
-      <p:sp>
-        <p:nvSpPr>
-          <p:cNvPr id="13" name="TextBox 12"/>
+          </a:p>
+        </p:txBody>
+      </p:sp>
+      <p:sp>
+        <p:nvSpPr>
+          <p:cNvPr id="14" name="TextBox 13"/>
           <p:cNvSpPr txBox="1"/>
           <p:nvPr/>
         </p:nvSpPr>
         <p:spPr>
           <a:xfrm>
-            <a:off x="1078992" y="3959352"/>
+            <a:off x="1078992" y="3584448"/>
             <a:ext cx="6613855" cy="274320"/>
           </a:xfrm>
           <a:prstGeom prst="rect">
@@ -7331,6 +7502,43 @@
           <a:p>
             <a:pPr algn="l"/>
             <a:r>
+              <a:rPr sz="1700" b="0" i="1" lang="en-US" altLang="en-US">
+                <a:solidFill>
+                  <a:srgbClr val="566873"/>
+                </a:solidFill>
+                <a:latin typeface="Sarabun"/>
+                <a:ea typeface="Sarabun"/>
+                <a:cs typeface="Sarabun"/>
+              </a:rPr>
+              <a:t>khâ</a:t>
+            </a:r>
+          </a:p>
+        </p:txBody>
+      </p:sp>
+      <p:sp>
+        <p:nvSpPr>
+          <p:cNvPr id="15" name="TextBox 14"/>
+          <p:cNvSpPr txBox="1"/>
+          <p:nvPr/>
+        </p:nvSpPr>
+        <p:spPr>
+          <a:xfrm>
+            <a:off x="1078992" y="3959352"/>
+            <a:ext cx="6613855" cy="274320"/>
+          </a:xfrm>
+          <a:prstGeom prst="rect">
+            <a:avLst/>
+          </a:prstGeom>
+          <a:noFill/>
+        </p:spPr>
+        <p:txBody>
+          <a:bodyPr wrap="square" anchor="t">
+            <a:spAutoFit/>
+          </a:bodyPr>
+          <a:lstStyle/>
+          <a:p>
+            <a:pPr algn="l"/>
+            <a:r>
               <a:rPr sz="1700" b="0" i="0" lang="en-US" altLang="en-US">
                 <a:solidFill>
                   <a:srgbClr val="82909A"/>
@@ -7346,7 +7554,7 @@
       </p:sp>
       <p:sp>
         <p:nvSpPr>
-          <p:cNvPr id="14" name="Rounded Rectangle 13"/>
+          <p:cNvPr id="16" name="Rounded Rectangle 15"/>
           <p:cNvSpPr/>
           <p:nvPr/>
         </p:nvSpPr>
@@ -7387,7 +7595,7 @@
       </p:sp>
       <p:sp>
         <p:nvSpPr>
-          <p:cNvPr id="15" name="Rectangle 14"/>
+          <p:cNvPr id="17" name="Rectangle 16"/>
           <p:cNvSpPr/>
           <p:nvPr/>
         </p:nvSpPr>
@@ -7430,14 +7638,14 @@
       </p:sp>
       <p:sp>
         <p:nvSpPr>
-          <p:cNvPr id="16" name="TextBox 15"/>
+          <p:cNvPr id="18" name="TextBox 17"/>
           <p:cNvSpPr txBox="1"/>
           <p:nvPr/>
         </p:nvSpPr>
         <p:spPr>
           <a:xfrm>
-            <a:off x="1078992" y="4946904"/>
-            <a:ext cx="6613855" cy="658368"/>
+            <a:off x="1078992" y="4974336"/>
+            <a:ext cx="6613855" cy="320040"/>
           </a:xfrm>
           <a:prstGeom prst="rect">
             <a:avLst/>
@@ -7452,7 +7660,7 @@
           <a:p>
             <a:pPr algn="l"/>
             <a:r>
-              <a:rPr sz="3600" b="1" i="0" lang="th-TH" altLang="en-US">
+              <a:rPr sz="1700" b="0" i="0" lang="th-TH" altLang="en-US">
                 <a:solidFill>
                   <a:srgbClr val="24333D"/>
                 </a:solidFill>
@@ -7462,8 +7670,34 @@
               </a:rPr>
               <a:t>คะ</a:t>
             </a:r>
-            <a:r>
-              <a:rPr sz="2230" b="0" i="1" lang="en-US" altLang="en-US">
+          </a:p>
+        </p:txBody>
+      </p:sp>
+      <p:sp>
+        <p:nvSpPr>
+          <p:cNvPr id="19" name="TextBox 18"/>
+          <p:cNvSpPr txBox="1"/>
+          <p:nvPr/>
+        </p:nvSpPr>
+        <p:spPr>
+          <a:xfrm>
+            <a:off x="1078992" y="5340096"/>
+            <a:ext cx="6613855" cy="274320"/>
+          </a:xfrm>
+          <a:prstGeom prst="rect">
+            <a:avLst/>
+          </a:prstGeom>
+          <a:noFill/>
+        </p:spPr>
+        <p:txBody>
+          <a:bodyPr wrap="square" anchor="t">
+            <a:spAutoFit/>
+          </a:bodyPr>
+          <a:lstStyle/>
+          <a:p>
+            <a:pPr algn="l"/>
+            <a:r>
+              <a:rPr sz="1700" b="0" i="1" lang="en-US" altLang="en-US">
                 <a:solidFill>
                   <a:srgbClr val="566873"/>
                 </a:solidFill>
@@ -7471,14 +7705,14 @@
                 <a:ea typeface="Sarabun"/>
                 <a:cs typeface="Sarabun"/>
               </a:rPr>
-              <a:t> (khá)</a:t>
-            </a:r>
-          </a:p>
-        </p:txBody>
-      </p:sp>
-      <p:sp>
-        <p:nvSpPr>
-          <p:cNvPr id="17" name="TextBox 16"/>
+              <a:t>khá</a:t>
+            </a:r>
+          </a:p>
+        </p:txBody>
+      </p:sp>
+      <p:sp>
+        <p:nvSpPr>
+          <p:cNvPr id="20" name="TextBox 19"/>
           <p:cNvSpPr txBox="1"/>
           <p:nvPr/>
         </p:nvSpPr>
@@ -7805,8 +8039,8 @@
         </p:nvSpPr>
         <p:spPr>
           <a:xfrm>
-            <a:off x="1078992" y="1435608"/>
-            <a:ext cx="6613855" cy="658368"/>
+            <a:off x="1078992" y="1463040"/>
+            <a:ext cx="6613855" cy="320040"/>
           </a:xfrm>
           <a:prstGeom prst="rect">
             <a:avLst/>
@@ -7821,7 +8055,7 @@
           <a:p>
             <a:pPr algn="l"/>
             <a:r>
-              <a:rPr sz="3600" b="1" i="0" lang="th-TH" altLang="en-US">
+              <a:rPr sz="1700" b="0" i="0" lang="th-TH" altLang="en-US">
                 <a:solidFill>
                   <a:srgbClr val="24333D"/>
                 </a:solidFill>
@@ -7830,17 +8064,6 @@
                 <a:cs typeface="Sarabun"/>
               </a:rPr>
               <a:t>ใช่</a:t>
-            </a:r>
-            <a:r>
-              <a:rPr sz="2230" b="0" i="1" lang="en-US" altLang="en-US">
-                <a:solidFill>
-                  <a:srgbClr val="566873"/>
-                </a:solidFill>
-                <a:latin typeface="Sarabun"/>
-                <a:ea typeface="Sarabun"/>
-                <a:cs typeface="Sarabun"/>
-              </a:rPr>
-              <a:t> (châi)</a:t>
             </a:r>
           </a:p>
         </p:txBody>
@@ -7853,7 +8076,7 @@
         </p:nvSpPr>
         <p:spPr>
           <a:xfrm>
-            <a:off x="1078992" y="2203704"/>
+            <a:off x="1078992" y="1828800"/>
             <a:ext cx="6613855" cy="274320"/>
           </a:xfrm>
           <a:prstGeom prst="rect">
@@ -7869,6 +8092,43 @@
           <a:p>
             <a:pPr algn="l"/>
             <a:r>
+              <a:rPr sz="1700" b="0" i="1" lang="en-US" altLang="en-US">
+                <a:solidFill>
+                  <a:srgbClr val="566873"/>
+                </a:solidFill>
+                <a:latin typeface="Sarabun"/>
+                <a:ea typeface="Sarabun"/>
+                <a:cs typeface="Sarabun"/>
+              </a:rPr>
+              <a:t>châi</a:t>
+            </a:r>
+          </a:p>
+        </p:txBody>
+      </p:sp>
+      <p:sp>
+        <p:nvSpPr>
+          <p:cNvPr id="10" name="TextBox 9"/>
+          <p:cNvSpPr txBox="1"/>
+          <p:nvPr/>
+        </p:nvSpPr>
+        <p:spPr>
+          <a:xfrm>
+            <a:off x="1078992" y="2203704"/>
+            <a:ext cx="6613855" cy="274320"/>
+          </a:xfrm>
+          <a:prstGeom prst="rect">
+            <a:avLst/>
+          </a:prstGeom>
+          <a:noFill/>
+        </p:spPr>
+        <p:txBody>
+          <a:bodyPr wrap="square" anchor="t">
+            <a:spAutoFit/>
+          </a:bodyPr>
+          <a:lstStyle/>
+          <a:p>
+            <a:pPr algn="l"/>
+            <a:r>
               <a:rPr sz="1700" b="0" i="0" lang="en-US" altLang="en-US">
                 <a:solidFill>
                   <a:srgbClr val="82909A"/>
@@ -7884,7 +8144,7 @@
       </p:sp>
       <p:sp>
         <p:nvSpPr>
-          <p:cNvPr id="10" name="Rounded Rectangle 9"/>
+          <p:cNvPr id="11" name="Rounded Rectangle 10"/>
           <p:cNvSpPr/>
           <p:nvPr/>
         </p:nvSpPr>
@@ -7925,7 +8185,7 @@
       </p:sp>
       <p:sp>
         <p:nvSpPr>
-          <p:cNvPr id="11" name="Rectangle 10"/>
+          <p:cNvPr id="12" name="Rectangle 11"/>
           <p:cNvSpPr/>
           <p:nvPr/>
         </p:nvSpPr>
@@ -7968,14 +8228,14 @@
       </p:sp>
       <p:sp>
         <p:nvSpPr>
-          <p:cNvPr id="12" name="TextBox 11"/>
+          <p:cNvPr id="13" name="TextBox 12"/>
           <p:cNvSpPr txBox="1"/>
           <p:nvPr/>
         </p:nvSpPr>
         <p:spPr>
           <a:xfrm>
-            <a:off x="1078992" y="3191256"/>
-            <a:ext cx="6613855" cy="658368"/>
+            <a:off x="1078992" y="3218688"/>
+            <a:ext cx="6613855" cy="320040"/>
           </a:xfrm>
           <a:prstGeom prst="rect">
             <a:avLst/>
@@ -7990,7 +8250,7 @@
           <a:p>
             <a:pPr algn="l"/>
             <a:r>
-              <a:rPr sz="3600" b="1" i="0" lang="th-TH" altLang="en-US">
+              <a:rPr sz="1700" b="0" i="0" lang="th-TH" altLang="en-US">
                 <a:solidFill>
                   <a:srgbClr val="24333D"/>
                 </a:solidFill>
@@ -8000,29 +8260,18 @@
               </a:rPr>
               <a:t>ไม่ใช่</a:t>
             </a:r>
-            <a:r>
-              <a:rPr sz="2230" b="0" i="1" lang="en-US" altLang="en-US">
-                <a:solidFill>
-                  <a:srgbClr val="566873"/>
-                </a:solidFill>
-                <a:latin typeface="Sarabun"/>
-                <a:ea typeface="Sarabun"/>
-                <a:cs typeface="Sarabun"/>
-              </a:rPr>
-              <a:t> (mâi châi)</a:t>
-            </a:r>
-          </a:p>
-        </p:txBody>
-      </p:sp>
-      <p:sp>
-        <p:nvSpPr>
-          <p:cNvPr id="13" name="TextBox 12"/>
+          </a:p>
+        </p:txBody>
+      </p:sp>
+      <p:sp>
+        <p:nvSpPr>
+          <p:cNvPr id="14" name="TextBox 13"/>
           <p:cNvSpPr txBox="1"/>
           <p:nvPr/>
         </p:nvSpPr>
         <p:spPr>
           <a:xfrm>
-            <a:off x="1078992" y="3959352"/>
+            <a:off x="1078992" y="3584448"/>
             <a:ext cx="6613855" cy="274320"/>
           </a:xfrm>
           <a:prstGeom prst="rect">
@@ -8038,6 +8287,43 @@
           <a:p>
             <a:pPr algn="l"/>
             <a:r>
+              <a:rPr sz="1700" b="0" i="1" lang="en-US" altLang="en-US">
+                <a:solidFill>
+                  <a:srgbClr val="566873"/>
+                </a:solidFill>
+                <a:latin typeface="Sarabun"/>
+                <a:ea typeface="Sarabun"/>
+                <a:cs typeface="Sarabun"/>
+              </a:rPr>
+              <a:t>mâi châi</a:t>
+            </a:r>
+          </a:p>
+        </p:txBody>
+      </p:sp>
+      <p:sp>
+        <p:nvSpPr>
+          <p:cNvPr id="15" name="TextBox 14"/>
+          <p:cNvSpPr txBox="1"/>
+          <p:nvPr/>
+        </p:nvSpPr>
+        <p:spPr>
+          <a:xfrm>
+            <a:off x="1078992" y="3959352"/>
+            <a:ext cx="6613855" cy="274320"/>
+          </a:xfrm>
+          <a:prstGeom prst="rect">
+            <a:avLst/>
+          </a:prstGeom>
+          <a:noFill/>
+        </p:spPr>
+        <p:txBody>
+          <a:bodyPr wrap="square" anchor="t">
+            <a:spAutoFit/>
+          </a:bodyPr>
+          <a:lstStyle/>
+          <a:p>
+            <a:pPr algn="l"/>
+            <a:r>
               <a:rPr sz="1700" b="0" i="0" lang="en-US" altLang="en-US">
                 <a:solidFill>
                   <a:srgbClr val="82909A"/>
@@ -8053,7 +8339,7 @@
       </p:sp>
       <p:sp>
         <p:nvSpPr>
-          <p:cNvPr id="14" name="Rounded Rectangle 13"/>
+          <p:cNvPr id="16" name="Rounded Rectangle 15"/>
           <p:cNvSpPr/>
           <p:nvPr/>
         </p:nvSpPr>
@@ -8094,7 +8380,7 @@
       </p:sp>
       <p:sp>
         <p:nvSpPr>
-          <p:cNvPr id="15" name="Rectangle 14"/>
+          <p:cNvPr id="17" name="Rectangle 16"/>
           <p:cNvSpPr/>
           <p:nvPr/>
         </p:nvSpPr>
@@ -8137,14 +8423,14 @@
       </p:sp>
       <p:sp>
         <p:nvSpPr>
-          <p:cNvPr id="16" name="TextBox 15"/>
+          <p:cNvPr id="18" name="TextBox 17"/>
           <p:cNvSpPr txBox="1"/>
           <p:nvPr/>
         </p:nvSpPr>
         <p:spPr>
           <a:xfrm>
-            <a:off x="1078992" y="4946904"/>
-            <a:ext cx="6613855" cy="658368"/>
+            <a:off x="1078992" y="4974336"/>
+            <a:ext cx="6613855" cy="320040"/>
           </a:xfrm>
           <a:prstGeom prst="rect">
             <a:avLst/>
@@ -8159,7 +8445,7 @@
           <a:p>
             <a:pPr algn="l"/>
             <a:r>
-              <a:rPr sz="3600" b="1" i="0" lang="th-TH" altLang="en-US">
+              <a:rPr sz="1700" b="0" i="0" lang="th-TH" altLang="en-US">
                 <a:solidFill>
                   <a:srgbClr val="24333D"/>
                 </a:solidFill>
@@ -8169,8 +8455,34 @@
               </a:rPr>
               <a:t>ไม่เป็นไร</a:t>
             </a:r>
-            <a:r>
-              <a:rPr sz="2230" b="0" i="1" lang="en-US" altLang="en-US">
+          </a:p>
+        </p:txBody>
+      </p:sp>
+      <p:sp>
+        <p:nvSpPr>
+          <p:cNvPr id="19" name="TextBox 18"/>
+          <p:cNvSpPr txBox="1"/>
+          <p:nvPr/>
+        </p:nvSpPr>
+        <p:spPr>
+          <a:xfrm>
+            <a:off x="1078992" y="5340096"/>
+            <a:ext cx="6613855" cy="274320"/>
+          </a:xfrm>
+          <a:prstGeom prst="rect">
+            <a:avLst/>
+          </a:prstGeom>
+          <a:noFill/>
+        </p:spPr>
+        <p:txBody>
+          <a:bodyPr wrap="square" anchor="t">
+            <a:spAutoFit/>
+          </a:bodyPr>
+          <a:lstStyle/>
+          <a:p>
+            <a:pPr algn="l"/>
+            <a:r>
+              <a:rPr sz="1700" b="0" i="1" lang="en-US" altLang="en-US">
                 <a:solidFill>
                   <a:srgbClr val="566873"/>
                 </a:solidFill>
@@ -8178,14 +8490,14 @@
                 <a:ea typeface="Sarabun"/>
                 <a:cs typeface="Sarabun"/>
               </a:rPr>
-              <a:t> (mâi bpen rai)</a:t>
-            </a:r>
-          </a:p>
-        </p:txBody>
-      </p:sp>
-      <p:sp>
-        <p:nvSpPr>
-          <p:cNvPr id="17" name="TextBox 16"/>
+              <a:t>mâi bpen rai</a:t>
+            </a:r>
+          </a:p>
+        </p:txBody>
+      </p:sp>
+      <p:sp>
+        <p:nvSpPr>
+          <p:cNvPr id="20" name="TextBox 19"/>
           <p:cNvSpPr txBox="1"/>
           <p:nvPr/>
         </p:nvSpPr>
@@ -8512,8 +8824,8 @@
         </p:nvSpPr>
         <p:spPr>
           <a:xfrm>
-            <a:off x="1078992" y="1435608"/>
-            <a:ext cx="6613855" cy="658368"/>
+            <a:off x="1078992" y="1463040"/>
+            <a:ext cx="6613855" cy="320040"/>
           </a:xfrm>
           <a:prstGeom prst="rect">
             <a:avLst/>
@@ -8528,7 +8840,7 @@
           <a:p>
             <a:pPr algn="l"/>
             <a:r>
-              <a:rPr sz="3600" b="1" i="0" lang="th-TH" altLang="en-US">
+              <a:rPr sz="1700" b="0" i="0" lang="th-TH" altLang="en-US">
                 <a:solidFill>
                   <a:srgbClr val="24333D"/>
                 </a:solidFill>
@@ -8537,17 +8849,6 @@
                 <a:cs typeface="Sarabun"/>
               </a:rPr>
               <a:t>ครับ</a:t>
-            </a:r>
-            <a:r>
-              <a:rPr sz="2230" b="0" i="1" lang="en-US" altLang="en-US">
-                <a:solidFill>
-                  <a:srgbClr val="566873"/>
-                </a:solidFill>
-                <a:latin typeface="Sarabun"/>
-                <a:ea typeface="Sarabun"/>
-                <a:cs typeface="Sarabun"/>
-              </a:rPr>
-              <a:t> (khráp)</a:t>
             </a:r>
           </a:p>
         </p:txBody>
@@ -8560,7 +8861,7 @@
         </p:nvSpPr>
         <p:spPr>
           <a:xfrm>
-            <a:off x="1078992" y="2203704"/>
+            <a:off x="1078992" y="1828800"/>
             <a:ext cx="6613855" cy="274320"/>
           </a:xfrm>
           <a:prstGeom prst="rect">
@@ -8576,6 +8877,43 @@
           <a:p>
             <a:pPr algn="l"/>
             <a:r>
+              <a:rPr sz="1700" b="0" i="1" lang="en-US" altLang="en-US">
+                <a:solidFill>
+                  <a:srgbClr val="566873"/>
+                </a:solidFill>
+                <a:latin typeface="Sarabun"/>
+                <a:ea typeface="Sarabun"/>
+                <a:cs typeface="Sarabun"/>
+              </a:rPr>
+              <a:t>khráp</a:t>
+            </a:r>
+          </a:p>
+        </p:txBody>
+      </p:sp>
+      <p:sp>
+        <p:nvSpPr>
+          <p:cNvPr id="10" name="TextBox 9"/>
+          <p:cNvSpPr txBox="1"/>
+          <p:nvPr/>
+        </p:nvSpPr>
+        <p:spPr>
+          <a:xfrm>
+            <a:off x="1078992" y="2203704"/>
+            <a:ext cx="6613855" cy="274320"/>
+          </a:xfrm>
+          <a:prstGeom prst="rect">
+            <a:avLst/>
+          </a:prstGeom>
+          <a:noFill/>
+        </p:spPr>
+        <p:txBody>
+          <a:bodyPr wrap="square" anchor="t">
+            <a:spAutoFit/>
+          </a:bodyPr>
+          <a:lstStyle/>
+          <a:p>
+            <a:pPr algn="l"/>
+            <a:r>
               <a:rPr sz="1700" b="0" i="0" lang="en-US" altLang="en-US">
                 <a:solidFill>
                   <a:srgbClr val="82909A"/>
@@ -8591,7 +8929,7 @@
       </p:sp>
       <p:sp>
         <p:nvSpPr>
-          <p:cNvPr id="10" name="Rounded Rectangle 9"/>
+          <p:cNvPr id="11" name="Rounded Rectangle 10"/>
           <p:cNvSpPr/>
           <p:nvPr/>
         </p:nvSpPr>
@@ -8632,7 +8970,7 @@
       </p:sp>
       <p:sp>
         <p:nvSpPr>
-          <p:cNvPr id="11" name="Rectangle 10"/>
+          <p:cNvPr id="12" name="Rectangle 11"/>
           <p:cNvSpPr/>
           <p:nvPr/>
         </p:nvSpPr>
@@ -8675,14 +9013,14 @@
       </p:sp>
       <p:sp>
         <p:nvSpPr>
-          <p:cNvPr id="12" name="TextBox 11"/>
+          <p:cNvPr id="13" name="TextBox 12"/>
           <p:cNvSpPr txBox="1"/>
           <p:nvPr/>
         </p:nvSpPr>
         <p:spPr>
           <a:xfrm>
-            <a:off x="1078992" y="3191256"/>
-            <a:ext cx="6613855" cy="658368"/>
+            <a:off x="1078992" y="3218688"/>
+            <a:ext cx="6613855" cy="320040"/>
           </a:xfrm>
           <a:prstGeom prst="rect">
             <a:avLst/>
@@ -8697,7 +9035,7 @@
           <a:p>
             <a:pPr algn="l"/>
             <a:r>
-              <a:rPr sz="3600" b="1" i="0" lang="th-TH" altLang="en-US">
+              <a:rPr sz="1700" b="0" i="0" lang="th-TH" altLang="en-US">
                 <a:solidFill>
                   <a:srgbClr val="24333D"/>
                 </a:solidFill>
@@ -8707,29 +9045,18 @@
               </a:rPr>
               <a:t>ค่ะ</a:t>
             </a:r>
-            <a:r>
-              <a:rPr sz="2230" b="0" i="1" lang="en-US" altLang="en-US">
-                <a:solidFill>
-                  <a:srgbClr val="566873"/>
-                </a:solidFill>
-                <a:latin typeface="Sarabun"/>
-                <a:ea typeface="Sarabun"/>
-                <a:cs typeface="Sarabun"/>
-              </a:rPr>
-              <a:t> (khâ)</a:t>
-            </a:r>
-          </a:p>
-        </p:txBody>
-      </p:sp>
-      <p:sp>
-        <p:nvSpPr>
-          <p:cNvPr id="13" name="TextBox 12"/>
+          </a:p>
+        </p:txBody>
+      </p:sp>
+      <p:sp>
+        <p:nvSpPr>
+          <p:cNvPr id="14" name="TextBox 13"/>
           <p:cNvSpPr txBox="1"/>
           <p:nvPr/>
         </p:nvSpPr>
         <p:spPr>
           <a:xfrm>
-            <a:off x="1078992" y="3959352"/>
+            <a:off x="1078992" y="3584448"/>
             <a:ext cx="6613855" cy="274320"/>
           </a:xfrm>
           <a:prstGeom prst="rect">
@@ -8745,6 +9072,43 @@
           <a:p>
             <a:pPr algn="l"/>
             <a:r>
+              <a:rPr sz="1700" b="0" i="1" lang="en-US" altLang="en-US">
+                <a:solidFill>
+                  <a:srgbClr val="566873"/>
+                </a:solidFill>
+                <a:latin typeface="Sarabun"/>
+                <a:ea typeface="Sarabun"/>
+                <a:cs typeface="Sarabun"/>
+              </a:rPr>
+              <a:t>khâ</a:t>
+            </a:r>
+          </a:p>
+        </p:txBody>
+      </p:sp>
+      <p:sp>
+        <p:nvSpPr>
+          <p:cNvPr id="15" name="TextBox 14"/>
+          <p:cNvSpPr txBox="1"/>
+          <p:nvPr/>
+        </p:nvSpPr>
+        <p:spPr>
+          <a:xfrm>
+            <a:off x="1078992" y="3959352"/>
+            <a:ext cx="6613855" cy="274320"/>
+          </a:xfrm>
+          <a:prstGeom prst="rect">
+            <a:avLst/>
+          </a:prstGeom>
+          <a:noFill/>
+        </p:spPr>
+        <p:txBody>
+          <a:bodyPr wrap="square" anchor="t">
+            <a:spAutoFit/>
+          </a:bodyPr>
+          <a:lstStyle/>
+          <a:p>
+            <a:pPr algn="l"/>
+            <a:r>
               <a:rPr sz="1700" b="0" i="0" lang="en-US" altLang="en-US">
                 <a:solidFill>
                   <a:srgbClr val="82909A"/>
@@ -8760,7 +9124,7 @@
       </p:sp>
       <p:sp>
         <p:nvSpPr>
-          <p:cNvPr id="14" name="Rounded Rectangle 13"/>
+          <p:cNvPr id="16" name="Rounded Rectangle 15"/>
           <p:cNvSpPr/>
           <p:nvPr/>
         </p:nvSpPr>
@@ -8801,7 +9165,7 @@
       </p:sp>
       <p:sp>
         <p:nvSpPr>
-          <p:cNvPr id="15" name="Rectangle 14"/>
+          <p:cNvPr id="17" name="Rectangle 16"/>
           <p:cNvSpPr/>
           <p:nvPr/>
         </p:nvSpPr>
@@ -8844,14 +9208,14 @@
       </p:sp>
       <p:sp>
         <p:nvSpPr>
-          <p:cNvPr id="16" name="TextBox 15"/>
+          <p:cNvPr id="18" name="TextBox 17"/>
           <p:cNvSpPr txBox="1"/>
           <p:nvPr/>
         </p:nvSpPr>
         <p:spPr>
           <a:xfrm>
-            <a:off x="1078992" y="4946904"/>
-            <a:ext cx="6613855" cy="658368"/>
+            <a:off x="1078992" y="4974336"/>
+            <a:ext cx="6613855" cy="320040"/>
           </a:xfrm>
           <a:prstGeom prst="rect">
             <a:avLst/>
@@ -8866,7 +9230,7 @@
           <a:p>
             <a:pPr algn="l"/>
             <a:r>
-              <a:rPr sz="3600" b="1" i="0" lang="th-TH" altLang="en-US">
+              <a:rPr sz="1700" b="0" i="0" lang="th-TH" altLang="en-US">
                 <a:solidFill>
                   <a:srgbClr val="24333D"/>
                 </a:solidFill>
@@ -8876,8 +9240,34 @@
               </a:rPr>
               <a:t>ขอบคุณ</a:t>
             </a:r>
-            <a:r>
-              <a:rPr sz="2230" b="0" i="1" lang="en-US" altLang="en-US">
+          </a:p>
+        </p:txBody>
+      </p:sp>
+      <p:sp>
+        <p:nvSpPr>
+          <p:cNvPr id="19" name="TextBox 18"/>
+          <p:cNvSpPr txBox="1"/>
+          <p:nvPr/>
+        </p:nvSpPr>
+        <p:spPr>
+          <a:xfrm>
+            <a:off x="1078992" y="5340096"/>
+            <a:ext cx="6613855" cy="274320"/>
+          </a:xfrm>
+          <a:prstGeom prst="rect">
+            <a:avLst/>
+          </a:prstGeom>
+          <a:noFill/>
+        </p:spPr>
+        <p:txBody>
+          <a:bodyPr wrap="square" anchor="t">
+            <a:spAutoFit/>
+          </a:bodyPr>
+          <a:lstStyle/>
+          <a:p>
+            <a:pPr algn="l"/>
+            <a:r>
+              <a:rPr sz="1700" b="0" i="1" lang="en-US" altLang="en-US">
                 <a:solidFill>
                   <a:srgbClr val="566873"/>
                 </a:solidFill>
@@ -8885,14 +9275,14 @@
                 <a:ea typeface="Sarabun"/>
                 <a:cs typeface="Sarabun"/>
               </a:rPr>
-              <a:t> (khàawp-khun)</a:t>
-            </a:r>
-          </a:p>
-        </p:txBody>
-      </p:sp>
-      <p:sp>
-        <p:nvSpPr>
-          <p:cNvPr id="17" name="TextBox 16"/>
+              <a:t>khàawp-khun</a:t>
+            </a:r>
+          </a:p>
+        </p:txBody>
+      </p:sp>
+      <p:sp>
+        <p:nvSpPr>
+          <p:cNvPr id="20" name="TextBox 19"/>
           <p:cNvSpPr txBox="1"/>
           <p:nvPr/>
         </p:nvSpPr>
@@ -9192,7 +9582,7 @@
         <p:spPr>
           <a:xfrm>
             <a:off x="1965960" y="1069848"/>
-            <a:ext cx="5836615" cy="384048"/>
+            <a:ext cx="5836615" cy="228600"/>
           </a:xfrm>
           <a:prstGeom prst="rect">
             <a:avLst/>
@@ -9207,7 +9597,7 @@
           <a:p>
             <a:pPr algn="l"/>
             <a:r>
-              <a:rPr sz="2600" b="1" i="0" lang="th-TH" altLang="en-US">
+              <a:rPr sz="1700" b="0" i="0" lang="th-TH" altLang="en-US">
                 <a:solidFill>
                   <a:srgbClr val="24333D"/>
                 </a:solidFill>
@@ -9216,17 +9606,6 @@
                 <a:cs typeface="Sarabun"/>
               </a:rPr>
               <a:t>ขอโทษครับ สวัสดีครับ</a:t>
-            </a:r>
-            <a:r>
-              <a:rPr sz="1700" b="0" i="1" lang="en-US" altLang="en-US">
-                <a:solidFill>
-                  <a:srgbClr val="566873"/>
-                </a:solidFill>
-                <a:latin typeface="Sarabun"/>
-                <a:ea typeface="Sarabun"/>
-                <a:cs typeface="Sarabun"/>
-              </a:rPr>
-              <a:t> (khǎaw-thôot khráp sà-wàt-dii khráp)</a:t>
             </a:r>
           </a:p>
         </p:txBody>
@@ -9239,8 +9618,8 @@
         </p:nvSpPr>
         <p:spPr>
           <a:xfrm>
-            <a:off x="1965960" y="1353312"/>
-            <a:ext cx="5836615" cy="228600"/>
+            <a:off x="1965960" y="1298448"/>
+            <a:ext cx="5836615" cy="201168"/>
           </a:xfrm>
           <a:prstGeom prst="rect">
             <a:avLst/>
@@ -9255,7 +9634,7 @@
           <a:p>
             <a:pPr algn="l"/>
             <a:r>
-              <a:rPr sz="1300" b="0" i="0" lang="en-US" altLang="en-US">
+              <a:rPr sz="1700" b="0" i="1" lang="en-US" altLang="en-US">
                 <a:solidFill>
                   <a:srgbClr val="566873"/>
                 </a:solidFill>
@@ -9263,6 +9642,43 @@
                 <a:ea typeface="Sarabun"/>
                 <a:cs typeface="Sarabun"/>
               </a:rPr>
+              <a:t>khǎaw-thôot khráp sà-wàt-dii khráp</a:t>
+            </a:r>
+          </a:p>
+        </p:txBody>
+      </p:sp>
+      <p:sp>
+        <p:nvSpPr>
+          <p:cNvPr id="9" name="TextBox 8"/>
+          <p:cNvSpPr txBox="1"/>
+          <p:nvPr/>
+        </p:nvSpPr>
+        <p:spPr>
+          <a:xfrm>
+            <a:off x="1965960" y="1499616"/>
+            <a:ext cx="5836615" cy="201168"/>
+          </a:xfrm>
+          <a:prstGeom prst="rect">
+            <a:avLst/>
+          </a:prstGeom>
+          <a:noFill/>
+        </p:spPr>
+        <p:txBody>
+          <a:bodyPr wrap="square" anchor="t">
+            <a:spAutoFit/>
+          </a:bodyPr>
+          <a:lstStyle/>
+          <a:p>
+            <a:pPr algn="l"/>
+            <a:r>
+              <a:rPr sz="1700" b="0" i="0" lang="en-US" altLang="en-US">
+                <a:solidFill>
+                  <a:srgbClr val="566873"/>
+                </a:solidFill>
+                <a:latin typeface="Sarabun"/>
+                <a:ea typeface="Sarabun"/>
+                <a:cs typeface="Sarabun"/>
+              </a:rPr>
               <a:t>Excuse me, hello.</a:t>
             </a:r>
           </a:p>
@@ -9270,13 +9686,13 @@
       </p:sp>
       <p:sp>
         <p:nvSpPr>
-          <p:cNvPr id="9" name="Rounded Rectangle 8"/>
+          <p:cNvPr id="10" name="Rounded Rectangle 9"/>
           <p:cNvSpPr/>
           <p:nvPr/>
         </p:nvSpPr>
         <p:spPr>
           <a:xfrm>
-            <a:off x="731520" y="1874520"/>
+            <a:off x="731520" y="2011680"/>
             <a:ext cx="1051560" cy="274320"/>
           </a:xfrm>
           <a:prstGeom prst="roundRect">
@@ -9326,14 +9742,14 @@
       </p:sp>
       <p:sp>
         <p:nvSpPr>
-          <p:cNvPr id="10" name="TextBox 9"/>
+          <p:cNvPr id="11" name="TextBox 10"/>
           <p:cNvSpPr txBox="1"/>
           <p:nvPr/>
         </p:nvSpPr>
         <p:spPr>
           <a:xfrm>
-            <a:off x="1965960" y="1847088"/>
-            <a:ext cx="5836615" cy="384048"/>
+            <a:off x="1965960" y="1984248"/>
+            <a:ext cx="5836615" cy="228600"/>
           </a:xfrm>
           <a:prstGeom prst="rect">
             <a:avLst/>
@@ -9348,7 +9764,7 @@
           <a:p>
             <a:pPr algn="l"/>
             <a:r>
-              <a:rPr sz="2600" b="1" i="0" lang="th-TH" altLang="en-US">
+              <a:rPr sz="1700" b="0" i="0" lang="th-TH" altLang="en-US">
                 <a:solidFill>
                   <a:srgbClr val="24333D"/>
                 </a:solidFill>
@@ -9358,30 +9774,19 @@
               </a:rPr>
               <a:t>สวัสดีค่ะ</a:t>
             </a:r>
-            <a:r>
-              <a:rPr sz="1700" b="0" i="1" lang="en-US" altLang="en-US">
-                <a:solidFill>
-                  <a:srgbClr val="566873"/>
-                </a:solidFill>
-                <a:latin typeface="Sarabun"/>
-                <a:ea typeface="Sarabun"/>
-                <a:cs typeface="Sarabun"/>
-              </a:rPr>
-              <a:t> (sà-wàt-dii khâ)</a:t>
-            </a:r>
-          </a:p>
-        </p:txBody>
-      </p:sp>
-      <p:sp>
-        <p:nvSpPr>
-          <p:cNvPr id="11" name="TextBox 10"/>
+          </a:p>
+        </p:txBody>
+      </p:sp>
+      <p:sp>
+        <p:nvSpPr>
+          <p:cNvPr id="12" name="TextBox 11"/>
           <p:cNvSpPr txBox="1"/>
           <p:nvPr/>
         </p:nvSpPr>
         <p:spPr>
           <a:xfrm>
-            <a:off x="1965960" y="2130552"/>
-            <a:ext cx="5836615" cy="228600"/>
+            <a:off x="1965960" y="2212848"/>
+            <a:ext cx="5836615" cy="201168"/>
           </a:xfrm>
           <a:prstGeom prst="rect">
             <a:avLst/>
@@ -9396,7 +9801,7 @@
           <a:p>
             <a:pPr algn="l"/>
             <a:r>
-              <a:rPr sz="1300" b="0" i="0" lang="en-US" altLang="en-US">
+              <a:rPr sz="1700" b="0" i="1" lang="en-US" altLang="en-US">
                 <a:solidFill>
                   <a:srgbClr val="566873"/>
                 </a:solidFill>
@@ -9404,6 +9809,43 @@
                 <a:ea typeface="Sarabun"/>
                 <a:cs typeface="Sarabun"/>
               </a:rPr>
+              <a:t>sà-wàt-dii khâ</a:t>
+            </a:r>
+          </a:p>
+        </p:txBody>
+      </p:sp>
+      <p:sp>
+        <p:nvSpPr>
+          <p:cNvPr id="13" name="TextBox 12"/>
+          <p:cNvSpPr txBox="1"/>
+          <p:nvPr/>
+        </p:nvSpPr>
+        <p:spPr>
+          <a:xfrm>
+            <a:off x="1965960" y="2414016"/>
+            <a:ext cx="5836615" cy="201168"/>
+          </a:xfrm>
+          <a:prstGeom prst="rect">
+            <a:avLst/>
+          </a:prstGeom>
+          <a:noFill/>
+        </p:spPr>
+        <p:txBody>
+          <a:bodyPr wrap="square" anchor="t">
+            <a:spAutoFit/>
+          </a:bodyPr>
+          <a:lstStyle/>
+          <a:p>
+            <a:pPr algn="l"/>
+            <a:r>
+              <a:rPr sz="1700" b="0" i="0" lang="en-US" altLang="en-US">
+                <a:solidFill>
+                  <a:srgbClr val="566873"/>
+                </a:solidFill>
+                <a:latin typeface="Sarabun"/>
+                <a:ea typeface="Sarabun"/>
+                <a:cs typeface="Sarabun"/>
+              </a:rPr>
               <a:t>Hello.</a:t>
             </a:r>
           </a:p>
@@ -9411,13 +9853,13 @@
       </p:sp>
       <p:sp>
         <p:nvSpPr>
-          <p:cNvPr id="12" name="Rounded Rectangle 11"/>
+          <p:cNvPr id="14" name="Rounded Rectangle 13"/>
           <p:cNvSpPr/>
           <p:nvPr/>
         </p:nvSpPr>
         <p:spPr>
           <a:xfrm>
-            <a:off x="731520" y="2651760"/>
+            <a:off x="731520" y="2926080"/>
             <a:ext cx="1051560" cy="274320"/>
           </a:xfrm>
           <a:prstGeom prst="roundRect">
@@ -9467,14 +9909,14 @@
       </p:sp>
       <p:sp>
         <p:nvSpPr>
-          <p:cNvPr id="13" name="TextBox 12"/>
+          <p:cNvPr id="15" name="TextBox 14"/>
           <p:cNvSpPr txBox="1"/>
           <p:nvPr/>
         </p:nvSpPr>
         <p:spPr>
           <a:xfrm>
-            <a:off x="1965960" y="2624328"/>
-            <a:ext cx="5836615" cy="384048"/>
+            <a:off x="1965960" y="2898648"/>
+            <a:ext cx="8823960" cy="228600"/>
           </a:xfrm>
           <a:prstGeom prst="rect">
             <a:avLst/>
@@ -9489,7 +9931,7 @@
           <a:p>
             <a:pPr algn="l"/>
             <a:r>
-              <a:rPr sz="2600" b="1" i="0" lang="th-TH" altLang="en-US">
+              <a:rPr sz="1700" b="0" i="0" lang="th-TH" altLang="en-US">
                 <a:solidFill>
                   <a:srgbClr val="24333D"/>
                 </a:solidFill>
@@ -9499,30 +9941,19 @@
               </a:rPr>
               <a:t>นี่ใช่ไหมครับ</a:t>
             </a:r>
-            <a:r>
-              <a:rPr sz="1700" b="0" i="1" lang="en-US" altLang="en-US">
-                <a:solidFill>
-                  <a:srgbClr val="566873"/>
-                </a:solidFill>
-                <a:latin typeface="Sarabun"/>
-                <a:ea typeface="Sarabun"/>
-                <a:cs typeface="Sarabun"/>
-              </a:rPr>
-              <a:t> (nîi châi mái khráp)</a:t>
-            </a:r>
-          </a:p>
-        </p:txBody>
-      </p:sp>
-      <p:sp>
-        <p:nvSpPr>
-          <p:cNvPr id="14" name="TextBox 13"/>
+          </a:p>
+        </p:txBody>
+      </p:sp>
+      <p:sp>
+        <p:nvSpPr>
+          <p:cNvPr id="16" name="TextBox 15"/>
           <p:cNvSpPr txBox="1"/>
           <p:nvPr/>
         </p:nvSpPr>
         <p:spPr>
           <a:xfrm>
-            <a:off x="1965960" y="2907792"/>
-            <a:ext cx="5836615" cy="228600"/>
+            <a:off x="1965960" y="3127248"/>
+            <a:ext cx="8823960" cy="201168"/>
           </a:xfrm>
           <a:prstGeom prst="rect">
             <a:avLst/>
@@ -9537,7 +9968,7 @@
           <a:p>
             <a:pPr algn="l"/>
             <a:r>
-              <a:rPr sz="1300" b="0" i="0" lang="en-US" altLang="en-US">
+              <a:rPr sz="1700" b="0" i="1" lang="en-US" altLang="en-US">
                 <a:solidFill>
                   <a:srgbClr val="566873"/>
                 </a:solidFill>
@@ -9545,6 +9976,43 @@
                 <a:ea typeface="Sarabun"/>
                 <a:cs typeface="Sarabun"/>
               </a:rPr>
+              <a:t>nîi châi mái khráp</a:t>
+            </a:r>
+          </a:p>
+        </p:txBody>
+      </p:sp>
+      <p:sp>
+        <p:nvSpPr>
+          <p:cNvPr id="17" name="TextBox 16"/>
+          <p:cNvSpPr txBox="1"/>
+          <p:nvPr/>
+        </p:nvSpPr>
+        <p:spPr>
+          <a:xfrm>
+            <a:off x="1965960" y="3328416"/>
+            <a:ext cx="8823960" cy="201168"/>
+          </a:xfrm>
+          <a:prstGeom prst="rect">
+            <a:avLst/>
+          </a:prstGeom>
+          <a:noFill/>
+        </p:spPr>
+        <p:txBody>
+          <a:bodyPr wrap="square" anchor="t">
+            <a:spAutoFit/>
+          </a:bodyPr>
+          <a:lstStyle/>
+          <a:p>
+            <a:pPr algn="l"/>
+            <a:r>
+              <a:rPr sz="1700" b="0" i="0" lang="en-US" altLang="en-US">
+                <a:solidFill>
+                  <a:srgbClr val="566873"/>
+                </a:solidFill>
+                <a:latin typeface="Sarabun"/>
+                <a:ea typeface="Sarabun"/>
+                <a:cs typeface="Sarabun"/>
+              </a:rPr>
               <a:t>Is this right?</a:t>
             </a:r>
           </a:p>
@@ -9552,13 +10020,13 @@
       </p:sp>
       <p:sp>
         <p:nvSpPr>
-          <p:cNvPr id="15" name="Rounded Rectangle 14"/>
+          <p:cNvPr id="18" name="Rounded Rectangle 17"/>
           <p:cNvSpPr/>
           <p:nvPr/>
         </p:nvSpPr>
         <p:spPr>
           <a:xfrm>
-            <a:off x="731520" y="3429000"/>
+            <a:off x="731520" y="3840480"/>
             <a:ext cx="1051560" cy="274320"/>
           </a:xfrm>
           <a:prstGeom prst="roundRect">
@@ -9608,14 +10076,14 @@
       </p:sp>
       <p:sp>
         <p:nvSpPr>
-          <p:cNvPr id="16" name="TextBox 15"/>
+          <p:cNvPr id="19" name="TextBox 18"/>
           <p:cNvSpPr txBox="1"/>
           <p:nvPr/>
         </p:nvSpPr>
         <p:spPr>
           <a:xfrm>
-            <a:off x="1965960" y="3401568"/>
-            <a:ext cx="8823960" cy="384048"/>
+            <a:off x="1965960" y="3813048"/>
+            <a:ext cx="8823960" cy="228600"/>
           </a:xfrm>
           <a:prstGeom prst="rect">
             <a:avLst/>
@@ -9630,7 +10098,7 @@
           <a:p>
             <a:pPr algn="l"/>
             <a:r>
-              <a:rPr sz="2600" b="1" i="0" lang="th-TH" altLang="en-US">
+              <a:rPr sz="1700" b="0" i="0" lang="th-TH" altLang="en-US">
                 <a:solidFill>
                   <a:srgbClr val="24333D"/>
                 </a:solidFill>
@@ -9640,30 +10108,19 @@
               </a:rPr>
               <a:t>ใช่ค่ะ</a:t>
             </a:r>
-            <a:r>
-              <a:rPr sz="1700" b="0" i="1" lang="en-US" altLang="en-US">
-                <a:solidFill>
-                  <a:srgbClr val="566873"/>
-                </a:solidFill>
-                <a:latin typeface="Sarabun"/>
-                <a:ea typeface="Sarabun"/>
-                <a:cs typeface="Sarabun"/>
-              </a:rPr>
-              <a:t> (châi khâ)</a:t>
-            </a:r>
-          </a:p>
-        </p:txBody>
-      </p:sp>
-      <p:sp>
-        <p:nvSpPr>
-          <p:cNvPr id="17" name="TextBox 16"/>
+          </a:p>
+        </p:txBody>
+      </p:sp>
+      <p:sp>
+        <p:nvSpPr>
+          <p:cNvPr id="20" name="TextBox 19"/>
           <p:cNvSpPr txBox="1"/>
           <p:nvPr/>
         </p:nvSpPr>
         <p:spPr>
           <a:xfrm>
-            <a:off x="1965960" y="3685032"/>
-            <a:ext cx="8823960" cy="228600"/>
+            <a:off x="1965960" y="4041648"/>
+            <a:ext cx="8823960" cy="201168"/>
           </a:xfrm>
           <a:prstGeom prst="rect">
             <a:avLst/>
@@ -9678,7 +10135,7 @@
           <a:p>
             <a:pPr algn="l"/>
             <a:r>
-              <a:rPr sz="1300" b="0" i="0" lang="en-US" altLang="en-US">
+              <a:rPr sz="1700" b="0" i="1" lang="en-US" altLang="en-US">
                 <a:solidFill>
                   <a:srgbClr val="566873"/>
                 </a:solidFill>
@@ -9686,6 +10143,43 @@
                 <a:ea typeface="Sarabun"/>
                 <a:cs typeface="Sarabun"/>
               </a:rPr>
+              <a:t>châi khâ</a:t>
+            </a:r>
+          </a:p>
+        </p:txBody>
+      </p:sp>
+      <p:sp>
+        <p:nvSpPr>
+          <p:cNvPr id="21" name="TextBox 20"/>
+          <p:cNvSpPr txBox="1"/>
+          <p:nvPr/>
+        </p:nvSpPr>
+        <p:spPr>
+          <a:xfrm>
+            <a:off x="1965960" y="4242816"/>
+            <a:ext cx="8823960" cy="201168"/>
+          </a:xfrm>
+          <a:prstGeom prst="rect">
+            <a:avLst/>
+          </a:prstGeom>
+          <a:noFill/>
+        </p:spPr>
+        <p:txBody>
+          <a:bodyPr wrap="square" anchor="t">
+            <a:spAutoFit/>
+          </a:bodyPr>
+          <a:lstStyle/>
+          <a:p>
+            <a:pPr algn="l"/>
+            <a:r>
+              <a:rPr sz="1700" b="0" i="0" lang="en-US" altLang="en-US">
+                <a:solidFill>
+                  <a:srgbClr val="566873"/>
+                </a:solidFill>
+                <a:latin typeface="Sarabun"/>
+                <a:ea typeface="Sarabun"/>
+                <a:cs typeface="Sarabun"/>
+              </a:rPr>
               <a:t>Yes.</a:t>
             </a:r>
           </a:p>
@@ -9693,13 +10187,13 @@
       </p:sp>
       <p:sp>
         <p:nvSpPr>
-          <p:cNvPr id="18" name="Rounded Rectangle 17"/>
+          <p:cNvPr id="22" name="Rounded Rectangle 21"/>
           <p:cNvSpPr/>
           <p:nvPr/>
         </p:nvSpPr>
         <p:spPr>
           <a:xfrm>
-            <a:off x="731520" y="4206240"/>
+            <a:off x="731520" y="4754880"/>
             <a:ext cx="1051560" cy="274320"/>
           </a:xfrm>
           <a:prstGeom prst="roundRect">
@@ -9749,14 +10243,14 @@
       </p:sp>
       <p:sp>
         <p:nvSpPr>
-          <p:cNvPr id="19" name="TextBox 18"/>
+          <p:cNvPr id="23" name="TextBox 22"/>
           <p:cNvSpPr txBox="1"/>
           <p:nvPr/>
         </p:nvSpPr>
         <p:spPr>
           <a:xfrm>
-            <a:off x="1965960" y="4178808"/>
-            <a:ext cx="8823960" cy="384048"/>
+            <a:off x="1965960" y="4727448"/>
+            <a:ext cx="8823960" cy="228600"/>
           </a:xfrm>
           <a:prstGeom prst="rect">
             <a:avLst/>
@@ -9771,7 +10265,7 @@
           <a:p>
             <a:pPr algn="l"/>
             <a:r>
-              <a:rPr sz="2600" b="1" i="0" lang="th-TH" altLang="en-US">
+              <a:rPr sz="1700" b="0" i="0" lang="th-TH" altLang="en-US">
                 <a:solidFill>
                   <a:srgbClr val="24333D"/>
                 </a:solidFill>
@@ -9781,30 +10275,19 @@
               </a:rPr>
               <a:t>ขอบคุณครับ</a:t>
             </a:r>
-            <a:r>
-              <a:rPr sz="1700" b="0" i="1" lang="en-US" altLang="en-US">
-                <a:solidFill>
-                  <a:srgbClr val="566873"/>
-                </a:solidFill>
-                <a:latin typeface="Sarabun"/>
-                <a:ea typeface="Sarabun"/>
-                <a:cs typeface="Sarabun"/>
-              </a:rPr>
-              <a:t> (khàawp-khun khráp)</a:t>
-            </a:r>
-          </a:p>
-        </p:txBody>
-      </p:sp>
-      <p:sp>
-        <p:nvSpPr>
-          <p:cNvPr id="20" name="TextBox 19"/>
+          </a:p>
+        </p:txBody>
+      </p:sp>
+      <p:sp>
+        <p:nvSpPr>
+          <p:cNvPr id="24" name="TextBox 23"/>
           <p:cNvSpPr txBox="1"/>
           <p:nvPr/>
         </p:nvSpPr>
         <p:spPr>
           <a:xfrm>
-            <a:off x="1965960" y="4462272"/>
-            <a:ext cx="8823960" cy="228600"/>
+            <a:off x="1965960" y="4956048"/>
+            <a:ext cx="8823960" cy="201168"/>
           </a:xfrm>
           <a:prstGeom prst="rect">
             <a:avLst/>
@@ -9819,7 +10302,7 @@
           <a:p>
             <a:pPr algn="l"/>
             <a:r>
-              <a:rPr sz="1300" b="0" i="0" lang="en-US" altLang="en-US">
+              <a:rPr sz="1700" b="0" i="1" lang="en-US" altLang="en-US">
                 <a:solidFill>
                   <a:srgbClr val="566873"/>
                 </a:solidFill>
@@ -9827,77 +10310,21 @@
                 <a:ea typeface="Sarabun"/>
                 <a:cs typeface="Sarabun"/>
               </a:rPr>
-              <a:t>Thank you.</a:t>
-            </a:r>
-          </a:p>
-        </p:txBody>
-      </p:sp>
-      <p:sp>
-        <p:nvSpPr>
-          <p:cNvPr id="21" name="Rounded Rectangle 20"/>
-          <p:cNvSpPr/>
-          <p:nvPr/>
-        </p:nvSpPr>
-        <p:spPr>
-          <a:xfrm>
-            <a:off x="731520" y="4983480"/>
-            <a:ext cx="1051560" cy="274320"/>
-          </a:xfrm>
-          <a:prstGeom prst="roundRect">
-            <a:avLst>
-              <a:gd name="adj" fmla="val 28000"/>
-            </a:avLst>
-          </a:prstGeom>
-          <a:solidFill>
-            <a:srgbClr val="C96F4A"/>
-          </a:solidFill>
-          <a:ln>
-            <a:noFill/>
-          </a:ln>
-        </p:spPr>
-        <p:style>
-          <a:lnRef idx="1">
-            <a:schemeClr val="accent1"/>
-          </a:lnRef>
-          <a:fillRef idx="3">
-            <a:schemeClr val="accent1"/>
-          </a:fillRef>
-          <a:effectRef idx="2">
-            <a:schemeClr val="accent1"/>
-          </a:effectRef>
-          <a:fontRef idx="minor">
-            <a:schemeClr val="lt1"/>
-          </a:fontRef>
-        </p:style>
-        <p:txBody>
-          <a:bodyPr rtlCol="0" anchor="ctr" wrap="none"/>
-          <a:lstStyle/>
-          <a:p>
-            <a:pPr algn="ctr"/>
-            <a:r>
-              <a:rPr sz="1200" b="1" lang="en-US" altLang="en-US">
-                <a:solidFill>
-                  <a:srgbClr val="FFFFFF"/>
-                </a:solidFill>
-                <a:latin typeface="Sarabun"/>
-                <a:ea typeface="Sarabun"/>
-                <a:cs typeface="Sarabun"/>
-              </a:rPr>
-              <a:t>Staff</a:t>
-            </a:r>
-          </a:p>
-        </p:txBody>
-      </p:sp>
-      <p:sp>
-        <p:nvSpPr>
-          <p:cNvPr id="22" name="TextBox 21"/>
+              <a:t>khàawp-khun khráp</a:t>
+            </a:r>
+          </a:p>
+        </p:txBody>
+      </p:sp>
+      <p:sp>
+        <p:nvSpPr>
+          <p:cNvPr id="25" name="TextBox 24"/>
           <p:cNvSpPr txBox="1"/>
           <p:nvPr/>
         </p:nvSpPr>
         <p:spPr>
           <a:xfrm>
-            <a:off x="1965960" y="4956048"/>
-            <a:ext cx="8823960" cy="384048"/>
+            <a:off x="1965960" y="5157216"/>
+            <a:ext cx="8823960" cy="201168"/>
           </a:xfrm>
           <a:prstGeom prst="rect">
             <a:avLst/>
@@ -9912,18 +10339,7 @@
           <a:p>
             <a:pPr algn="l"/>
             <a:r>
-              <a:rPr sz="2600" b="1" i="0" lang="th-TH" altLang="en-US">
-                <a:solidFill>
-                  <a:srgbClr val="24333D"/>
-                </a:solidFill>
-                <a:latin typeface="Sarabun"/>
-                <a:ea typeface="Sarabun"/>
-                <a:cs typeface="Sarabun"/>
-              </a:rPr>
-              <a:t>ไม่เป็นไรค่ะ</a:t>
-            </a:r>
-            <a:r>
-              <a:rPr sz="1700" b="0" i="1" lang="en-US" altLang="en-US">
+              <a:rPr sz="1700" b="0" i="0" lang="en-US" altLang="en-US">
                 <a:solidFill>
                   <a:srgbClr val="566873"/>
                 </a:solidFill>
@@ -9931,44 +10347,7 @@
                 <a:ea typeface="Sarabun"/>
                 <a:cs typeface="Sarabun"/>
               </a:rPr>
-              <a:t> (mâi bpen rai khâ)</a:t>
-            </a:r>
-          </a:p>
-        </p:txBody>
-      </p:sp>
-      <p:sp>
-        <p:nvSpPr>
-          <p:cNvPr id="23" name="TextBox 22"/>
-          <p:cNvSpPr txBox="1"/>
-          <p:nvPr/>
-        </p:nvSpPr>
-        <p:spPr>
-          <a:xfrm>
-            <a:off x="1965960" y="5239512"/>
-            <a:ext cx="8823960" cy="228600"/>
-          </a:xfrm>
-          <a:prstGeom prst="rect">
-            <a:avLst/>
-          </a:prstGeom>
-          <a:noFill/>
-        </p:spPr>
-        <p:txBody>
-          <a:bodyPr wrap="square" anchor="t">
-            <a:spAutoFit/>
-          </a:bodyPr>
-          <a:lstStyle/>
-          <a:p>
-            <a:pPr algn="l"/>
-            <a:r>
-              <a:rPr sz="1300" b="0" i="0" lang="en-US" altLang="en-US">
-                <a:solidFill>
-                  <a:srgbClr val="566873"/>
-                </a:solidFill>
-                <a:latin typeface="Sarabun"/>
-                <a:ea typeface="Sarabun"/>
-                <a:cs typeface="Sarabun"/>
-              </a:rPr>
-              <a:t>No problem.</a:t>
+              <a:t>Thank you.</a:t>
             </a:r>
           </a:p>
         </p:txBody>

</xml_diff>